<commit_message>
Reword the xpugen slide in plain language instead of repository vocabulary
The two cards read as internal shorthand: directory names, bare interface names,
"reward hacking", "machine gate", "verdict". Each claim now says what it buys:
the four interfaces are named by what they do, swapping a chip is one layer of work,
and the two disciplines lead with what they guarantee. The fail-closed rule moves
next to the loop it belongs to, and the backend chips show coverage.
</commit_message>
<xml_diff>
--- a/slides/xpugen_operator_agent.pptx
+++ b/slides/xpugen_operator_agent.pptx
@@ -515,7 +515,7 @@
                 <a:ea typeface="Microsoft YaHei"/>
                 <a:cs typeface="Microsoft YaHei"/>
               </a:rPr>
-              <a:t>【附页 · xpugen · 约 110 秒（1:50）】</a:t>
+              <a:t>【附页 · xpugen · 约 120 秒（2:00）】</a:t>
             </a:r>
           </a:p>
           <a:p>
@@ -533,7 +533,7 @@
                 <a:ea typeface="Microsoft YaHei"/>
                 <a:cs typeface="Microsoft YaHei"/>
               </a:rPr>
-              <a:t>这一页是另一个仓库 xpugen：面向国产 GPU 的算子生成 Agent。闭环是 LLM 生成、编译、和 golden 对齐数值、测延迟，再把结构化反馈喂回去迭代。它生成的是 M100 的 SDNN4 内核，不是 CUDA；CUDA、Triton、torch 只当算法参考和基线。</a:t>
+              <a:t>这一页是另一个仓库 xpugen：给国产 GPU 写算子的 Agent。闭环是 LLM 生成、编译、和 golden 对数值、测延迟，再把结构化的反馈喂回去改下一轮，最多八轮。它生成的是 M100 的 SDNN4 内核，不是 CUDA；CUDA、Triton、torch 只当算法参考和基线。</a:t>
             </a:r>
           </a:p>
           <a:p>
@@ -551,7 +551,7 @@
                 <a:ea typeface="Microsoft YaHei"/>
                 <a:cs typeface="Microsoft YaHei"/>
               </a:rPr>
-              <a:t>评测是分级放行的：先编译，过了精度门才测性能。入口有两条：从需求出发，或者从现有实现反推规格，第 0 轮直接拿它当基线，后面在它上面改。</a:t>
+              <a:t>评测是分级放行的：先编译，过了精度这一关才测性能。入口有两条：从一句需求开始，或者从现有实现反推规格，第 0 轮直接拿它当基线，后面在它上面改。</a:t>
             </a:r>
           </a:p>
           <a:p>
@@ -569,7 +569,7 @@
                 <a:ea typeface="Microsoft YaHei"/>
                 <a:cs typeface="Microsoft YaHei"/>
               </a:rPr>
-              <a:t>架构上最重要的不变量是硬件解耦：agent 和 harness 不碰任何硬件库，只依赖四个抽象接口，backend 是唯一的耦合层。换一款芯片，只要实现这四个接口、再填一张硬件卡片，循环本身零改动。现在有三个后端：mock 在 CPU 上用纯 PyTorch 跑通全闭环，m100 是真机，p800 还是占位。</a:t>
+              <a:t>架构上最重要的一条是硬件解耦：生成和评测这套流程完全不碰硬件，只认四个接口——编译、运行、采性能、算理论上限。换一款芯片，只要照这四个接口写一个后端、再填一张硬件说明卡，主流程一行不改。现在没有硬件也能在 CPU 上跑通整条闭环，M100 真机已经接上，P800 还没接。</a:t>
             </a:r>
           </a:p>
           <a:p>
@@ -587,7 +587,7 @@
                 <a:ea typeface="Microsoft YaHei"/>
                 <a:cs typeface="Microsoft YaHei"/>
               </a:rPr>
-              <a:t>两条纪律是防止自己骗自己：精度参考只用 CPU 实现，精度门永远先于性能门；机制看模拟器，收益必须在真机的生产 shape 上测，不一致以真机为准。</a:t>
+              <a:t>两条纪律是防止自己骗自己：精度参考只用 CPU 实现，绝不拿 CUDA 当标准，精度不过关就不看性能；模拟器只用来看清改动动了哪一块，收益一律以真机、生产形状的实测为准，两边对不上听真机的。</a:t>
             </a:r>
           </a:p>
           <a:p>
@@ -605,7 +605,7 @@
                 <a:ea typeface="Microsoft YaHei"/>
                 <a:cs typeface="Microsoft YaHei"/>
               </a:rPr>
-              <a:t>这些规矩都是机器门强制的，不靠人肉 review：每轮的 before、after、判词写不进去，这一轮就算失败。</a:t>
+              <a:t>这些规矩不是靠人盯，是写死在流程里的：每轮改了什么、前后数据、结论，写不进去这一轮就算失败。</a:t>
             </a:r>
           </a:p>
         </p:txBody>
@@ -3849,7 +3849,7 @@
                 <a:ea typeface="Microsoft YaHei"/>
                 <a:cs typeface="Microsoft YaHei"/>
               </a:rPr>
-              <a:t>LLM 按硬件卡片写内核</a:t>
+              <a:t>LLM 照硬件说明卡写内核</a:t>
             </a:r>
           </a:p>
         </p:txBody>
@@ -3951,7 +3951,7 @@
                 <a:ea typeface="Microsoft YaHei"/>
                 <a:cs typeface="Microsoft YaHei"/>
               </a:rPr>
-              <a:t>编译 + 起 app 冒烟</a:t>
+              <a:t>编译并拉起程序</a:t>
             </a:r>
           </a:p>
         </p:txBody>
@@ -4075,7 +4075,7 @@
                 <a:ea typeface="Microsoft YaHei"/>
                 <a:cs typeface="Microsoft YaHei"/>
               </a:rPr>
-              <a:t>多 shape × dtype 对数值</a:t>
+              <a:t>多种形状、精度逐一对数值</a:t>
             </a:r>
           </a:p>
         </p:txBody>
@@ -4199,7 +4199,7 @@
                 <a:ea typeface="Microsoft YaHei"/>
                 <a:cs typeface="Microsoft YaHei"/>
               </a:rPr>
-              <a:t>中位延迟 + roofline 上界</a:t>
+              <a:t>取中位延迟，比理论上限</a:t>
             </a:r>
           </a:p>
         </p:txBody>
@@ -4323,7 +4323,7 @@
                 <a:ea typeface="Microsoft YaHei"/>
                 <a:cs typeface="Microsoft YaHei"/>
               </a:rPr>
-              <a:t>reward 打分 + 机制证据</a:t>
+              <a:t>打分，并指出慢在哪</a:t>
             </a:r>
           </a:p>
         </p:txBody>
@@ -4409,7 +4409,7 @@
         <p:spPr>
           <a:xfrm>
             <a:off x="1734891" y="3374136"/>
-            <a:ext cx="4754880" cy="274320"/>
+            <a:ext cx="4114800" cy="274320"/>
           </a:xfrm>
           <a:prstGeom prst="rect">
             <a:avLst/>
@@ -4442,7 +4442,7 @@
                 <a:ea typeface="Microsoft YaHei"/>
                 <a:cs typeface="Microsoft YaHei"/>
               </a:rPr>
-              <a:t>每轮落盘 before / after / 判词；最多 8 轮</a:t>
+              <a:t>每轮改了什么、前后数据、结论都要落盘，写不进去这轮就算失败</a:t>
             </a:r>
           </a:p>
         </p:txBody>
@@ -4489,7 +4489,7 @@
                 <a:ea typeface="Microsoft YaHei"/>
                 <a:cs typeface="Microsoft YaHei"/>
               </a:rPr>
-              <a:t>入口：从需求出发，或从现有实现反推规格、第 0 轮当基线</a:t>
+              <a:t>入口：从一句需求开始，或从现有实现反推规格、第 0 轮当基线</a:t>
             </a:r>
           </a:p>
         </p:txBody>
@@ -4565,7 +4565,7 @@
                 <a:ea typeface="Microsoft YaHei"/>
                 <a:cs typeface="Microsoft YaHei"/>
               </a:rPr>
-              <a:t>硬件解耦 · 唯一的架构不变量</a:t>
+              <a:t>硬件解耦 · 换一款芯片只动一层</a:t>
             </a:r>
           </a:p>
         </p:txBody>
@@ -4600,7 +4600,7 @@
                 <a:spcPts val="0"/>
               </a:spcBef>
               <a:spcAft>
-                <a:spcPts val="400"/>
+                <a:spcPts val="200"/>
               </a:spcAft>
               <a:buClr>
                 <a:srgbClr val="C0612C"/>
@@ -4617,7 +4617,31 @@
                 <a:ea typeface="Microsoft YaHei"/>
                 <a:cs typeface="Microsoft YaHei"/>
               </a:rPr>
-              <a:t>agent / harness 硬件无关，不 import 任何硬件库</a:t>
+              <a:t>生成和评测完全不碰硬件，只认四个接口</a:t>
+            </a:r>
+          </a:p>
+          <a:p>
+            <a:pPr algn="l" latinLnBrk="0">
+              <a:lnSpc>
+                <a:spcPct val="100000"/>
+              </a:lnSpc>
+              <a:spcBef>
+                <a:spcPts val="0"/>
+              </a:spcBef>
+              <a:spcAft>
+                <a:spcPts val="500"/>
+              </a:spcAft>
+            </a:pPr>
+            <a:r>
+              <a:rPr sz="1050" b="0">
+                <a:solidFill>
+                  <a:srgbClr val="66727F"/>
+                </a:solidFill>
+                <a:latin typeface="Microsoft YaHei"/>
+                <a:ea typeface="Microsoft YaHei"/>
+                <a:cs typeface="Microsoft YaHei"/>
+              </a:rPr>
+              <a:t>　编译、运行、采性能、算理论上限（roofline）</a:t>
             </a:r>
           </a:p>
           <a:p>
@@ -4629,7 +4653,7 @@
                 <a:spcPts val="0"/>
               </a:spcBef>
               <a:spcAft>
-                <a:spcPts val="400"/>
+                <a:spcPts val="0"/>
               </a:spcAft>
               <a:buClr>
                 <a:srgbClr val="C0612C"/>
@@ -4646,36 +4670,7 @@
                 <a:ea typeface="Microsoft YaHei"/>
                 <a:cs typeface="Microsoft YaHei"/>
               </a:rPr>
-              <a:t>只依赖四个抽象接口：Compiler、Runtime、Profiler、Roofline</a:t>
-            </a:r>
-          </a:p>
-          <a:p>
-            <a:pPr algn="l" latinLnBrk="0" marL="146304" indent="-146304">
-              <a:lnSpc>
-                <a:spcPct val="100000"/>
-              </a:lnSpc>
-              <a:spcBef>
-                <a:spcPts val="0"/>
-              </a:spcBef>
-              <a:spcAft>
-                <a:spcPts val="400"/>
-              </a:spcAft>
-              <a:buClr>
-                <a:srgbClr val="C0612C"/>
-              </a:buClr>
-              <a:buFont typeface="Arial"/>
-              <a:buChar char="•"/>
-            </a:pPr>
-            <a:r>
-              <a:rPr sz="1100" b="0">
-                <a:solidFill>
-                  <a:srgbClr val="35424F"/>
-                </a:solidFill>
-                <a:latin typeface="Microsoft YaHei"/>
-                <a:ea typeface="Microsoft YaHei"/>
-                <a:cs typeface="Microsoft YaHei"/>
-              </a:rPr>
-              <a:t>backend/ 是唯一耦合层，换一款芯片循环零改动</a:t>
+              <a:t>换芯片 = 照这四个接口写一个后端 + 填一张硬件说明卡</a:t>
             </a:r>
           </a:p>
         </p:txBody>
@@ -4784,7 +4779,7 @@
                 <a:ea typeface="Microsoft YaHei"/>
                 <a:cs typeface="Microsoft YaHei"/>
               </a:rPr>
-              <a:t>mock：无硬件也能跑通闭环</a:t>
+              <a:t>没有硬件也能跑通整条闭环</a:t>
             </a:r>
           </a:p>
         </p:txBody>
@@ -4798,7 +4793,7 @@
         <p:spPr>
           <a:xfrm>
             <a:off x="3182112" y="5047488"/>
-            <a:ext cx="1737360" cy="274320"/>
+            <a:ext cx="1417320" cy="274320"/>
           </a:xfrm>
           <a:prstGeom prst="roundRect">
             <a:avLst>
@@ -4860,7 +4855,7 @@
         <p:spPr>
           <a:xfrm>
             <a:off x="3456432" y="5047488"/>
-            <a:ext cx="1444751" cy="274320"/>
+            <a:ext cx="1124712" cy="274320"/>
           </a:xfrm>
           <a:prstGeom prst="rect">
             <a:avLst/>
@@ -4893,14 +4888,123 @@
                 <a:ea typeface="Microsoft YaHei"/>
                 <a:cs typeface="Microsoft YaHei"/>
               </a:rPr>
-              <a:t>m100：真机 SDNN4</a:t>
-            </a:r>
-          </a:p>
-        </p:txBody>
-      </p:sp>
-      <p:sp>
-        <p:nvSpPr>
-          <p:cNvPr id="26" name="Rectangle 25"/>
+              <a:t>M100 真机已接</a:t>
+            </a:r>
+          </a:p>
+        </p:txBody>
+      </p:sp>
+      <p:sp>
+        <p:nvSpPr>
+          <p:cNvPr id="26" name="Rounded Rectangle 25"/>
+          <p:cNvSpPr/>
+          <p:nvPr/>
+        </p:nvSpPr>
+        <p:spPr>
+          <a:xfrm>
+            <a:off x="4709160" y="5047488"/>
+            <a:ext cx="1097280" cy="274320"/>
+          </a:xfrm>
+          <a:prstGeom prst="roundRect">
+            <a:avLst>
+              <a:gd name="adj" fmla="val 50000"/>
+            </a:avLst>
+          </a:prstGeom>
+          <a:solidFill>
+            <a:srgbClr val="F6F7F9"/>
+          </a:solidFill>
+          <a:ln w="9525">
+            <a:solidFill>
+              <a:srgbClr val="DDE2E7"/>
+            </a:solidFill>
+          </a:ln>
+        </p:spPr>
+        <p:txBody>
+          <a:bodyPr rtlCol="0" anchor="ctr"/>
+          <a:lstStyle/>
+          <a:p>
+            <a:pPr algn="ctr"/>
+          </a:p>
+        </p:txBody>
+      </p:sp>
+      <p:sp>
+        <p:nvSpPr>
+          <p:cNvPr id="27" name="Oval 26"/>
+          <p:cNvSpPr/>
+          <p:nvPr/>
+        </p:nvSpPr>
+        <p:spPr>
+          <a:xfrm>
+            <a:off x="4809744" y="5129783"/>
+            <a:ext cx="109728" cy="109728"/>
+          </a:xfrm>
+          <a:prstGeom prst="ellipse">
+            <a:avLst/>
+          </a:prstGeom>
+          <a:solidFill>
+            <a:srgbClr val="8C96A1"/>
+          </a:solidFill>
+          <a:ln>
+            <a:noFill/>
+          </a:ln>
+        </p:spPr>
+        <p:txBody>
+          <a:bodyPr rtlCol="0" anchor="ctr"/>
+          <a:lstStyle/>
+          <a:p>
+            <a:pPr algn="ctr"/>
+          </a:p>
+        </p:txBody>
+      </p:sp>
+      <p:sp>
+        <p:nvSpPr>
+          <p:cNvPr id="28" name="TextBox 27"/>
+          <p:cNvSpPr txBox="1"/>
+          <p:nvPr/>
+        </p:nvSpPr>
+        <p:spPr>
+          <a:xfrm>
+            <a:off x="4983480" y="5047488"/>
+            <a:ext cx="804671" cy="274320"/>
+          </a:xfrm>
+          <a:prstGeom prst="rect">
+            <a:avLst/>
+          </a:prstGeom>
+          <a:noFill/>
+        </p:spPr>
+        <p:txBody>
+          <a:bodyPr wrap="square" anchor="ctr" lIns="0" tIns="0" rIns="0" bIns="0">
+            <a:noAutofit/>
+          </a:bodyPr>
+          <a:lstStyle/>
+          <a:p>
+            <a:pPr algn="l" latinLnBrk="0">
+              <a:lnSpc>
+                <a:spcPct val="100000"/>
+              </a:lnSpc>
+              <a:spcBef>
+                <a:spcPts val="0"/>
+              </a:spcBef>
+              <a:spcAft>
+                <a:spcPts val="0"/>
+              </a:spcAft>
+            </a:pPr>
+            <a:r>
+              <a:rPr sz="1050" b="0">
+                <a:solidFill>
+                  <a:srgbClr val="35424F"/>
+                </a:solidFill>
+                <a:latin typeface="Microsoft YaHei"/>
+                <a:ea typeface="Microsoft YaHei"/>
+                <a:cs typeface="Microsoft YaHei"/>
+              </a:rPr>
+              <a:t>P800 待接</a:t>
+            </a:r>
+          </a:p>
+        </p:txBody>
+      </p:sp>
+      <p:sp>
+        <p:nvSpPr>
+          <p:cNvPr id="29" name="Rectangle 28"/>
           <p:cNvSpPr/>
           <p:nvPr/>
         </p:nvSpPr>
@@ -4931,7 +5035,7 @@
       </p:sp>
       <p:sp>
         <p:nvSpPr>
-          <p:cNvPr id="27" name="TextBox 26"/>
+          <p:cNvPr id="30" name="TextBox 29"/>
           <p:cNvSpPr txBox="1"/>
           <p:nvPr/>
         </p:nvSpPr>
@@ -4971,10 +5075,10 @@
                 <a:ea typeface="Microsoft YaHei"/>
                 <a:cs typeface="Microsoft YaHei"/>
               </a:rPr>
-              <a:t>两条关键纪律</a:t>
-            </a:r>
-            <a:r>
-              <a:rPr sz="1050" b="0">
+              <a:t>两条纪律</a:t>
+            </a:r>
+            <a:r>
+              <a:rPr sz="1200" b="1">
                 <a:solidFill>
                   <a:srgbClr val="66727F"/>
                 </a:solidFill>
@@ -4982,20 +5086,20 @@
                 <a:ea typeface="Microsoft YaHei"/>
                 <a:cs typeface="Microsoft YaHei"/>
               </a:rPr>
-              <a:t>　防 reward hacking</a:t>
-            </a:r>
-          </a:p>
-        </p:txBody>
-      </p:sp>
-      <p:sp>
-        <p:nvSpPr>
-          <p:cNvPr id="28" name="Oval 27"/>
+              <a:t>　怎么保证收益是真的</a:t>
+            </a:r>
+          </a:p>
+        </p:txBody>
+      </p:sp>
+      <p:sp>
+        <p:nvSpPr>
+          <p:cNvPr id="31" name="Oval 30"/>
           <p:cNvSpPr/>
           <p:nvPr/>
         </p:nvSpPr>
         <p:spPr>
           <a:xfrm>
-            <a:off x="6470751" y="4315967"/>
+            <a:off x="6470751" y="4334255"/>
             <a:ext cx="256032" cy="256032"/>
           </a:xfrm>
           <a:prstGeom prst="ellipse">
@@ -5041,14 +5145,14 @@
       </p:sp>
       <p:sp>
         <p:nvSpPr>
-          <p:cNvPr id="29" name="TextBox 28"/>
+          <p:cNvPr id="32" name="TextBox 31"/>
           <p:cNvSpPr txBox="1"/>
           <p:nvPr/>
         </p:nvSpPr>
         <p:spPr>
           <a:xfrm>
             <a:off x="6818223" y="4297679"/>
-            <a:ext cx="4587087" cy="292608"/>
+            <a:ext cx="4587087" cy="420624"/>
           </a:xfrm>
           <a:prstGeom prst="rect">
             <a:avLst/>
@@ -5060,6 +5164,30 @@
             <a:noAutofit/>
           </a:bodyPr>
           <a:lstStyle/>
+          <a:p>
+            <a:pPr algn="l" latinLnBrk="0">
+              <a:lnSpc>
+                <a:spcPct val="100000"/>
+              </a:lnSpc>
+              <a:spcBef>
+                <a:spcPts val="0"/>
+              </a:spcBef>
+              <a:spcAft>
+                <a:spcPts val="200"/>
+              </a:spcAft>
+            </a:pPr>
+            <a:r>
+              <a:rPr sz="1150" b="1">
+                <a:solidFill>
+                  <a:srgbClr val="16202A"/>
+                </a:solidFill>
+                <a:latin typeface="Microsoft YaHei"/>
+                <a:ea typeface="Microsoft YaHei"/>
+                <a:cs typeface="Microsoft YaHei"/>
+              </a:rPr>
+              <a:t>精度只认 CPU 参考实现</a:t>
+            </a:r>
+          </a:p>
           <a:p>
             <a:pPr algn="l" latinLnBrk="0">
               <a:lnSpc>
@@ -5073,7 +5201,7 @@
               </a:spcAft>
             </a:pPr>
             <a:r>
-              <a:rPr sz="1100" b="0">
+              <a:rPr sz="1050" b="0">
                 <a:solidFill>
                   <a:srgbClr val="35424F"/>
                 </a:solidFill>
@@ -5081,20 +5209,20 @@
                 <a:ea typeface="Microsoft YaHei"/>
                 <a:cs typeface="Microsoft YaHei"/>
               </a:rPr>
-              <a:t>精度参考只用 CPU 实现，精度门永远先于性能门</a:t>
-            </a:r>
-          </a:p>
-        </p:txBody>
-      </p:sp>
-      <p:sp>
-        <p:nvSpPr>
-          <p:cNvPr id="30" name="Oval 29"/>
+              <a:t>绝不拿 CUDA 当标准；精度不过关，就不看性能</a:t>
+            </a:r>
+          </a:p>
+        </p:txBody>
+      </p:sp>
+      <p:sp>
+        <p:nvSpPr>
+          <p:cNvPr id="33" name="Oval 32"/>
           <p:cNvSpPr/>
           <p:nvPr/>
         </p:nvSpPr>
         <p:spPr>
           <a:xfrm>
-            <a:off x="6470751" y="4663439"/>
+            <a:off x="6470751" y="4809743"/>
             <a:ext cx="256032" cy="256032"/>
           </a:xfrm>
           <a:prstGeom prst="ellipse">
@@ -5140,14 +5268,14 @@
       </p:sp>
       <p:sp>
         <p:nvSpPr>
-          <p:cNvPr id="31" name="TextBox 30"/>
+          <p:cNvPr id="34" name="TextBox 33"/>
           <p:cNvSpPr txBox="1"/>
           <p:nvPr/>
         </p:nvSpPr>
         <p:spPr>
           <a:xfrm>
-            <a:off x="6818223" y="4645151"/>
-            <a:ext cx="4587087" cy="292608"/>
+            <a:off x="6818223" y="4773167"/>
+            <a:ext cx="4587087" cy="420624"/>
           </a:xfrm>
           <a:prstGeom prst="rect">
             <a:avLst/>
@@ -5159,6 +5287,30 @@
             <a:noAutofit/>
           </a:bodyPr>
           <a:lstStyle/>
+          <a:p>
+            <a:pPr algn="l" latinLnBrk="0">
+              <a:lnSpc>
+                <a:spcPct val="100000"/>
+              </a:lnSpc>
+              <a:spcBef>
+                <a:spcPts val="0"/>
+              </a:spcBef>
+              <a:spcAft>
+                <a:spcPts val="200"/>
+              </a:spcAft>
+            </a:pPr>
+            <a:r>
+              <a:rPr sz="1150" b="1">
+                <a:solidFill>
+                  <a:srgbClr val="16202A"/>
+                </a:solidFill>
+                <a:latin typeface="Microsoft YaHei"/>
+                <a:ea typeface="Microsoft YaHei"/>
+                <a:cs typeface="Microsoft YaHei"/>
+              </a:rPr>
+              <a:t>收益只认真机实测</a:t>
+            </a:r>
+          </a:p>
           <a:p>
             <a:pPr algn="l" latinLnBrk="0">
               <a:lnSpc>
@@ -5172,7 +5324,7 @@
               </a:spcAft>
             </a:pPr>
             <a:r>
-              <a:rPr sz="1100" b="0">
+              <a:rPr sz="1050" b="0">
                 <a:solidFill>
                   <a:srgbClr val="35424F"/>
                 </a:solidFill>
@@ -5180,21 +5332,50 @@
                 <a:ea typeface="Microsoft YaHei"/>
                 <a:cs typeface="Microsoft YaHei"/>
               </a:rPr>
-              <a:t>机制看模拟器，收益在真机生产 shape 上测，不一致以真机为准</a:t>
-            </a:r>
-          </a:p>
-        </p:txBody>
-      </p:sp>
-      <p:sp>
-        <p:nvSpPr>
-          <p:cNvPr id="32" name="TextBox 31"/>
+              <a:t>模拟器只用来看清改动动了哪一块，两边对不上听真机的</a:t>
+            </a:r>
+          </a:p>
+        </p:txBody>
+      </p:sp>
+      <p:sp>
+        <p:nvSpPr>
+          <p:cNvPr id="35" name="Rectangle 34"/>
+          <p:cNvSpPr/>
+          <p:nvPr/>
+        </p:nvSpPr>
+        <p:spPr>
+          <a:xfrm>
+            <a:off x="548640" y="5596128"/>
+            <a:ext cx="11094415" cy="603504"/>
+          </a:xfrm>
+          <a:prstGeom prst="rect">
+            <a:avLst/>
+          </a:prstGeom>
+          <a:solidFill>
+            <a:srgbClr val="16202A"/>
+          </a:solidFill>
+          <a:ln>
+            <a:noFill/>
+          </a:ln>
+        </p:spPr>
+        <p:txBody>
+          <a:bodyPr rtlCol="0" anchor="ctr"/>
+          <a:lstStyle/>
+          <a:p>
+            <a:pPr algn="ctr"/>
+          </a:p>
+        </p:txBody>
+      </p:sp>
+      <p:sp>
+        <p:nvSpPr>
+          <p:cNvPr id="36" name="TextBox 35"/>
           <p:cNvSpPr txBox="1"/>
           <p:nvPr/>
         </p:nvSpPr>
         <p:spPr>
           <a:xfrm>
-            <a:off x="6470751" y="5029199"/>
-            <a:ext cx="4934559" cy="274320"/>
+            <a:off x="822959" y="5596128"/>
+            <a:ext cx="10545775" cy="603504"/>
           </a:xfrm>
           <a:prstGeom prst="rect">
             <a:avLst/>
@@ -5219,58 +5400,51 @@
               </a:spcAft>
             </a:pPr>
             <a:r>
-              <a:rPr sz="1050" b="0">
-                <a:solidFill>
-                  <a:srgbClr val="66727F"/>
+              <a:rPr sz="1300" b="1">
+                <a:solidFill>
+                  <a:srgbClr val="FFFFFF"/>
                 </a:solidFill>
                 <a:latin typeface="Microsoft YaHei"/>
                 <a:ea typeface="Microsoft YaHei"/>
                 <a:cs typeface="Microsoft YaHei"/>
               </a:rPr>
-              <a:t>两条都由机器门强制：每轮 before / after / 判词写不进去，这一轮就算失败</a:t>
-            </a:r>
-          </a:p>
-        </p:txBody>
-      </p:sp>
-      <p:sp>
-        <p:nvSpPr>
-          <p:cNvPr id="33" name="Rectangle 32"/>
-          <p:cNvSpPr/>
-          <p:nvPr/>
-        </p:nvSpPr>
-        <p:spPr>
-          <a:xfrm>
-            <a:off x="548640" y="5596128"/>
-            <a:ext cx="11094415" cy="603504"/>
-          </a:xfrm>
-          <a:prstGeom prst="rect">
-            <a:avLst/>
-          </a:prstGeom>
-          <a:solidFill>
-            <a:srgbClr val="16202A"/>
-          </a:solidFill>
-          <a:ln>
-            <a:noFill/>
-          </a:ln>
-        </p:spPr>
-        <p:txBody>
-          <a:bodyPr rtlCol="0" anchor="ctr"/>
-          <a:lstStyle/>
-          <a:p>
-            <a:pPr algn="ctr"/>
-          </a:p>
-        </p:txBody>
-      </p:sp>
-      <p:sp>
-        <p:nvSpPr>
-          <p:cNvPr id="34" name="TextBox 33"/>
+              <a:t>对外接口　</a:t>
+            </a:r>
+            <a:r>
+              <a:rPr sz="1300" b="1">
+                <a:solidFill>
+                  <a:srgbClr val="F2B233"/>
+                </a:solidFill>
+                <a:latin typeface="Microsoft YaHei"/>
+                <a:ea typeface="Microsoft YaHei"/>
+                <a:cs typeface="Microsoft YaHei"/>
+              </a:rPr>
+              <a:t>operator-channel 透传通道</a:t>
+            </a:r>
+            <a:r>
+              <a:rPr sz="1300" b="1">
+                <a:solidFill>
+                  <a:srgbClr val="FFFFFF"/>
+                </a:solidFill>
+                <a:latin typeface="Microsoft YaHei"/>
+                <a:ea typeface="Microsoft YaHei"/>
+                <a:cs typeface="Microsoft YaHei"/>
+              </a:rPr>
+              <a:t>　m100-model-agent 管整模型接入与调优，xpugen 管单算子生成</a:t>
+            </a:r>
+          </a:p>
+        </p:txBody>
+      </p:sp>
+      <p:sp>
+        <p:nvSpPr>
+          <p:cNvPr id="37" name="TextBox 36"/>
           <p:cNvSpPr txBox="1"/>
           <p:nvPr/>
         </p:nvSpPr>
         <p:spPr>
           <a:xfrm>
-            <a:off x="822959" y="5596128"/>
-            <a:ext cx="10545775" cy="603504"/>
+            <a:off x="548640" y="6382512"/>
+            <a:ext cx="9905695" cy="256032"/>
           </a:xfrm>
           <a:prstGeom prst="rect">
             <a:avLst/>
@@ -5295,75 +5469,6 @@
               </a:spcAft>
             </a:pPr>
             <a:r>
-              <a:rPr sz="1300" b="1">
-                <a:solidFill>
-                  <a:srgbClr val="FFFFFF"/>
-                </a:solidFill>
-                <a:latin typeface="Microsoft YaHei"/>
-                <a:ea typeface="Microsoft YaHei"/>
-                <a:cs typeface="Microsoft YaHei"/>
-              </a:rPr>
-              <a:t>对外接口　</a:t>
-            </a:r>
-            <a:r>
-              <a:rPr sz="1300" b="1">
-                <a:solidFill>
-                  <a:srgbClr val="F2B233"/>
-                </a:solidFill>
-                <a:latin typeface="Microsoft YaHei"/>
-                <a:ea typeface="Microsoft YaHei"/>
-                <a:cs typeface="Microsoft YaHei"/>
-              </a:rPr>
-              <a:t>operator-channel 透传通道</a:t>
-            </a:r>
-            <a:r>
-              <a:rPr sz="1300" b="1">
-                <a:solidFill>
-                  <a:srgbClr val="FFFFFF"/>
-                </a:solidFill>
-                <a:latin typeface="Microsoft YaHei"/>
-                <a:ea typeface="Microsoft YaHei"/>
-                <a:cs typeface="Microsoft YaHei"/>
-              </a:rPr>
-              <a:t>　m100-model-agent 管整模型接入与调优，xpugen 管单算子生成</a:t>
-            </a:r>
-          </a:p>
-        </p:txBody>
-      </p:sp>
-      <p:sp>
-        <p:nvSpPr>
-          <p:cNvPr id="35" name="TextBox 34"/>
-          <p:cNvSpPr txBox="1"/>
-          <p:nvPr/>
-        </p:nvSpPr>
-        <p:spPr>
-          <a:xfrm>
-            <a:off x="548640" y="6382512"/>
-            <a:ext cx="9905695" cy="256032"/>
-          </a:xfrm>
-          <a:prstGeom prst="rect">
-            <a:avLst/>
-          </a:prstGeom>
-          <a:noFill/>
-        </p:spPr>
-        <p:txBody>
-          <a:bodyPr wrap="square" anchor="ctr" lIns="0" tIns="0" rIns="0" bIns="0">
-            <a:noAutofit/>
-          </a:bodyPr>
-          <a:lstStyle/>
-          <a:p>
-            <a:pPr algn="l" latinLnBrk="0">
-              <a:lnSpc>
-                <a:spcPct val="100000"/>
-              </a:lnSpc>
-              <a:spcBef>
-                <a:spcPts val="0"/>
-              </a:spcBef>
-              <a:spcAft>
-                <a:spcPts val="0"/>
-              </a:spcAft>
-            </a:pPr>
-            <a:r>
               <a:rPr sz="1000" b="0">
                 <a:solidFill>
                   <a:srgbClr val="66727F"/>
@@ -5379,7 +5484,7 @@
       </p:sp>
       <p:sp>
         <p:nvSpPr>
-          <p:cNvPr id="36" name="TextBox 35"/>
+          <p:cNvPr id="38" name="TextBox 37"/>
           <p:cNvSpPr txBox="1"/>
           <p:nvPr/>
         </p:nvSpPr>

</xml_diff>

<commit_message>
Rebuild the xpugen slide around how it works and what it achieves
The page now answers two questions and nothing else: the left column walks the five
steps of one iteration, the right panel is a blank result area to fill in once the
numbers are measured. Splitting left/right matches the loop pages of this deck.
Dropped the detail cards, the level tags and the channel bar; the architecture and
discipline points moved into the speaker notes as answers to hold in reserve.
</commit_message>
<xml_diff>
--- a/slides/xpugen_operator_agent.pptx
+++ b/slides/xpugen_operator_agent.pptx
@@ -515,7 +515,7 @@
                 <a:ea typeface="Microsoft YaHei"/>
                 <a:cs typeface="Microsoft YaHei"/>
               </a:rPr>
-              <a:t>【附页 · xpugen · 约 120 秒（2:00）】</a:t>
+              <a:t>【附页 · xpugen · 约 70 秒（1:10）】</a:t>
             </a:r>
           </a:p>
           <a:p>
@@ -533,7 +533,7 @@
                 <a:ea typeface="Microsoft YaHei"/>
                 <a:cs typeface="Microsoft YaHei"/>
               </a:rPr>
-              <a:t>这一页是另一个仓库 xpugen：给国产 GPU 写算子的 Agent。闭环是 LLM 生成、编译、和 golden 对数值、测延迟，再把结构化的反馈喂回去改下一轮，最多八轮。它生成的是 M100 的 SDNN4 内核，不是 CUDA；CUDA、Triton、torch 只当算法参考和基线。</a:t>
+              <a:t>这一页是另一个仓库 xpugen：给国产 GPU 写算子的 Agent。它生成的是 M100 的 SDNN4 内核，不是 CUDA；CUDA、Triton、torch 只当算法参考和基线。</a:t>
             </a:r>
           </a:p>
           <a:p>
@@ -551,7 +551,7 @@
                 <a:ea typeface="Microsoft YaHei"/>
                 <a:cs typeface="Microsoft YaHei"/>
               </a:rPr>
-              <a:t>评测是分级放行的：先编译，过了精度这一关才测性能。入口有两条：从一句需求开始，或者从现有实现反推规格，第 0 轮直接拿它当基线，后面在它上面改。</a:t>
+              <a:t>左边是它怎么工作的。入口有两条：从一句需求开始，或者从现有实现反推出规格，第 0 轮直接拿现有实现当基线，后面在它上面改。</a:t>
             </a:r>
           </a:p>
           <a:p>
@@ -569,7 +569,7 @@
                 <a:ea typeface="Microsoft YaHei"/>
                 <a:cs typeface="Microsoft YaHei"/>
               </a:rPr>
-              <a:t>架构上最重要的一条是硬件解耦：生成和评测这套流程完全不碰硬件，只认四个接口——编译、运行、采性能、算理论上限。换一款芯片，只要照这四个接口写一个后端、再填一张硬件说明卡，主流程一行不改。现在没有硬件也能在 CPU 上跑通整条闭环，M100 真机已经接上，P800 还没接。</a:t>
+              <a:t>然后就是一轮轮迭代：LLM 照硬件说明卡写内核，编译跑起来，多种形状和精度逐一和 golden 对数值，再测延迟、跟理论上限比，最后把打分和慢在哪带进下一轮。最多八轮。</a:t>
             </a:r>
           </a:p>
           <a:p>
@@ -587,7 +587,7 @@
                 <a:ea typeface="Microsoft YaHei"/>
                 <a:cs typeface="Microsoft YaHei"/>
               </a:rPr>
-              <a:t>两条纪律是防止自己骗自己：精度参考只用 CPU 实现，绝不拿 CUDA 当标准，精度不过关就不看性能；模拟器只用来看清改动动了哪一块，收益一律以真机、生产形状的实测为准，两边对不上听真机的。</a:t>
+              <a:t>右边是效果。（按实测数字讲：已经有多少个算子达标、平均几轮、相对原来的实现快多少、离理论上限还差多少。口径都是真机、生产形状上的实测。）</a:t>
             </a:r>
           </a:p>
           <a:p>
@@ -597,15 +597,51 @@
               </a:spcAft>
             </a:pPr>
             <a:r>
-              <a:rPr sz="1200" b="0">
-                <a:solidFill>
-                  <a:srgbClr val="16202A"/>
+              <a:rPr sz="1200" b="1">
+                <a:solidFill>
+                  <a:srgbClr val="66727F"/>
                 </a:solidFill>
                 <a:latin typeface="Microsoft YaHei"/>
                 <a:ea typeface="Microsoft YaHei"/>
                 <a:cs typeface="Microsoft YaHei"/>
               </a:rPr>
-              <a:t>这些规矩不是靠人盯，是写死在流程里的：每轮改了什么、前后数据、结论，写不进去这一轮就算失败。</a:t>
+              <a:t>被问到再说 ——</a:t>
+            </a:r>
+          </a:p>
+          <a:p>
+            <a:pPr>
+              <a:spcAft>
+                <a:spcPts val="600"/>
+              </a:spcAft>
+            </a:pPr>
+            <a:r>
+              <a:rPr sz="1200" b="0">
+                <a:solidFill>
+                  <a:srgbClr val="66727F"/>
+                </a:solidFill>
+                <a:latin typeface="Microsoft YaHei"/>
+                <a:ea typeface="Microsoft YaHei"/>
+                <a:cs typeface="Microsoft YaHei"/>
+              </a:rPr>
+              <a:t>换芯片要改什么：生成和评测这套流程完全不碰硬件，只认四个接口——编译、运行、采性能、算理论上限。每款芯片照这四个接口写一个后端、再填一张硬件说明卡，主流程一行不改。现在没有硬件也能在 CPU 上跑通整条闭环，M100 真机已接，P800 还没接。</a:t>
+            </a:r>
+          </a:p>
+          <a:p>
+            <a:pPr>
+              <a:spcAft>
+                <a:spcPts val="600"/>
+              </a:spcAft>
+            </a:pPr>
+            <a:r>
+              <a:rPr sz="1200" b="0">
+                <a:solidFill>
+                  <a:srgbClr val="66727F"/>
+                </a:solidFill>
+                <a:latin typeface="Microsoft YaHei"/>
+                <a:ea typeface="Microsoft YaHei"/>
+                <a:cs typeface="Microsoft YaHei"/>
+              </a:rPr>
+              <a:t>数字凭什么信：精度参考只用 CPU 实现，绝不拿 CUDA 当标准，精度不过关就不看性能；模拟器只用来看清改动动了哪一块，收益一律以真机实测为准，两边对不上听真机的。而且每轮改了什么、前后数据、结论都必须落盘，写不进去这一轮就算失败。</a:t>
             </a:r>
           </a:p>
         </p:txBody>
@@ -3700,7 +3736,7 @@
                 <a:ea typeface="Microsoft YaHei"/>
                 <a:cs typeface="Microsoft YaHei"/>
               </a:rPr>
-              <a:t>xpugen：给国产 GPU 生成原生算子，编译、对齐、测速后按反馈迭代</a:t>
+              <a:t>xpugen：给国产 GPU 写算子的 Agent</a:t>
             </a:r>
           </a:p>
         </p:txBody>
@@ -3754,34 +3790,27 @@
       </p:sp>
       <p:sp>
         <p:nvSpPr>
-          <p:cNvPr id="5" name="Rectangle 4"/>
-          <p:cNvSpPr/>
+          <p:cNvPr id="5" name="TextBox 4"/>
+          <p:cNvSpPr txBox="1"/>
           <p:nvPr/>
         </p:nvSpPr>
         <p:spPr>
           <a:xfrm>
-            <a:off x="548640" y="1874519"/>
-            <a:ext cx="1970166" cy="1207008"/>
+            <a:off x="548640" y="1755648"/>
+            <a:ext cx="5029200" cy="292608"/>
           </a:xfrm>
           <a:prstGeom prst="rect">
             <a:avLst/>
           </a:prstGeom>
-          <a:solidFill>
-            <a:srgbClr val="FFFFFF"/>
-          </a:solidFill>
-          <a:ln w="12700">
-            <a:solidFill>
-              <a:srgbClr val="C0612C"/>
-            </a:solidFill>
-          </a:ln>
-        </p:spPr>
-        <p:txBody>
-          <a:bodyPr rtlCol="0" anchor="ctr" wrap="square" lIns="128016" tIns="91440" rIns="128016" bIns="91440">
+          <a:noFill/>
+        </p:spPr>
+        <p:txBody>
+          <a:bodyPr wrap="square" anchor="ctr" lIns="0" tIns="0" rIns="0" bIns="0">
             <a:noAutofit/>
           </a:bodyPr>
           <a:lstStyle/>
           <a:p>
-            <a:pPr algn="ctr" latinLnBrk="0">
+            <a:pPr algn="l" latinLnBrk="0">
               <a:lnSpc>
                 <a:spcPct val="100000"/>
               </a:lnSpc>
@@ -3789,23 +3818,57 @@
                 <a:spcPts val="0"/>
               </a:spcBef>
               <a:spcAft>
-                <a:spcPts val="500"/>
+                <a:spcPts val="0"/>
               </a:spcAft>
             </a:pPr>
             <a:r>
-              <a:rPr sz="950" b="1">
-                <a:solidFill>
-                  <a:srgbClr val="C0612C"/>
-                </a:solidFill>
-                <a:latin typeface="Consolas"/>
+              <a:rPr sz="1350" b="1">
+                <a:solidFill>
+                  <a:srgbClr val="16202A"/>
+                </a:solidFill>
+                <a:latin typeface="Microsoft YaHei"/>
                 <a:ea typeface="Microsoft YaHei"/>
                 <a:cs typeface="Microsoft YaHei"/>
               </a:rPr>
-              <a:t>　</a:t>
-            </a:r>
-          </a:p>
-          <a:p>
-            <a:pPr algn="ctr" latinLnBrk="0">
+              <a:t>怎么工作</a:t>
+            </a:r>
+            <a:r>
+              <a:rPr sz="1050" b="0">
+                <a:solidFill>
+                  <a:srgbClr val="66727F"/>
+                </a:solidFill>
+                <a:latin typeface="Microsoft YaHei"/>
+                <a:ea typeface="Microsoft YaHei"/>
+                <a:cs typeface="Microsoft YaHei"/>
+              </a:rPr>
+              <a:t>　一个算子，最多 8 轮</a:t>
+            </a:r>
+          </a:p>
+        </p:txBody>
+      </p:sp>
+      <p:sp>
+        <p:nvSpPr>
+          <p:cNvPr id="6" name="TextBox 5"/>
+          <p:cNvSpPr txBox="1"/>
+          <p:nvPr/>
+        </p:nvSpPr>
+        <p:spPr>
+          <a:xfrm>
+            <a:off x="548640" y="2066543"/>
+            <a:ext cx="5029200" cy="256032"/>
+          </a:xfrm>
+          <a:prstGeom prst="rect">
+            <a:avLst/>
+          </a:prstGeom>
+          <a:noFill/>
+        </p:spPr>
+        <p:txBody>
+          <a:bodyPr wrap="square" anchor="ctr" lIns="0" tIns="0" rIns="0" bIns="0">
+            <a:noAutofit/>
+          </a:bodyPr>
+          <a:lstStyle/>
+          <a:p>
+            <a:pPr algn="l" latinLnBrk="0">
               <a:lnSpc>
                 <a:spcPct val="100000"/>
               </a:lnSpc>
@@ -3813,145 +3876,19 @@
                 <a:spcPts val="0"/>
               </a:spcBef>
               <a:spcAft>
-                <a:spcPts val="600"/>
+                <a:spcPts val="0"/>
               </a:spcAft>
             </a:pPr>
             <a:r>
-              <a:rPr sz="1400" b="1">
-                <a:solidFill>
-                  <a:srgbClr val="16202A"/>
+              <a:rPr sz="1050" b="0">
+                <a:solidFill>
+                  <a:srgbClr val="66727F"/>
                 </a:solidFill>
                 <a:latin typeface="Microsoft YaHei"/>
                 <a:ea typeface="Microsoft YaHei"/>
                 <a:cs typeface="Microsoft YaHei"/>
               </a:rPr>
-              <a:t>生成</a:t>
-            </a:r>
-          </a:p>
-          <a:p>
-            <a:pPr algn="ctr" latinLnBrk="0">
-              <a:lnSpc>
-                <a:spcPct val="114000"/>
-              </a:lnSpc>
-              <a:spcBef>
-                <a:spcPts val="0"/>
-              </a:spcBef>
-              <a:spcAft>
-                <a:spcPts val="0"/>
-              </a:spcAft>
-            </a:pPr>
-            <a:r>
-              <a:rPr sz="1050" b="0">
-                <a:solidFill>
-                  <a:srgbClr val="35424F"/>
-                </a:solidFill>
-                <a:latin typeface="Microsoft YaHei"/>
-                <a:ea typeface="Microsoft YaHei"/>
-                <a:cs typeface="Microsoft YaHei"/>
-              </a:rPr>
-              <a:t>LLM 照硬件说明卡写内核</a:t>
-            </a:r>
-          </a:p>
-        </p:txBody>
-      </p:sp>
-      <p:sp>
-        <p:nvSpPr>
-          <p:cNvPr id="6" name="Rectangle 5"/>
-          <p:cNvSpPr/>
-          <p:nvPr/>
-        </p:nvSpPr>
-        <p:spPr>
-          <a:xfrm>
-            <a:off x="2829702" y="1874519"/>
-            <a:ext cx="1970166" cy="1207008"/>
-          </a:xfrm>
-          <a:prstGeom prst="rect">
-            <a:avLst/>
-          </a:prstGeom>
-          <a:solidFill>
-            <a:srgbClr val="FFFFFF"/>
-          </a:solidFill>
-          <a:ln w="12700">
-            <a:solidFill>
-              <a:srgbClr val="C0612C"/>
-            </a:solidFill>
-          </a:ln>
-        </p:spPr>
-        <p:txBody>
-          <a:bodyPr rtlCol="0" anchor="ctr" wrap="square" lIns="128016" tIns="91440" rIns="128016" bIns="91440">
-            <a:noAutofit/>
-          </a:bodyPr>
-          <a:lstStyle/>
-          <a:p>
-            <a:pPr algn="ctr" latinLnBrk="0">
-              <a:lnSpc>
-                <a:spcPct val="100000"/>
-              </a:lnSpc>
-              <a:spcBef>
-                <a:spcPts val="0"/>
-              </a:spcBef>
-              <a:spcAft>
-                <a:spcPts val="500"/>
-              </a:spcAft>
-            </a:pPr>
-            <a:r>
-              <a:rPr sz="950" b="1">
-                <a:solidFill>
-                  <a:srgbClr val="C0612C"/>
-                </a:solidFill>
-                <a:latin typeface="Consolas"/>
-                <a:ea typeface="Microsoft YaHei"/>
-                <a:cs typeface="Microsoft YaHei"/>
-              </a:rPr>
-              <a:t>L0</a:t>
-            </a:r>
-          </a:p>
-          <a:p>
-            <a:pPr algn="ctr" latinLnBrk="0">
-              <a:lnSpc>
-                <a:spcPct val="100000"/>
-              </a:lnSpc>
-              <a:spcBef>
-                <a:spcPts val="0"/>
-              </a:spcBef>
-              <a:spcAft>
-                <a:spcPts val="600"/>
-              </a:spcAft>
-            </a:pPr>
-            <a:r>
-              <a:rPr sz="1400" b="1">
-                <a:solidFill>
-                  <a:srgbClr val="16202A"/>
-                </a:solidFill>
-                <a:latin typeface="Microsoft YaHei"/>
-                <a:ea typeface="Microsoft YaHei"/>
-                <a:cs typeface="Microsoft YaHei"/>
-              </a:rPr>
-              <a:t>编译</a:t>
-            </a:r>
-          </a:p>
-          <a:p>
-            <a:pPr algn="ctr" latinLnBrk="0">
-              <a:lnSpc>
-                <a:spcPct val="114000"/>
-              </a:lnSpc>
-              <a:spcBef>
-                <a:spcPts val="0"/>
-              </a:spcBef>
-              <a:spcAft>
-                <a:spcPts val="0"/>
-              </a:spcAft>
-            </a:pPr>
-            <a:r>
-              <a:rPr sz="1050" b="0">
-                <a:solidFill>
-                  <a:srgbClr val="35424F"/>
-                </a:solidFill>
-                <a:latin typeface="Microsoft YaHei"/>
-                <a:ea typeface="Microsoft YaHei"/>
-                <a:cs typeface="Microsoft YaHei"/>
-              </a:rPr>
-              <a:t>编译并拉起程序</a:t>
+              <a:t>入口：一句需求，或拿现有实现当第 0 轮基线</a:t>
             </a:r>
           </a:p>
         </p:txBody>
@@ -3964,45 +3901,42 @@
         </p:nvCxnSpPr>
         <p:spPr>
           <a:xfrm>
-            <a:off x="2573670" y="2478024"/>
-            <a:ext cx="201168" cy="0"/>
+            <a:off x="1161288" y="2587752"/>
+            <a:ext cx="0" cy="3090672"/>
           </a:xfrm>
           <a:prstGeom prst="line">
             <a:avLst/>
           </a:prstGeom>
-          <a:ln w="19050">
+          <a:ln w="15875">
             <a:solidFill>
-              <a:srgbClr val="C0612C"/>
+              <a:srgbClr val="C5CCD4"/>
             </a:solidFill>
-            <a:tailEnd type="triangle" w="med" len="med"/>
           </a:ln>
         </p:spPr>
       </p:cxnSp>
       <p:sp>
         <p:nvSpPr>
-          <p:cNvPr id="8" name="Rectangle 7"/>
+          <p:cNvPr id="8" name="Oval 7"/>
           <p:cNvSpPr/>
           <p:nvPr/>
         </p:nvSpPr>
         <p:spPr>
           <a:xfrm>
-            <a:off x="5110764" y="1874519"/>
-            <a:ext cx="1970166" cy="1207008"/>
-          </a:xfrm>
-          <a:prstGeom prst="rect">
+            <a:off x="1005840" y="2432304"/>
+            <a:ext cx="310896" cy="310896"/>
+          </a:xfrm>
+          <a:prstGeom prst="ellipse">
             <a:avLst/>
           </a:prstGeom>
           <a:solidFill>
-            <a:srgbClr val="FFFFFF"/>
+            <a:srgbClr val="C0612C"/>
           </a:solidFill>
-          <a:ln w="12700">
-            <a:solidFill>
-              <a:srgbClr val="C0612C"/>
-            </a:solidFill>
+          <a:ln>
+            <a:noFill/>
           </a:ln>
         </p:spPr>
         <p:txBody>
-          <a:bodyPr rtlCol="0" anchor="ctr" wrap="square" lIns="128016" tIns="91440" rIns="128016" bIns="91440">
+          <a:bodyPr rtlCol="0" anchor="ctr" wrap="square" lIns="0" tIns="0" rIns="0" bIns="0">
             <a:noAutofit/>
           </a:bodyPr>
           <a:lstStyle/>
@@ -4015,21 +3949,143 @@
                 <a:spcPts val="0"/>
               </a:spcBef>
               <a:spcAft>
-                <a:spcPts val="500"/>
+                <a:spcPts val="0"/>
               </a:spcAft>
             </a:pPr>
             <a:r>
-              <a:rPr sz="950" b="1">
-                <a:solidFill>
-                  <a:srgbClr val="C0612C"/>
-                </a:solidFill>
-                <a:latin typeface="Consolas"/>
+              <a:rPr sz="1100" b="1">
+                <a:solidFill>
+                  <a:srgbClr val="FFFFFF"/>
+                </a:solidFill>
+                <a:latin typeface="Arial"/>
                 <a:ea typeface="Microsoft YaHei"/>
                 <a:cs typeface="Microsoft YaHei"/>
               </a:rPr>
-              <a:t>L1</a:t>
-            </a:r>
-          </a:p>
+              <a:t>1</a:t>
+            </a:r>
+          </a:p>
+        </p:txBody>
+      </p:sp>
+      <p:sp>
+        <p:nvSpPr>
+          <p:cNvPr id="9" name="TextBox 8"/>
+          <p:cNvSpPr txBox="1"/>
+          <p:nvPr/>
+        </p:nvSpPr>
+        <p:spPr>
+          <a:xfrm>
+            <a:off x="1463040" y="2395728"/>
+            <a:ext cx="4572000" cy="274320"/>
+          </a:xfrm>
+          <a:prstGeom prst="rect">
+            <a:avLst/>
+          </a:prstGeom>
+          <a:noFill/>
+        </p:spPr>
+        <p:txBody>
+          <a:bodyPr wrap="square" anchor="ctr" lIns="0" tIns="0" rIns="0" bIns="0">
+            <a:noAutofit/>
+          </a:bodyPr>
+          <a:lstStyle/>
+          <a:p>
+            <a:pPr algn="l" latinLnBrk="0">
+              <a:lnSpc>
+                <a:spcPct val="100000"/>
+              </a:lnSpc>
+              <a:spcBef>
+                <a:spcPts val="0"/>
+              </a:spcBef>
+              <a:spcAft>
+                <a:spcPts val="0"/>
+              </a:spcAft>
+            </a:pPr>
+            <a:r>
+              <a:rPr sz="1300" b="1">
+                <a:solidFill>
+                  <a:srgbClr val="16202A"/>
+                </a:solidFill>
+                <a:latin typeface="Microsoft YaHei"/>
+                <a:ea typeface="Microsoft YaHei"/>
+                <a:cs typeface="Microsoft YaHei"/>
+              </a:rPr>
+              <a:t>生成</a:t>
+            </a:r>
+          </a:p>
+        </p:txBody>
+      </p:sp>
+      <p:sp>
+        <p:nvSpPr>
+          <p:cNvPr id="10" name="TextBox 9"/>
+          <p:cNvSpPr txBox="1"/>
+          <p:nvPr/>
+        </p:nvSpPr>
+        <p:spPr>
+          <a:xfrm>
+            <a:off x="1463040" y="2670048"/>
+            <a:ext cx="4572000" cy="256032"/>
+          </a:xfrm>
+          <a:prstGeom prst="rect">
+            <a:avLst/>
+          </a:prstGeom>
+          <a:noFill/>
+        </p:spPr>
+        <p:txBody>
+          <a:bodyPr wrap="square" anchor="ctr" lIns="0" tIns="0" rIns="0" bIns="0">
+            <a:noAutofit/>
+          </a:bodyPr>
+          <a:lstStyle/>
+          <a:p>
+            <a:pPr algn="l" latinLnBrk="0">
+              <a:lnSpc>
+                <a:spcPct val="100000"/>
+              </a:lnSpc>
+              <a:spcBef>
+                <a:spcPts val="0"/>
+              </a:spcBef>
+              <a:spcAft>
+                <a:spcPts val="0"/>
+              </a:spcAft>
+            </a:pPr>
+            <a:r>
+              <a:rPr sz="1050" b="0">
+                <a:solidFill>
+                  <a:srgbClr val="35424F"/>
+                </a:solidFill>
+                <a:latin typeface="Microsoft YaHei"/>
+                <a:ea typeface="Microsoft YaHei"/>
+                <a:cs typeface="Microsoft YaHei"/>
+              </a:rPr>
+              <a:t>LLM 照硬件说明卡写出内核</a:t>
+            </a:r>
+          </a:p>
+        </p:txBody>
+      </p:sp>
+      <p:sp>
+        <p:nvSpPr>
+          <p:cNvPr id="11" name="Oval 10"/>
+          <p:cNvSpPr/>
+          <p:nvPr/>
+        </p:nvSpPr>
+        <p:spPr>
+          <a:xfrm>
+            <a:off x="1005840" y="3204972"/>
+            <a:ext cx="310896" cy="310896"/>
+          </a:xfrm>
+          <a:prstGeom prst="ellipse">
+            <a:avLst/>
+          </a:prstGeom>
+          <a:solidFill>
+            <a:srgbClr val="C0612C"/>
+          </a:solidFill>
+          <a:ln>
+            <a:noFill/>
+          </a:ln>
+        </p:spPr>
+        <p:txBody>
+          <a:bodyPr rtlCol="0" anchor="ctr" wrap="square" lIns="0" tIns="0" rIns="0" bIns="0">
+            <a:noAutofit/>
+          </a:bodyPr>
+          <a:lstStyle/>
           <a:p>
             <a:pPr algn="ctr" latinLnBrk="0">
               <a:lnSpc>
@@ -4039,11 +4095,58 @@
                 <a:spcPts val="0"/>
               </a:spcBef>
               <a:spcAft>
-                <a:spcPts val="600"/>
+                <a:spcPts val="0"/>
               </a:spcAft>
             </a:pPr>
             <a:r>
-              <a:rPr sz="1400" b="1">
+              <a:rPr sz="1100" b="1">
+                <a:solidFill>
+                  <a:srgbClr val="FFFFFF"/>
+                </a:solidFill>
+                <a:latin typeface="Arial"/>
+                <a:ea typeface="Microsoft YaHei"/>
+                <a:cs typeface="Microsoft YaHei"/>
+              </a:rPr>
+              <a:t>2</a:t>
+            </a:r>
+          </a:p>
+        </p:txBody>
+      </p:sp>
+      <p:sp>
+        <p:nvSpPr>
+          <p:cNvPr id="12" name="TextBox 11"/>
+          <p:cNvSpPr txBox="1"/>
+          <p:nvPr/>
+        </p:nvSpPr>
+        <p:spPr>
+          <a:xfrm>
+            <a:off x="1463040" y="3168396"/>
+            <a:ext cx="4572000" cy="274320"/>
+          </a:xfrm>
+          <a:prstGeom prst="rect">
+            <a:avLst/>
+          </a:prstGeom>
+          <a:noFill/>
+        </p:spPr>
+        <p:txBody>
+          <a:bodyPr wrap="square" anchor="ctr" lIns="0" tIns="0" rIns="0" bIns="0">
+            <a:noAutofit/>
+          </a:bodyPr>
+          <a:lstStyle/>
+          <a:p>
+            <a:pPr algn="l" latinLnBrk="0">
+              <a:lnSpc>
+                <a:spcPct val="100000"/>
+              </a:lnSpc>
+              <a:spcBef>
+                <a:spcPts val="0"/>
+              </a:spcBef>
+              <a:spcAft>
+                <a:spcPts val="0"/>
+              </a:spcAft>
+            </a:pPr>
+            <a:r>
+              <a:rPr sz="1300" b="1">
                 <a:solidFill>
                   <a:srgbClr val="16202A"/>
                 </a:solidFill>
@@ -4051,13 +4154,36 @@
                 <a:ea typeface="Microsoft YaHei"/>
                 <a:cs typeface="Microsoft YaHei"/>
               </a:rPr>
-              <a:t>对齐 golden</a:t>
-            </a:r>
-          </a:p>
-          <a:p>
-            <a:pPr algn="ctr" latinLnBrk="0">
+              <a:t>编译</a:t>
+            </a:r>
+          </a:p>
+        </p:txBody>
+      </p:sp>
+      <p:sp>
+        <p:nvSpPr>
+          <p:cNvPr id="13" name="TextBox 12"/>
+          <p:cNvSpPr txBox="1"/>
+          <p:nvPr/>
+        </p:nvSpPr>
+        <p:spPr>
+          <a:xfrm>
+            <a:off x="1463040" y="3442715"/>
+            <a:ext cx="4572000" cy="256032"/>
+          </a:xfrm>
+          <a:prstGeom prst="rect">
+            <a:avLst/>
+          </a:prstGeom>
+          <a:noFill/>
+        </p:spPr>
+        <p:txBody>
+          <a:bodyPr wrap="square" anchor="ctr" lIns="0" tIns="0" rIns="0" bIns="0">
+            <a:noAutofit/>
+          </a:bodyPr>
+          <a:lstStyle/>
+          <a:p>
+            <a:pPr algn="l" latinLnBrk="0">
               <a:lnSpc>
-                <a:spcPct val="114000"/>
+                <a:spcPct val="100000"/>
               </a:lnSpc>
               <a:spcBef>
                 <a:spcPts val="0"/>
@@ -4075,58 +4201,34 @@
                 <a:ea typeface="Microsoft YaHei"/>
                 <a:cs typeface="Microsoft YaHei"/>
               </a:rPr>
-              <a:t>多种形状、精度逐一对数值</a:t>
-            </a:r>
-          </a:p>
-        </p:txBody>
-      </p:sp>
-      <p:cxnSp>
-        <p:nvCxnSpPr>
-          <p:cNvPr id="9" name="Connector 8"/>
-          <p:cNvCxnSpPr/>
-          <p:nvPr/>
-        </p:nvCxnSpPr>
-        <p:spPr>
-          <a:xfrm>
-            <a:off x="4854732" y="2478024"/>
-            <a:ext cx="201168" cy="0"/>
-          </a:xfrm>
-          <a:prstGeom prst="line">
-            <a:avLst/>
-          </a:prstGeom>
-          <a:ln w="19050">
-            <a:solidFill>
-              <a:srgbClr val="C0612C"/>
-            </a:solidFill>
-            <a:tailEnd type="triangle" w="med" len="med"/>
-          </a:ln>
-        </p:spPr>
-      </p:cxnSp>
-      <p:sp>
-        <p:nvSpPr>
-          <p:cNvPr id="10" name="Rectangle 9"/>
+              <a:t>编译并拉起程序，跑通才往下走</a:t>
+            </a:r>
+          </a:p>
+        </p:txBody>
+      </p:sp>
+      <p:sp>
+        <p:nvSpPr>
+          <p:cNvPr id="14" name="Oval 13"/>
           <p:cNvSpPr/>
           <p:nvPr/>
         </p:nvSpPr>
         <p:spPr>
           <a:xfrm>
-            <a:off x="7391826" y="1874519"/>
-            <a:ext cx="1970166" cy="1207008"/>
-          </a:xfrm>
-          <a:prstGeom prst="rect">
+            <a:off x="1005840" y="3977639"/>
+            <a:ext cx="310896" cy="310896"/>
+          </a:xfrm>
+          <a:prstGeom prst="ellipse">
             <a:avLst/>
           </a:prstGeom>
           <a:solidFill>
-            <a:srgbClr val="FFFFFF"/>
+            <a:srgbClr val="C0612C"/>
           </a:solidFill>
-          <a:ln w="12700">
-            <a:solidFill>
-              <a:srgbClr val="C0612C"/>
-            </a:solidFill>
+          <a:ln>
+            <a:noFill/>
           </a:ln>
         </p:spPr>
         <p:txBody>
-          <a:bodyPr rtlCol="0" anchor="ctr" wrap="square" lIns="128016" tIns="91440" rIns="128016" bIns="91440">
+          <a:bodyPr rtlCol="0" anchor="ctr" wrap="square" lIns="0" tIns="0" rIns="0" bIns="0">
             <a:noAutofit/>
           </a:bodyPr>
           <a:lstStyle/>
@@ -4139,21 +4241,143 @@
                 <a:spcPts val="0"/>
               </a:spcBef>
               <a:spcAft>
-                <a:spcPts val="500"/>
+                <a:spcPts val="0"/>
               </a:spcAft>
             </a:pPr>
             <a:r>
-              <a:rPr sz="950" b="1">
-                <a:solidFill>
-                  <a:srgbClr val="C0612C"/>
-                </a:solidFill>
-                <a:latin typeface="Consolas"/>
+              <a:rPr sz="1100" b="1">
+                <a:solidFill>
+                  <a:srgbClr val="FFFFFF"/>
+                </a:solidFill>
+                <a:latin typeface="Arial"/>
                 <a:ea typeface="Microsoft YaHei"/>
                 <a:cs typeface="Microsoft YaHei"/>
               </a:rPr>
-              <a:t>BENCH · PROFILE</a:t>
-            </a:r>
-          </a:p>
+              <a:t>3</a:t>
+            </a:r>
+          </a:p>
+        </p:txBody>
+      </p:sp>
+      <p:sp>
+        <p:nvSpPr>
+          <p:cNvPr id="15" name="TextBox 14"/>
+          <p:cNvSpPr txBox="1"/>
+          <p:nvPr/>
+        </p:nvSpPr>
+        <p:spPr>
+          <a:xfrm>
+            <a:off x="1463040" y="3941063"/>
+            <a:ext cx="4572000" cy="274320"/>
+          </a:xfrm>
+          <a:prstGeom prst="rect">
+            <a:avLst/>
+          </a:prstGeom>
+          <a:noFill/>
+        </p:spPr>
+        <p:txBody>
+          <a:bodyPr wrap="square" anchor="ctr" lIns="0" tIns="0" rIns="0" bIns="0">
+            <a:noAutofit/>
+          </a:bodyPr>
+          <a:lstStyle/>
+          <a:p>
+            <a:pPr algn="l" latinLnBrk="0">
+              <a:lnSpc>
+                <a:spcPct val="100000"/>
+              </a:lnSpc>
+              <a:spcBef>
+                <a:spcPts val="0"/>
+              </a:spcBef>
+              <a:spcAft>
+                <a:spcPts val="0"/>
+              </a:spcAft>
+            </a:pPr>
+            <a:r>
+              <a:rPr sz="1300" b="1">
+                <a:solidFill>
+                  <a:srgbClr val="16202A"/>
+                </a:solidFill>
+                <a:latin typeface="Microsoft YaHei"/>
+                <a:ea typeface="Microsoft YaHei"/>
+                <a:cs typeface="Microsoft YaHei"/>
+              </a:rPr>
+              <a:t>对数值</a:t>
+            </a:r>
+          </a:p>
+        </p:txBody>
+      </p:sp>
+      <p:sp>
+        <p:nvSpPr>
+          <p:cNvPr id="16" name="TextBox 15"/>
+          <p:cNvSpPr txBox="1"/>
+          <p:nvPr/>
+        </p:nvSpPr>
+        <p:spPr>
+          <a:xfrm>
+            <a:off x="1463040" y="4215383"/>
+            <a:ext cx="4572000" cy="256032"/>
+          </a:xfrm>
+          <a:prstGeom prst="rect">
+            <a:avLst/>
+          </a:prstGeom>
+          <a:noFill/>
+        </p:spPr>
+        <p:txBody>
+          <a:bodyPr wrap="square" anchor="ctr" lIns="0" tIns="0" rIns="0" bIns="0">
+            <a:noAutofit/>
+          </a:bodyPr>
+          <a:lstStyle/>
+          <a:p>
+            <a:pPr algn="l" latinLnBrk="0">
+              <a:lnSpc>
+                <a:spcPct val="100000"/>
+              </a:lnSpc>
+              <a:spcBef>
+                <a:spcPts val="0"/>
+              </a:spcBef>
+              <a:spcAft>
+                <a:spcPts val="0"/>
+              </a:spcAft>
+            </a:pPr>
+            <a:r>
+              <a:rPr sz="1050" b="0">
+                <a:solidFill>
+                  <a:srgbClr val="35424F"/>
+                </a:solidFill>
+                <a:latin typeface="Microsoft YaHei"/>
+                <a:ea typeface="Microsoft YaHei"/>
+                <a:cs typeface="Microsoft YaHei"/>
+              </a:rPr>
+              <a:t>多种形状、精度逐一对 golden</a:t>
+            </a:r>
+          </a:p>
+        </p:txBody>
+      </p:sp>
+      <p:sp>
+        <p:nvSpPr>
+          <p:cNvPr id="17" name="Oval 16"/>
+          <p:cNvSpPr/>
+          <p:nvPr/>
+        </p:nvSpPr>
+        <p:spPr>
+          <a:xfrm>
+            <a:off x="1005840" y="4750308"/>
+            <a:ext cx="310896" cy="310896"/>
+          </a:xfrm>
+          <a:prstGeom prst="ellipse">
+            <a:avLst/>
+          </a:prstGeom>
+          <a:solidFill>
+            <a:srgbClr val="C0612C"/>
+          </a:solidFill>
+          <a:ln>
+            <a:noFill/>
+          </a:ln>
+        </p:spPr>
+        <p:txBody>
+          <a:bodyPr rtlCol="0" anchor="ctr" wrap="square" lIns="0" tIns="0" rIns="0" bIns="0">
+            <a:noAutofit/>
+          </a:bodyPr>
+          <a:lstStyle/>
           <a:p>
             <a:pPr algn="ctr" latinLnBrk="0">
               <a:lnSpc>
@@ -4163,11 +4387,58 @@
                 <a:spcPts val="0"/>
               </a:spcBef>
               <a:spcAft>
-                <a:spcPts val="600"/>
+                <a:spcPts val="0"/>
               </a:spcAft>
             </a:pPr>
             <a:r>
-              <a:rPr sz="1400" b="1">
+              <a:rPr sz="1100" b="1">
+                <a:solidFill>
+                  <a:srgbClr val="FFFFFF"/>
+                </a:solidFill>
+                <a:latin typeface="Arial"/>
+                <a:ea typeface="Microsoft YaHei"/>
+                <a:cs typeface="Microsoft YaHei"/>
+              </a:rPr>
+              <a:t>4</a:t>
+            </a:r>
+          </a:p>
+        </p:txBody>
+      </p:sp>
+      <p:sp>
+        <p:nvSpPr>
+          <p:cNvPr id="18" name="TextBox 17"/>
+          <p:cNvSpPr txBox="1"/>
+          <p:nvPr/>
+        </p:nvSpPr>
+        <p:spPr>
+          <a:xfrm>
+            <a:off x="1463040" y="4713732"/>
+            <a:ext cx="4572000" cy="274320"/>
+          </a:xfrm>
+          <a:prstGeom prst="rect">
+            <a:avLst/>
+          </a:prstGeom>
+          <a:noFill/>
+        </p:spPr>
+        <p:txBody>
+          <a:bodyPr wrap="square" anchor="ctr" lIns="0" tIns="0" rIns="0" bIns="0">
+            <a:noAutofit/>
+          </a:bodyPr>
+          <a:lstStyle/>
+          <a:p>
+            <a:pPr algn="l" latinLnBrk="0">
+              <a:lnSpc>
+                <a:spcPct val="100000"/>
+              </a:lnSpc>
+              <a:spcBef>
+                <a:spcPts val="0"/>
+              </a:spcBef>
+              <a:spcAft>
+                <a:spcPts val="0"/>
+              </a:spcAft>
+            </a:pPr>
+            <a:r>
+              <a:rPr sz="1300" b="1">
                 <a:solidFill>
                   <a:srgbClr val="16202A"/>
                 </a:solidFill>
@@ -4175,13 +4446,36 @@
                 <a:ea typeface="Microsoft YaHei"/>
                 <a:cs typeface="Microsoft YaHei"/>
               </a:rPr>
-              <a:t>测延迟</a:t>
-            </a:r>
-          </a:p>
-          <a:p>
-            <a:pPr algn="ctr" latinLnBrk="0">
+              <a:t>测性能</a:t>
+            </a:r>
+          </a:p>
+        </p:txBody>
+      </p:sp>
+      <p:sp>
+        <p:nvSpPr>
+          <p:cNvPr id="19" name="TextBox 18"/>
+          <p:cNvSpPr txBox="1"/>
+          <p:nvPr/>
+        </p:nvSpPr>
+        <p:spPr>
+          <a:xfrm>
+            <a:off x="1463040" y="4988052"/>
+            <a:ext cx="4572000" cy="256032"/>
+          </a:xfrm>
+          <a:prstGeom prst="rect">
+            <a:avLst/>
+          </a:prstGeom>
+          <a:noFill/>
+        </p:spPr>
+        <p:txBody>
+          <a:bodyPr wrap="square" anchor="ctr" lIns="0" tIns="0" rIns="0" bIns="0">
+            <a:noAutofit/>
+          </a:bodyPr>
+          <a:lstStyle/>
+          <a:p>
+            <a:pPr algn="l" latinLnBrk="0">
               <a:lnSpc>
-                <a:spcPct val="114000"/>
+                <a:spcPct val="100000"/>
               </a:lnSpc>
               <a:spcBef>
                 <a:spcPts val="0"/>
@@ -4199,58 +4493,34 @@
                 <a:ea typeface="Microsoft YaHei"/>
                 <a:cs typeface="Microsoft YaHei"/>
               </a:rPr>
-              <a:t>取中位延迟，比理论上限</a:t>
-            </a:r>
-          </a:p>
-        </p:txBody>
-      </p:sp>
-      <p:cxnSp>
-        <p:nvCxnSpPr>
-          <p:cNvPr id="11" name="Connector 10"/>
-          <p:cNvCxnSpPr/>
-          <p:nvPr/>
-        </p:nvCxnSpPr>
-        <p:spPr>
-          <a:xfrm>
-            <a:off x="7135794" y="2478024"/>
-            <a:ext cx="201168" cy="0"/>
-          </a:xfrm>
-          <a:prstGeom prst="line">
-            <a:avLst/>
-          </a:prstGeom>
-          <a:ln w="19050">
-            <a:solidFill>
-              <a:srgbClr val="C0612C"/>
-            </a:solidFill>
-            <a:tailEnd type="triangle" w="med" len="med"/>
-          </a:ln>
-        </p:spPr>
-      </p:cxnSp>
-      <p:sp>
-        <p:nvSpPr>
-          <p:cNvPr id="12" name="Rectangle 11"/>
+              <a:t>取中位延迟，和理论上限比</a:t>
+            </a:r>
+          </a:p>
+        </p:txBody>
+      </p:sp>
+      <p:sp>
+        <p:nvSpPr>
+          <p:cNvPr id="20" name="Oval 19"/>
           <p:cNvSpPr/>
           <p:nvPr/>
         </p:nvSpPr>
         <p:spPr>
           <a:xfrm>
-            <a:off x="9672888" y="1874519"/>
-            <a:ext cx="1970166" cy="1207008"/>
-          </a:xfrm>
-          <a:prstGeom prst="rect">
+            <a:off x="1005840" y="5522976"/>
+            <a:ext cx="310896" cy="310896"/>
+          </a:xfrm>
+          <a:prstGeom prst="ellipse">
             <a:avLst/>
           </a:prstGeom>
           <a:solidFill>
-            <a:srgbClr val="FFFFFF"/>
+            <a:srgbClr val="C0612C"/>
           </a:solidFill>
-          <a:ln w="12700">
-            <a:solidFill>
-              <a:srgbClr val="C0612C"/>
-            </a:solidFill>
+          <a:ln>
+            <a:noFill/>
           </a:ln>
         </p:spPr>
         <p:txBody>
-          <a:bodyPr rtlCol="0" anchor="ctr" wrap="square" lIns="128016" tIns="91440" rIns="128016" bIns="91440">
+          <a:bodyPr rtlCol="0" anchor="ctr" wrap="square" lIns="0" tIns="0" rIns="0" bIns="0">
             <a:noAutofit/>
           </a:bodyPr>
           <a:lstStyle/>
@@ -4263,23 +4533,46 @@
                 <a:spcPts val="0"/>
               </a:spcBef>
               <a:spcAft>
-                <a:spcPts val="500"/>
+                <a:spcPts val="0"/>
               </a:spcAft>
             </a:pPr>
             <a:r>
-              <a:rPr sz="950" b="1">
-                <a:solidFill>
-                  <a:srgbClr val="C0612C"/>
-                </a:solidFill>
-                <a:latin typeface="Consolas"/>
+              <a:rPr sz="1100" b="1">
+                <a:solidFill>
+                  <a:srgbClr val="FFFFFF"/>
+                </a:solidFill>
+                <a:latin typeface="Arial"/>
                 <a:ea typeface="Microsoft YaHei"/>
                 <a:cs typeface="Microsoft YaHei"/>
               </a:rPr>
-              <a:t>SIM</a:t>
-            </a:r>
-          </a:p>
-          <a:p>
-            <a:pPr algn="ctr" latinLnBrk="0">
+              <a:t>5</a:t>
+            </a:r>
+          </a:p>
+        </p:txBody>
+      </p:sp>
+      <p:sp>
+        <p:nvSpPr>
+          <p:cNvPr id="21" name="TextBox 20"/>
+          <p:cNvSpPr txBox="1"/>
+          <p:nvPr/>
+        </p:nvSpPr>
+        <p:spPr>
+          <a:xfrm>
+            <a:off x="1463040" y="5486400"/>
+            <a:ext cx="4572000" cy="274320"/>
+          </a:xfrm>
+          <a:prstGeom prst="rect">
+            <a:avLst/>
+          </a:prstGeom>
+          <a:noFill/>
+        </p:spPr>
+        <p:txBody>
+          <a:bodyPr wrap="square" anchor="ctr" lIns="0" tIns="0" rIns="0" bIns="0">
+            <a:noAutofit/>
+          </a:bodyPr>
+          <a:lstStyle/>
+          <a:p>
+            <a:pPr algn="l" latinLnBrk="0">
               <a:lnSpc>
                 <a:spcPct val="100000"/>
               </a:lnSpc>
@@ -4287,11 +4580,11 @@
                 <a:spcPts val="0"/>
               </a:spcBef>
               <a:spcAft>
-                <a:spcPts val="600"/>
+                <a:spcPts val="0"/>
               </a:spcAft>
             </a:pPr>
             <a:r>
-              <a:rPr sz="1400" b="1">
+              <a:rPr sz="1300" b="1">
                 <a:solidFill>
                   <a:srgbClr val="16202A"/>
                 </a:solidFill>
@@ -4299,13 +4592,36 @@
                 <a:ea typeface="Microsoft YaHei"/>
                 <a:cs typeface="Microsoft YaHei"/>
               </a:rPr>
-              <a:t>结构化反馈</a:t>
-            </a:r>
-          </a:p>
-          <a:p>
-            <a:pPr algn="ctr" latinLnBrk="0">
+              <a:t>给反馈</a:t>
+            </a:r>
+          </a:p>
+        </p:txBody>
+      </p:sp>
+      <p:sp>
+        <p:nvSpPr>
+          <p:cNvPr id="22" name="TextBox 21"/>
+          <p:cNvSpPr txBox="1"/>
+          <p:nvPr/>
+        </p:nvSpPr>
+        <p:spPr>
+          <a:xfrm>
+            <a:off x="1463040" y="5760720"/>
+            <a:ext cx="4572000" cy="256032"/>
+          </a:xfrm>
+          <a:prstGeom prst="rect">
+            <a:avLst/>
+          </a:prstGeom>
+          <a:noFill/>
+        </p:spPr>
+        <p:txBody>
+          <a:bodyPr wrap="square" anchor="ctr" lIns="0" tIns="0" rIns="0" bIns="0">
+            <a:noAutofit/>
+          </a:bodyPr>
+          <a:lstStyle/>
+          <a:p>
+            <a:pPr algn="l" latinLnBrk="0">
               <a:lnSpc>
-                <a:spcPct val="114000"/>
+                <a:spcPct val="100000"/>
               </a:lnSpc>
               <a:spcBef>
                 <a:spcPts val="0"/>
@@ -4323,43 +4639,21 @@
                 <a:ea typeface="Microsoft YaHei"/>
                 <a:cs typeface="Microsoft YaHei"/>
               </a:rPr>
-              <a:t>打分，并指出慢在哪</a:t>
-            </a:r>
-          </a:p>
-        </p:txBody>
-      </p:sp>
-      <p:cxnSp>
-        <p:nvCxnSpPr>
-          <p:cNvPr id="13" name="Connector 12"/>
-          <p:cNvCxnSpPr/>
-          <p:nvPr/>
-        </p:nvCxnSpPr>
-        <p:spPr>
-          <a:xfrm>
-            <a:off x="9416856" y="2478024"/>
-            <a:ext cx="201168" cy="0"/>
-          </a:xfrm>
-          <a:prstGeom prst="line">
-            <a:avLst/>
-          </a:prstGeom>
-          <a:ln w="19050">
-            <a:solidFill>
-              <a:srgbClr val="C0612C"/>
-            </a:solidFill>
-            <a:tailEnd type="triangle" w="med" len="med"/>
-          </a:ln>
-        </p:spPr>
-      </p:cxnSp>
-      <p:sp>
-        <p:nvSpPr>
-          <p:cNvPr id="14" name="Freeform 13"/>
+              <a:t>打分、指出慢在哪，带进下一轮</a:t>
+            </a:r>
+          </a:p>
+        </p:txBody>
+      </p:sp>
+      <p:sp>
+        <p:nvSpPr>
+          <p:cNvPr id="23" name="Freeform 22"/>
           <p:cNvSpPr/>
           <p:nvPr/>
         </p:nvSpPr>
         <p:spPr>
           <a:xfrm>
-            <a:off x="1533723" y="3081528"/>
-            <a:ext cx="9124249" cy="256032"/>
+            <a:off x="594360" y="2587752"/>
+            <a:ext cx="566928" cy="3337560"/>
           </a:xfrm>
           <a:custGeom>
             <a:avLst/>
@@ -4368,18 +4662,18 @@
             <a:cxnLst/>
             <a:rect l="l" t="t" r="r" b="b"/>
             <a:pathLst>
-              <a:path w="9124249" h="256032">
+              <a:path w="566928" h="3337560">
                 <a:moveTo>
-                  <a:pt x="9124249" y="0"/>
+                  <a:pt x="566928" y="3337560"/>
                 </a:moveTo>
                 <a:lnTo>
-                  <a:pt x="9124249" y="256032"/>
-                </a:lnTo>
-                <a:lnTo>
-                  <a:pt x="0" y="256032"/>
+                  <a:pt x="0" y="3337560"/>
                 </a:lnTo>
                 <a:lnTo>
                   <a:pt x="0" y="0"/>
+                </a:lnTo>
+                <a:lnTo>
+                  <a:pt x="374904" y="0"/>
                 </a:lnTo>
               </a:path>
             </a:pathLst>
@@ -4402,108 +4696,14 @@
       </p:sp>
       <p:sp>
         <p:nvSpPr>
-          <p:cNvPr id="15" name="TextBox 14"/>
-          <p:cNvSpPr txBox="1"/>
-          <p:nvPr/>
-        </p:nvSpPr>
-        <p:spPr>
-          <a:xfrm>
-            <a:off x="1734891" y="3374136"/>
-            <a:ext cx="4114800" cy="274320"/>
-          </a:xfrm>
-          <a:prstGeom prst="rect">
-            <a:avLst/>
-          </a:prstGeom>
-          <a:noFill/>
-        </p:spPr>
-        <p:txBody>
-          <a:bodyPr wrap="square" anchor="ctr" lIns="0" tIns="0" rIns="0" bIns="0">
-            <a:noAutofit/>
-          </a:bodyPr>
-          <a:lstStyle/>
-          <a:p>
-            <a:pPr algn="l" latinLnBrk="0">
-              <a:lnSpc>
-                <a:spcPct val="100000"/>
-              </a:lnSpc>
-              <a:spcBef>
-                <a:spcPts val="0"/>
-              </a:spcBef>
-              <a:spcAft>
-                <a:spcPts val="0"/>
-              </a:spcAft>
-            </a:pPr>
-            <a:r>
-              <a:rPr sz="1050" b="0">
-                <a:solidFill>
-                  <a:srgbClr val="66727F"/>
-                </a:solidFill>
-                <a:latin typeface="Microsoft YaHei"/>
-                <a:ea typeface="Microsoft YaHei"/>
-                <a:cs typeface="Microsoft YaHei"/>
-              </a:rPr>
-              <a:t>每轮改了什么、前后数据、结论都要落盘，写不进去这轮就算失败</a:t>
-            </a:r>
-          </a:p>
-        </p:txBody>
-      </p:sp>
-      <p:sp>
-        <p:nvSpPr>
-          <p:cNvPr id="16" name="TextBox 15"/>
-          <p:cNvSpPr txBox="1"/>
-          <p:nvPr/>
-        </p:nvSpPr>
-        <p:spPr>
-          <a:xfrm>
-            <a:off x="6085972" y="3374136"/>
-            <a:ext cx="4572000" cy="274320"/>
-          </a:xfrm>
-          <a:prstGeom prst="rect">
-            <a:avLst/>
-          </a:prstGeom>
-          <a:noFill/>
-        </p:spPr>
-        <p:txBody>
-          <a:bodyPr wrap="square" anchor="ctr" lIns="0" tIns="0" rIns="0" bIns="0">
-            <a:noAutofit/>
-          </a:bodyPr>
-          <a:lstStyle/>
-          <a:p>
-            <a:pPr algn="r" latinLnBrk="0">
-              <a:lnSpc>
-                <a:spcPct val="100000"/>
-              </a:lnSpc>
-              <a:spcBef>
-                <a:spcPts val="0"/>
-              </a:spcBef>
-              <a:spcAft>
-                <a:spcPts val="0"/>
-              </a:spcAft>
-            </a:pPr>
-            <a:r>
-              <a:rPr sz="1050" b="0">
-                <a:solidFill>
-                  <a:srgbClr val="66727F"/>
-                </a:solidFill>
-                <a:latin typeface="Microsoft YaHei"/>
-                <a:ea typeface="Microsoft YaHei"/>
-                <a:cs typeface="Microsoft YaHei"/>
-              </a:rPr>
-              <a:t>入口：从一句需求开始，或从现有实现反推规格、第 0 轮当基线</a:t>
-            </a:r>
-          </a:p>
-        </p:txBody>
-      </p:sp>
-      <p:sp>
-        <p:nvSpPr>
-          <p:cNvPr id="17" name="Rectangle 16"/>
+          <p:cNvPr id="24" name="Rectangle 23"/>
           <p:cNvSpPr/>
           <p:nvPr/>
         </p:nvSpPr>
         <p:spPr>
           <a:xfrm>
-            <a:off x="548640" y="3785615"/>
-            <a:ext cx="5410047" cy="1645920"/>
+            <a:off x="5897880" y="2066543"/>
+            <a:ext cx="5745175" cy="3785616"/>
           </a:xfrm>
           <a:prstGeom prst="rect">
             <a:avLst/>
@@ -4525,14 +4725,14 @@
       </p:sp>
       <p:sp>
         <p:nvSpPr>
-          <p:cNvPr id="18" name="TextBox 17"/>
+          <p:cNvPr id="25" name="TextBox 24"/>
           <p:cNvSpPr txBox="1"/>
           <p:nvPr/>
         </p:nvSpPr>
         <p:spPr>
           <a:xfrm>
-            <a:off x="786384" y="3931920"/>
-            <a:ext cx="4952847" cy="292608"/>
+            <a:off x="6135624" y="2212848"/>
+            <a:ext cx="5287975" cy="292608"/>
           </a:xfrm>
           <a:prstGeom prst="rect">
             <a:avLst/>
@@ -4565,134 +4765,38 @@
                 <a:ea typeface="Microsoft YaHei"/>
                 <a:cs typeface="Microsoft YaHei"/>
               </a:rPr>
-              <a:t>硬件解耦 · 换一款芯片只动一层</a:t>
-            </a:r>
-          </a:p>
-        </p:txBody>
-      </p:sp>
-      <p:sp>
-        <p:nvSpPr>
-          <p:cNvPr id="19" name="TextBox 18"/>
-          <p:cNvSpPr txBox="1"/>
-          <p:nvPr/>
-        </p:nvSpPr>
-        <p:spPr>
-          <a:xfrm>
-            <a:off x="786384" y="4261104"/>
-            <a:ext cx="4934559" cy="731520"/>
-          </a:xfrm>
-          <a:prstGeom prst="rect">
-            <a:avLst/>
-          </a:prstGeom>
-          <a:noFill/>
-        </p:spPr>
-        <p:txBody>
-          <a:bodyPr wrap="square" anchor="t" lIns="0" tIns="0" rIns="0" bIns="0">
-            <a:noAutofit/>
-          </a:bodyPr>
-          <a:lstStyle/>
-          <a:p>
-            <a:pPr algn="l" latinLnBrk="0" marL="146304" indent="-146304">
-              <a:lnSpc>
-                <a:spcPct val="100000"/>
-              </a:lnSpc>
-              <a:spcBef>
-                <a:spcPts val="0"/>
-              </a:spcBef>
-              <a:spcAft>
-                <a:spcPts val="200"/>
-              </a:spcAft>
-              <a:buClr>
-                <a:srgbClr val="C0612C"/>
-              </a:buClr>
-              <a:buFont typeface="Arial"/>
-              <a:buChar char="•"/>
-            </a:pPr>
-            <a:r>
-              <a:rPr sz="1100" b="0">
-                <a:solidFill>
-                  <a:srgbClr val="35424F"/>
+              <a:t>效果</a:t>
+            </a:r>
+            <a:r>
+              <a:rPr sz="1050" b="0">
+                <a:solidFill>
+                  <a:srgbClr val="8C96A1"/>
                 </a:solidFill>
                 <a:latin typeface="Microsoft YaHei"/>
                 <a:ea typeface="Microsoft YaHei"/>
                 <a:cs typeface="Microsoft YaHei"/>
               </a:rPr>
-              <a:t>生成和评测完全不碰硬件，只认四个接口</a:t>
-            </a:r>
-          </a:p>
-          <a:p>
-            <a:pPr algn="l" latinLnBrk="0">
-              <a:lnSpc>
-                <a:spcPct val="100000"/>
-              </a:lnSpc>
-              <a:spcBef>
-                <a:spcPts val="0"/>
-              </a:spcBef>
-              <a:spcAft>
-                <a:spcPts val="500"/>
-              </a:spcAft>
-            </a:pPr>
-            <a:r>
-              <a:rPr sz="1050" b="0">
-                <a:solidFill>
-                  <a:srgbClr val="66727F"/>
-                </a:solidFill>
-                <a:latin typeface="Microsoft YaHei"/>
-                <a:ea typeface="Microsoft YaHei"/>
-                <a:cs typeface="Microsoft YaHei"/>
-              </a:rPr>
-              <a:t>　编译、运行、采性能、算理论上限（roofline）</a:t>
-            </a:r>
-          </a:p>
-          <a:p>
-            <a:pPr algn="l" latinLnBrk="0" marL="146304" indent="-146304">
-              <a:lnSpc>
-                <a:spcPct val="100000"/>
-              </a:lnSpc>
-              <a:spcBef>
-                <a:spcPts val="0"/>
-              </a:spcBef>
-              <a:spcAft>
-                <a:spcPts val="0"/>
-              </a:spcAft>
-              <a:buClr>
-                <a:srgbClr val="C0612C"/>
-              </a:buClr>
-              <a:buFont typeface="Arial"/>
-              <a:buChar char="•"/>
-            </a:pPr>
-            <a:r>
-              <a:rPr sz="1100" b="0">
-                <a:solidFill>
-                  <a:srgbClr val="35424F"/>
-                </a:solidFill>
-                <a:latin typeface="Microsoft YaHei"/>
-                <a:ea typeface="Microsoft YaHei"/>
-                <a:cs typeface="Microsoft YaHei"/>
-              </a:rPr>
-              <a:t>换芯片 = 照这四个接口写一个后端 + 填一张硬件说明卡</a:t>
-            </a:r>
-          </a:p>
-        </p:txBody>
-      </p:sp>
-      <p:sp>
-        <p:nvSpPr>
-          <p:cNvPr id="20" name="Rounded Rectangle 19"/>
+              <a:t>　数字待补</a:t>
+            </a:r>
+          </a:p>
+        </p:txBody>
+      </p:sp>
+      <p:sp>
+        <p:nvSpPr>
+          <p:cNvPr id="26" name="Rectangle 25"/>
           <p:cNvSpPr/>
           <p:nvPr/>
         </p:nvSpPr>
         <p:spPr>
           <a:xfrm>
-            <a:off x="786384" y="5047488"/>
-            <a:ext cx="2286000" cy="274320"/>
-          </a:xfrm>
-          <a:prstGeom prst="roundRect">
-            <a:avLst>
-              <a:gd name="adj" fmla="val 50000"/>
-            </a:avLst>
+            <a:off x="6135624" y="2688336"/>
+            <a:ext cx="2552547" cy="1188720"/>
+          </a:xfrm>
+          <a:prstGeom prst="rect">
+            <a:avLst/>
           </a:prstGeom>
           <a:solidFill>
-            <a:srgbClr val="F6F7F9"/>
+            <a:srgbClr val="FFFFFF"/>
           </a:solidFill>
           <a:ln w="9525">
             <a:solidFill>
@@ -4710,43 +4814,14 @@
       </p:sp>
       <p:sp>
         <p:nvSpPr>
-          <p:cNvPr id="21" name="Oval 20"/>
-          <p:cNvSpPr/>
-          <p:nvPr/>
-        </p:nvSpPr>
-        <p:spPr>
-          <a:xfrm>
-            <a:off x="886968" y="5129783"/>
-            <a:ext cx="109728" cy="109728"/>
-          </a:xfrm>
-          <a:prstGeom prst="ellipse">
-            <a:avLst/>
-          </a:prstGeom>
-          <a:solidFill>
-            <a:srgbClr val="C0612C"/>
-          </a:solidFill>
-          <a:ln>
-            <a:noFill/>
-          </a:ln>
-        </p:spPr>
-        <p:txBody>
-          <a:bodyPr rtlCol="0" anchor="ctr"/>
-          <a:lstStyle/>
-          <a:p>
-            <a:pPr algn="ctr"/>
-          </a:p>
-        </p:txBody>
-      </p:sp>
-      <p:sp>
-        <p:nvSpPr>
-          <p:cNvPr id="22" name="TextBox 21"/>
+          <p:cNvPr id="27" name="TextBox 26"/>
           <p:cNvSpPr txBox="1"/>
           <p:nvPr/>
         </p:nvSpPr>
         <p:spPr>
           <a:xfrm>
-            <a:off x="1060704" y="5047488"/>
-            <a:ext cx="1993392" cy="274320"/>
+            <a:off x="6135624" y="2926080"/>
+            <a:ext cx="2552547" cy="457200"/>
           </a:xfrm>
           <a:prstGeom prst="rect">
             <a:avLst/>
@@ -4759,7 +4834,7 @@
           </a:bodyPr>
           <a:lstStyle/>
           <a:p>
-            <a:pPr algn="l" latinLnBrk="0">
+            <a:pPr algn="ctr" latinLnBrk="0">
               <a:lnSpc>
                 <a:spcPct val="100000"/>
               </a:lnSpc>
@@ -4771,7 +4846,54 @@
               </a:spcAft>
             </a:pPr>
             <a:r>
-              <a:rPr sz="1050" b="0">
+              <a:rPr sz="2800" b="1">
+                <a:solidFill>
+                  <a:srgbClr val="C5CCD4"/>
+                </a:solidFill>
+                <a:latin typeface="Arial"/>
+                <a:ea typeface="Microsoft YaHei"/>
+                <a:cs typeface="Microsoft YaHei"/>
+              </a:rPr>
+              <a:t>—</a:t>
+            </a:r>
+          </a:p>
+        </p:txBody>
+      </p:sp>
+      <p:sp>
+        <p:nvSpPr>
+          <p:cNvPr id="28" name="TextBox 27"/>
+          <p:cNvSpPr txBox="1"/>
+          <p:nvPr/>
+        </p:nvSpPr>
+        <p:spPr>
+          <a:xfrm>
+            <a:off x="6135624" y="3438144"/>
+            <a:ext cx="2552547" cy="274320"/>
+          </a:xfrm>
+          <a:prstGeom prst="rect">
+            <a:avLst/>
+          </a:prstGeom>
+          <a:noFill/>
+        </p:spPr>
+        <p:txBody>
+          <a:bodyPr wrap="square" anchor="ctr" lIns="0" tIns="0" rIns="0" bIns="0">
+            <a:noAutofit/>
+          </a:bodyPr>
+          <a:lstStyle/>
+          <a:p>
+            <a:pPr algn="ctr" latinLnBrk="0">
+              <a:lnSpc>
+                <a:spcPct val="100000"/>
+              </a:lnSpc>
+              <a:spcBef>
+                <a:spcPts val="0"/>
+              </a:spcBef>
+              <a:spcAft>
+                <a:spcPts val="0"/>
+              </a:spcAft>
+            </a:pPr>
+            <a:r>
+              <a:rPr sz="1100" b="0">
                 <a:solidFill>
                   <a:srgbClr val="35424F"/>
                 </a:solidFill>
@@ -4779,29 +4901,27 @@
                 <a:ea typeface="Microsoft YaHei"/>
                 <a:cs typeface="Microsoft YaHei"/>
               </a:rPr>
-              <a:t>没有硬件也能跑通整条闭环</a:t>
-            </a:r>
-          </a:p>
-        </p:txBody>
-      </p:sp>
-      <p:sp>
-        <p:nvSpPr>
-          <p:cNvPr id="23" name="Rounded Rectangle 22"/>
+              <a:t>已达标算子数</a:t>
+            </a:r>
+          </a:p>
+        </p:txBody>
+      </p:sp>
+      <p:sp>
+        <p:nvSpPr>
+          <p:cNvPr id="29" name="Rectangle 28"/>
           <p:cNvSpPr/>
           <p:nvPr/>
         </p:nvSpPr>
         <p:spPr>
           <a:xfrm>
-            <a:off x="3182112" y="5047488"/>
-            <a:ext cx="1417320" cy="274320"/>
-          </a:xfrm>
-          <a:prstGeom prst="roundRect">
-            <a:avLst>
-              <a:gd name="adj" fmla="val 50000"/>
-            </a:avLst>
+            <a:off x="8852763" y="2688336"/>
+            <a:ext cx="2552547" cy="1188720"/>
+          </a:xfrm>
+          <a:prstGeom prst="rect">
+            <a:avLst/>
           </a:prstGeom>
           <a:solidFill>
-            <a:srgbClr val="F6F7F9"/>
+            <a:srgbClr val="FFFFFF"/>
           </a:solidFill>
           <a:ln w="9525">
             <a:solidFill>
@@ -4819,43 +4939,14 @@
       </p:sp>
       <p:sp>
         <p:nvSpPr>
-          <p:cNvPr id="24" name="Oval 23"/>
-          <p:cNvSpPr/>
-          <p:nvPr/>
-        </p:nvSpPr>
-        <p:spPr>
-          <a:xfrm>
-            <a:off x="3282696" y="5129783"/>
-            <a:ext cx="109728" cy="109728"/>
-          </a:xfrm>
-          <a:prstGeom prst="ellipse">
-            <a:avLst/>
-          </a:prstGeom>
-          <a:solidFill>
-            <a:srgbClr val="C0612C"/>
-          </a:solidFill>
-          <a:ln>
-            <a:noFill/>
-          </a:ln>
-        </p:spPr>
-        <p:txBody>
-          <a:bodyPr rtlCol="0" anchor="ctr"/>
-          <a:lstStyle/>
-          <a:p>
-            <a:pPr algn="ctr"/>
-          </a:p>
-        </p:txBody>
-      </p:sp>
-      <p:sp>
-        <p:nvSpPr>
-          <p:cNvPr id="25" name="TextBox 24"/>
+          <p:cNvPr id="30" name="TextBox 29"/>
           <p:cNvSpPr txBox="1"/>
           <p:nvPr/>
         </p:nvSpPr>
         <p:spPr>
           <a:xfrm>
-            <a:off x="3456432" y="5047488"/>
-            <a:ext cx="1124712" cy="274320"/>
+            <a:off x="8852763" y="2926080"/>
+            <a:ext cx="2552547" cy="457200"/>
           </a:xfrm>
           <a:prstGeom prst="rect">
             <a:avLst/>
@@ -4868,7 +4959,7 @@
           </a:bodyPr>
           <a:lstStyle/>
           <a:p>
-            <a:pPr algn="l" latinLnBrk="0">
+            <a:pPr algn="ctr" latinLnBrk="0">
               <a:lnSpc>
                 <a:spcPct val="100000"/>
               </a:lnSpc>
@@ -4880,7 +4971,54 @@
               </a:spcAft>
             </a:pPr>
             <a:r>
-              <a:rPr sz="1050" b="0">
+              <a:rPr sz="2800" b="1">
+                <a:solidFill>
+                  <a:srgbClr val="C5CCD4"/>
+                </a:solidFill>
+                <a:latin typeface="Arial"/>
+                <a:ea typeface="Microsoft YaHei"/>
+                <a:cs typeface="Microsoft YaHei"/>
+              </a:rPr>
+              <a:t>—</a:t>
+            </a:r>
+          </a:p>
+        </p:txBody>
+      </p:sp>
+      <p:sp>
+        <p:nvSpPr>
+          <p:cNvPr id="31" name="TextBox 30"/>
+          <p:cNvSpPr txBox="1"/>
+          <p:nvPr/>
+        </p:nvSpPr>
+        <p:spPr>
+          <a:xfrm>
+            <a:off x="8852763" y="3438144"/>
+            <a:ext cx="2552547" cy="274320"/>
+          </a:xfrm>
+          <a:prstGeom prst="rect">
+            <a:avLst/>
+          </a:prstGeom>
+          <a:noFill/>
+        </p:spPr>
+        <p:txBody>
+          <a:bodyPr wrap="square" anchor="ctr" lIns="0" tIns="0" rIns="0" bIns="0">
+            <a:noAutofit/>
+          </a:bodyPr>
+          <a:lstStyle/>
+          <a:p>
+            <a:pPr algn="ctr" latinLnBrk="0">
+              <a:lnSpc>
+                <a:spcPct val="100000"/>
+              </a:lnSpc>
+              <a:spcBef>
+                <a:spcPts val="0"/>
+              </a:spcBef>
+              <a:spcAft>
+                <a:spcPts val="0"/>
+              </a:spcAft>
+            </a:pPr>
+            <a:r>
+              <a:rPr sz="1100" b="0">
                 <a:solidFill>
                   <a:srgbClr val="35424F"/>
                 </a:solidFill>
@@ -4888,29 +5026,27 @@
                 <a:ea typeface="Microsoft YaHei"/>
                 <a:cs typeface="Microsoft YaHei"/>
               </a:rPr>
-              <a:t>M100 真机已接</a:t>
-            </a:r>
-          </a:p>
-        </p:txBody>
-      </p:sp>
-      <p:sp>
-        <p:nvSpPr>
-          <p:cNvPr id="26" name="Rounded Rectangle 25"/>
+              <a:t>平均达标轮数</a:t>
+            </a:r>
+          </a:p>
+        </p:txBody>
+      </p:sp>
+      <p:sp>
+        <p:nvSpPr>
+          <p:cNvPr id="32" name="Rectangle 31"/>
           <p:cNvSpPr/>
           <p:nvPr/>
         </p:nvSpPr>
         <p:spPr>
           <a:xfrm>
-            <a:off x="4709160" y="5047488"/>
-            <a:ext cx="1097280" cy="274320"/>
-          </a:xfrm>
-          <a:prstGeom prst="roundRect">
-            <a:avLst>
-              <a:gd name="adj" fmla="val 50000"/>
-            </a:avLst>
+            <a:off x="6135624" y="4023360"/>
+            <a:ext cx="2552547" cy="1188720"/>
+          </a:xfrm>
+          <a:prstGeom prst="rect">
+            <a:avLst/>
           </a:prstGeom>
           <a:solidFill>
-            <a:srgbClr val="F6F7F9"/>
+            <a:srgbClr val="FFFFFF"/>
           </a:solidFill>
           <a:ln w="9525">
             <a:solidFill>
@@ -4928,23 +5064,119 @@
       </p:sp>
       <p:sp>
         <p:nvSpPr>
-          <p:cNvPr id="27" name="Oval 26"/>
+          <p:cNvPr id="33" name="TextBox 32"/>
+          <p:cNvSpPr txBox="1"/>
+          <p:nvPr/>
+        </p:nvSpPr>
+        <p:spPr>
+          <a:xfrm>
+            <a:off x="6135624" y="4261104"/>
+            <a:ext cx="2552547" cy="457200"/>
+          </a:xfrm>
+          <a:prstGeom prst="rect">
+            <a:avLst/>
+          </a:prstGeom>
+          <a:noFill/>
+        </p:spPr>
+        <p:txBody>
+          <a:bodyPr wrap="square" anchor="ctr" lIns="0" tIns="0" rIns="0" bIns="0">
+            <a:noAutofit/>
+          </a:bodyPr>
+          <a:lstStyle/>
+          <a:p>
+            <a:pPr algn="ctr" latinLnBrk="0">
+              <a:lnSpc>
+                <a:spcPct val="100000"/>
+              </a:lnSpc>
+              <a:spcBef>
+                <a:spcPts val="0"/>
+              </a:spcBef>
+              <a:spcAft>
+                <a:spcPts val="0"/>
+              </a:spcAft>
+            </a:pPr>
+            <a:r>
+              <a:rPr sz="2800" b="1">
+                <a:solidFill>
+                  <a:srgbClr val="C5CCD4"/>
+                </a:solidFill>
+                <a:latin typeface="Arial"/>
+                <a:ea typeface="Microsoft YaHei"/>
+                <a:cs typeface="Microsoft YaHei"/>
+              </a:rPr>
+              <a:t>—</a:t>
+            </a:r>
+          </a:p>
+        </p:txBody>
+      </p:sp>
+      <p:sp>
+        <p:nvSpPr>
+          <p:cNvPr id="34" name="TextBox 33"/>
+          <p:cNvSpPr txBox="1"/>
+          <p:nvPr/>
+        </p:nvSpPr>
+        <p:spPr>
+          <a:xfrm>
+            <a:off x="6135624" y="4773168"/>
+            <a:ext cx="2552547" cy="274320"/>
+          </a:xfrm>
+          <a:prstGeom prst="rect">
+            <a:avLst/>
+          </a:prstGeom>
+          <a:noFill/>
+        </p:spPr>
+        <p:txBody>
+          <a:bodyPr wrap="square" anchor="ctr" lIns="0" tIns="0" rIns="0" bIns="0">
+            <a:noAutofit/>
+          </a:bodyPr>
+          <a:lstStyle/>
+          <a:p>
+            <a:pPr algn="ctr" latinLnBrk="0">
+              <a:lnSpc>
+                <a:spcPct val="100000"/>
+              </a:lnSpc>
+              <a:spcBef>
+                <a:spcPts val="0"/>
+              </a:spcBef>
+              <a:spcAft>
+                <a:spcPts val="0"/>
+              </a:spcAft>
+            </a:pPr>
+            <a:r>
+              <a:rPr sz="1100" b="0">
+                <a:solidFill>
+                  <a:srgbClr val="35424F"/>
+                </a:solidFill>
+                <a:latin typeface="Microsoft YaHei"/>
+                <a:ea typeface="Microsoft YaHei"/>
+                <a:cs typeface="Microsoft YaHei"/>
+              </a:rPr>
+              <a:t>相对基线加速</a:t>
+            </a:r>
+          </a:p>
+        </p:txBody>
+      </p:sp>
+      <p:sp>
+        <p:nvSpPr>
+          <p:cNvPr id="35" name="Rectangle 34"/>
           <p:cNvSpPr/>
           <p:nvPr/>
         </p:nvSpPr>
         <p:spPr>
           <a:xfrm>
-            <a:off x="4809744" y="5129783"/>
-            <a:ext cx="109728" cy="109728"/>
-          </a:xfrm>
-          <a:prstGeom prst="ellipse">
+            <a:off x="8852763" y="4023360"/>
+            <a:ext cx="2552547" cy="1188720"/>
+          </a:xfrm>
+          <a:prstGeom prst="rect">
             <a:avLst/>
           </a:prstGeom>
           <a:solidFill>
-            <a:srgbClr val="8C96A1"/>
+            <a:srgbClr val="FFFFFF"/>
           </a:solidFill>
-          <a:ln>
-            <a:noFill/>
+          <a:ln w="9525">
+            <a:solidFill>
+              <a:srgbClr val="DDE2E7"/>
+            </a:solidFill>
           </a:ln>
         </p:spPr>
         <p:txBody>
@@ -4957,14 +5189,108 @@
       </p:sp>
       <p:sp>
         <p:nvSpPr>
-          <p:cNvPr id="28" name="TextBox 27"/>
+          <p:cNvPr id="36" name="TextBox 35"/>
           <p:cNvSpPr txBox="1"/>
           <p:nvPr/>
         </p:nvSpPr>
         <p:spPr>
           <a:xfrm>
-            <a:off x="4983480" y="5047488"/>
-            <a:ext cx="804671" cy="274320"/>
+            <a:off x="8852763" y="4261104"/>
+            <a:ext cx="2552547" cy="457200"/>
+          </a:xfrm>
+          <a:prstGeom prst="rect">
+            <a:avLst/>
+          </a:prstGeom>
+          <a:noFill/>
+        </p:spPr>
+        <p:txBody>
+          <a:bodyPr wrap="square" anchor="ctr" lIns="0" tIns="0" rIns="0" bIns="0">
+            <a:noAutofit/>
+          </a:bodyPr>
+          <a:lstStyle/>
+          <a:p>
+            <a:pPr algn="ctr" latinLnBrk="0">
+              <a:lnSpc>
+                <a:spcPct val="100000"/>
+              </a:lnSpc>
+              <a:spcBef>
+                <a:spcPts val="0"/>
+              </a:spcBef>
+              <a:spcAft>
+                <a:spcPts val="0"/>
+              </a:spcAft>
+            </a:pPr>
+            <a:r>
+              <a:rPr sz="2800" b="1">
+                <a:solidFill>
+                  <a:srgbClr val="C5CCD4"/>
+                </a:solidFill>
+                <a:latin typeface="Arial"/>
+                <a:ea typeface="Microsoft YaHei"/>
+                <a:cs typeface="Microsoft YaHei"/>
+              </a:rPr>
+              <a:t>—</a:t>
+            </a:r>
+          </a:p>
+        </p:txBody>
+      </p:sp>
+      <p:sp>
+        <p:nvSpPr>
+          <p:cNvPr id="37" name="TextBox 36"/>
+          <p:cNvSpPr txBox="1"/>
+          <p:nvPr/>
+        </p:nvSpPr>
+        <p:spPr>
+          <a:xfrm>
+            <a:off x="8852763" y="4773168"/>
+            <a:ext cx="2552547" cy="274320"/>
+          </a:xfrm>
+          <a:prstGeom prst="rect">
+            <a:avLst/>
+          </a:prstGeom>
+          <a:noFill/>
+        </p:spPr>
+        <p:txBody>
+          <a:bodyPr wrap="square" anchor="ctr" lIns="0" tIns="0" rIns="0" bIns="0">
+            <a:noAutofit/>
+          </a:bodyPr>
+          <a:lstStyle/>
+          <a:p>
+            <a:pPr algn="ctr" latinLnBrk="0">
+              <a:lnSpc>
+                <a:spcPct val="100000"/>
+              </a:lnSpc>
+              <a:spcBef>
+                <a:spcPts val="0"/>
+              </a:spcBef>
+              <a:spcAft>
+                <a:spcPts val="0"/>
+              </a:spcAft>
+            </a:pPr>
+            <a:r>
+              <a:rPr sz="1100" b="0">
+                <a:solidFill>
+                  <a:srgbClr val="35424F"/>
+                </a:solidFill>
+                <a:latin typeface="Microsoft YaHei"/>
+                <a:ea typeface="Microsoft YaHei"/>
+                <a:cs typeface="Microsoft YaHei"/>
+              </a:rPr>
+              <a:t>理论上限达成率</a:t>
+            </a:r>
+          </a:p>
+        </p:txBody>
+      </p:sp>
+      <p:sp>
+        <p:nvSpPr>
+          <p:cNvPr id="38" name="TextBox 37"/>
+          <p:cNvSpPr txBox="1"/>
+          <p:nvPr/>
+        </p:nvSpPr>
+        <p:spPr>
+          <a:xfrm>
+            <a:off x="6135624" y="5431536"/>
+            <a:ext cx="5269687" cy="274320"/>
           </a:xfrm>
           <a:prstGeom prst="rect">
             <a:avLst/>
@@ -4991,58 +5317,27 @@
             <a:r>
               <a:rPr sz="1050" b="0">
                 <a:solidFill>
-                  <a:srgbClr val="35424F"/>
+                  <a:srgbClr val="66727F"/>
                 </a:solidFill>
                 <a:latin typeface="Microsoft YaHei"/>
                 <a:ea typeface="Microsoft YaHei"/>
                 <a:cs typeface="Microsoft YaHei"/>
               </a:rPr>
-              <a:t>P800 待接</a:t>
-            </a:r>
-          </a:p>
-        </p:txBody>
-      </p:sp>
-      <p:sp>
-        <p:nvSpPr>
-          <p:cNvPr id="29" name="Rectangle 28"/>
-          <p:cNvSpPr/>
-          <p:nvPr/>
-        </p:nvSpPr>
-        <p:spPr>
-          <a:xfrm>
-            <a:off x="6233007" y="3785615"/>
-            <a:ext cx="5410047" cy="1645920"/>
-          </a:xfrm>
-          <a:prstGeom prst="rect">
-            <a:avLst/>
-          </a:prstGeom>
-          <a:solidFill>
-            <a:srgbClr val="F6F7F9"/>
-          </a:solidFill>
-          <a:ln w="9525">
-            <a:solidFill>
-              <a:srgbClr val="C5CCD4"/>
-            </a:solidFill>
-          </a:ln>
-        </p:spPr>
-        <p:txBody>
-          <a:bodyPr rtlCol="0" anchor="ctr"/>
-          <a:lstStyle/>
-          <a:p>
-            <a:pPr algn="ctr"/>
-          </a:p>
-        </p:txBody>
-      </p:sp>
-      <p:sp>
-        <p:nvSpPr>
-          <p:cNvPr id="30" name="TextBox 29"/>
+              <a:t>口径：真机、生产形状上的实测</a:t>
+            </a:r>
+          </a:p>
+        </p:txBody>
+      </p:sp>
+      <p:sp>
+        <p:nvSpPr>
+          <p:cNvPr id="39" name="TextBox 38"/>
           <p:cNvSpPr txBox="1"/>
           <p:nvPr/>
         </p:nvSpPr>
         <p:spPr>
           <a:xfrm>
-            <a:off x="6470751" y="3931920"/>
-            <a:ext cx="4952847" cy="292608"/>
+            <a:off x="548640" y="6382512"/>
+            <a:ext cx="9905695" cy="256032"/>
           </a:xfrm>
           <a:prstGeom prst="rect">
             <a:avLst/>
@@ -5067,408 +5362,6 @@
               </a:spcAft>
             </a:pPr>
             <a:r>
-              <a:rPr sz="1400" b="1">
-                <a:solidFill>
-                  <a:srgbClr val="16202A"/>
-                </a:solidFill>
-                <a:latin typeface="Microsoft YaHei"/>
-                <a:ea typeface="Microsoft YaHei"/>
-                <a:cs typeface="Microsoft YaHei"/>
-              </a:rPr>
-              <a:t>两条纪律</a:t>
-            </a:r>
-            <a:r>
-              <a:rPr sz="1200" b="1">
-                <a:solidFill>
-                  <a:srgbClr val="66727F"/>
-                </a:solidFill>
-                <a:latin typeface="Microsoft YaHei"/>
-                <a:ea typeface="Microsoft YaHei"/>
-                <a:cs typeface="Microsoft YaHei"/>
-              </a:rPr>
-              <a:t>　怎么保证收益是真的</a:t>
-            </a:r>
-          </a:p>
-        </p:txBody>
-      </p:sp>
-      <p:sp>
-        <p:nvSpPr>
-          <p:cNvPr id="31" name="Oval 30"/>
-          <p:cNvSpPr/>
-          <p:nvPr/>
-        </p:nvSpPr>
-        <p:spPr>
-          <a:xfrm>
-            <a:off x="6470751" y="4334255"/>
-            <a:ext cx="256032" cy="256032"/>
-          </a:xfrm>
-          <a:prstGeom prst="ellipse">
-            <a:avLst/>
-          </a:prstGeom>
-          <a:solidFill>
-            <a:srgbClr val="C0612C"/>
-          </a:solidFill>
-          <a:ln>
-            <a:noFill/>
-          </a:ln>
-        </p:spPr>
-        <p:txBody>
-          <a:bodyPr rtlCol="0" anchor="ctr" wrap="square" lIns="0" tIns="0" rIns="0" bIns="0">
-            <a:noAutofit/>
-          </a:bodyPr>
-          <a:lstStyle/>
-          <a:p>
-            <a:pPr algn="ctr" latinLnBrk="0">
-              <a:lnSpc>
-                <a:spcPct val="100000"/>
-              </a:lnSpc>
-              <a:spcBef>
-                <a:spcPts val="0"/>
-              </a:spcBef>
-              <a:spcAft>
-                <a:spcPts val="0"/>
-              </a:spcAft>
-            </a:pPr>
-            <a:r>
-              <a:rPr sz="1050" b="1">
-                <a:solidFill>
-                  <a:srgbClr val="FFFFFF"/>
-                </a:solidFill>
-                <a:latin typeface="Arial"/>
-                <a:ea typeface="Microsoft YaHei"/>
-                <a:cs typeface="Microsoft YaHei"/>
-              </a:rPr>
-              <a:t>1</a:t>
-            </a:r>
-          </a:p>
-        </p:txBody>
-      </p:sp>
-      <p:sp>
-        <p:nvSpPr>
-          <p:cNvPr id="32" name="TextBox 31"/>
-          <p:cNvSpPr txBox="1"/>
-          <p:nvPr/>
-        </p:nvSpPr>
-        <p:spPr>
-          <a:xfrm>
-            <a:off x="6818223" y="4297679"/>
-            <a:ext cx="4587087" cy="420624"/>
-          </a:xfrm>
-          <a:prstGeom prst="rect">
-            <a:avLst/>
-          </a:prstGeom>
-          <a:noFill/>
-        </p:spPr>
-        <p:txBody>
-          <a:bodyPr wrap="square" anchor="ctr" lIns="0" tIns="0" rIns="0" bIns="0">
-            <a:noAutofit/>
-          </a:bodyPr>
-          <a:lstStyle/>
-          <a:p>
-            <a:pPr algn="l" latinLnBrk="0">
-              <a:lnSpc>
-                <a:spcPct val="100000"/>
-              </a:lnSpc>
-              <a:spcBef>
-                <a:spcPts val="0"/>
-              </a:spcBef>
-              <a:spcAft>
-                <a:spcPts val="200"/>
-              </a:spcAft>
-            </a:pPr>
-            <a:r>
-              <a:rPr sz="1150" b="1">
-                <a:solidFill>
-                  <a:srgbClr val="16202A"/>
-                </a:solidFill>
-                <a:latin typeface="Microsoft YaHei"/>
-                <a:ea typeface="Microsoft YaHei"/>
-                <a:cs typeface="Microsoft YaHei"/>
-              </a:rPr>
-              <a:t>精度只认 CPU 参考实现</a:t>
-            </a:r>
-          </a:p>
-          <a:p>
-            <a:pPr algn="l" latinLnBrk="0">
-              <a:lnSpc>
-                <a:spcPct val="100000"/>
-              </a:lnSpc>
-              <a:spcBef>
-                <a:spcPts val="0"/>
-              </a:spcBef>
-              <a:spcAft>
-                <a:spcPts val="0"/>
-              </a:spcAft>
-            </a:pPr>
-            <a:r>
-              <a:rPr sz="1050" b="0">
-                <a:solidFill>
-                  <a:srgbClr val="35424F"/>
-                </a:solidFill>
-                <a:latin typeface="Microsoft YaHei"/>
-                <a:ea typeface="Microsoft YaHei"/>
-                <a:cs typeface="Microsoft YaHei"/>
-              </a:rPr>
-              <a:t>绝不拿 CUDA 当标准；精度不过关，就不看性能</a:t>
-            </a:r>
-          </a:p>
-        </p:txBody>
-      </p:sp>
-      <p:sp>
-        <p:nvSpPr>
-          <p:cNvPr id="33" name="Oval 32"/>
-          <p:cNvSpPr/>
-          <p:nvPr/>
-        </p:nvSpPr>
-        <p:spPr>
-          <a:xfrm>
-            <a:off x="6470751" y="4809743"/>
-            <a:ext cx="256032" cy="256032"/>
-          </a:xfrm>
-          <a:prstGeom prst="ellipse">
-            <a:avLst/>
-          </a:prstGeom>
-          <a:solidFill>
-            <a:srgbClr val="C0612C"/>
-          </a:solidFill>
-          <a:ln>
-            <a:noFill/>
-          </a:ln>
-        </p:spPr>
-        <p:txBody>
-          <a:bodyPr rtlCol="0" anchor="ctr" wrap="square" lIns="0" tIns="0" rIns="0" bIns="0">
-            <a:noAutofit/>
-          </a:bodyPr>
-          <a:lstStyle/>
-          <a:p>
-            <a:pPr algn="ctr" latinLnBrk="0">
-              <a:lnSpc>
-                <a:spcPct val="100000"/>
-              </a:lnSpc>
-              <a:spcBef>
-                <a:spcPts val="0"/>
-              </a:spcBef>
-              <a:spcAft>
-                <a:spcPts val="0"/>
-              </a:spcAft>
-            </a:pPr>
-            <a:r>
-              <a:rPr sz="1050" b="1">
-                <a:solidFill>
-                  <a:srgbClr val="FFFFFF"/>
-                </a:solidFill>
-                <a:latin typeface="Arial"/>
-                <a:ea typeface="Microsoft YaHei"/>
-                <a:cs typeface="Microsoft YaHei"/>
-              </a:rPr>
-              <a:t>2</a:t>
-            </a:r>
-          </a:p>
-        </p:txBody>
-      </p:sp>
-      <p:sp>
-        <p:nvSpPr>
-          <p:cNvPr id="34" name="TextBox 33"/>
-          <p:cNvSpPr txBox="1"/>
-          <p:nvPr/>
-        </p:nvSpPr>
-        <p:spPr>
-          <a:xfrm>
-            <a:off x="6818223" y="4773167"/>
-            <a:ext cx="4587087" cy="420624"/>
-          </a:xfrm>
-          <a:prstGeom prst="rect">
-            <a:avLst/>
-          </a:prstGeom>
-          <a:noFill/>
-        </p:spPr>
-        <p:txBody>
-          <a:bodyPr wrap="square" anchor="ctr" lIns="0" tIns="0" rIns="0" bIns="0">
-            <a:noAutofit/>
-          </a:bodyPr>
-          <a:lstStyle/>
-          <a:p>
-            <a:pPr algn="l" latinLnBrk="0">
-              <a:lnSpc>
-                <a:spcPct val="100000"/>
-              </a:lnSpc>
-              <a:spcBef>
-                <a:spcPts val="0"/>
-              </a:spcBef>
-              <a:spcAft>
-                <a:spcPts val="200"/>
-              </a:spcAft>
-            </a:pPr>
-            <a:r>
-              <a:rPr sz="1150" b="1">
-                <a:solidFill>
-                  <a:srgbClr val="16202A"/>
-                </a:solidFill>
-                <a:latin typeface="Microsoft YaHei"/>
-                <a:ea typeface="Microsoft YaHei"/>
-                <a:cs typeface="Microsoft YaHei"/>
-              </a:rPr>
-              <a:t>收益只认真机实测</a:t>
-            </a:r>
-          </a:p>
-          <a:p>
-            <a:pPr algn="l" latinLnBrk="0">
-              <a:lnSpc>
-                <a:spcPct val="100000"/>
-              </a:lnSpc>
-              <a:spcBef>
-                <a:spcPts val="0"/>
-              </a:spcBef>
-              <a:spcAft>
-                <a:spcPts val="0"/>
-              </a:spcAft>
-            </a:pPr>
-            <a:r>
-              <a:rPr sz="1050" b="0">
-                <a:solidFill>
-                  <a:srgbClr val="35424F"/>
-                </a:solidFill>
-                <a:latin typeface="Microsoft YaHei"/>
-                <a:ea typeface="Microsoft YaHei"/>
-                <a:cs typeface="Microsoft YaHei"/>
-              </a:rPr>
-              <a:t>模拟器只用来看清改动动了哪一块，两边对不上听真机的</a:t>
-            </a:r>
-          </a:p>
-        </p:txBody>
-      </p:sp>
-      <p:sp>
-        <p:nvSpPr>
-          <p:cNvPr id="35" name="Rectangle 34"/>
-          <p:cNvSpPr/>
-          <p:nvPr/>
-        </p:nvSpPr>
-        <p:spPr>
-          <a:xfrm>
-            <a:off x="548640" y="5596128"/>
-            <a:ext cx="11094415" cy="603504"/>
-          </a:xfrm>
-          <a:prstGeom prst="rect">
-            <a:avLst/>
-          </a:prstGeom>
-          <a:solidFill>
-            <a:srgbClr val="16202A"/>
-          </a:solidFill>
-          <a:ln>
-            <a:noFill/>
-          </a:ln>
-        </p:spPr>
-        <p:txBody>
-          <a:bodyPr rtlCol="0" anchor="ctr"/>
-          <a:lstStyle/>
-          <a:p>
-            <a:pPr algn="ctr"/>
-          </a:p>
-        </p:txBody>
-      </p:sp>
-      <p:sp>
-        <p:nvSpPr>
-          <p:cNvPr id="36" name="TextBox 35"/>
-          <p:cNvSpPr txBox="1"/>
-          <p:nvPr/>
-        </p:nvSpPr>
-        <p:spPr>
-          <a:xfrm>
-            <a:off x="822959" y="5596128"/>
-            <a:ext cx="10545775" cy="603504"/>
-          </a:xfrm>
-          <a:prstGeom prst="rect">
-            <a:avLst/>
-          </a:prstGeom>
-          <a:noFill/>
-        </p:spPr>
-        <p:txBody>
-          <a:bodyPr wrap="square" anchor="ctr" lIns="0" tIns="0" rIns="0" bIns="0">
-            <a:noAutofit/>
-          </a:bodyPr>
-          <a:lstStyle/>
-          <a:p>
-            <a:pPr algn="l" latinLnBrk="0">
-              <a:lnSpc>
-                <a:spcPct val="100000"/>
-              </a:lnSpc>
-              <a:spcBef>
-                <a:spcPts val="0"/>
-              </a:spcBef>
-              <a:spcAft>
-                <a:spcPts val="0"/>
-              </a:spcAft>
-            </a:pPr>
-            <a:r>
-              <a:rPr sz="1300" b="1">
-                <a:solidFill>
-                  <a:srgbClr val="FFFFFF"/>
-                </a:solidFill>
-                <a:latin typeface="Microsoft YaHei"/>
-                <a:ea typeface="Microsoft YaHei"/>
-                <a:cs typeface="Microsoft YaHei"/>
-              </a:rPr>
-              <a:t>对外接口　</a:t>
-            </a:r>
-            <a:r>
-              <a:rPr sz="1300" b="1">
-                <a:solidFill>
-                  <a:srgbClr val="F2B233"/>
-                </a:solidFill>
-                <a:latin typeface="Microsoft YaHei"/>
-                <a:ea typeface="Microsoft YaHei"/>
-                <a:cs typeface="Microsoft YaHei"/>
-              </a:rPr>
-              <a:t>operator-channel 透传通道</a:t>
-            </a:r>
-            <a:r>
-              <a:rPr sz="1300" b="1">
-                <a:solidFill>
-                  <a:srgbClr val="FFFFFF"/>
-                </a:solidFill>
-                <a:latin typeface="Microsoft YaHei"/>
-                <a:ea typeface="Microsoft YaHei"/>
-                <a:cs typeface="Microsoft YaHei"/>
-              </a:rPr>
-              <a:t>　m100-model-agent 管整模型接入与调优，xpugen 管单算子生成</a:t>
-            </a:r>
-          </a:p>
-        </p:txBody>
-      </p:sp>
-      <p:sp>
-        <p:nvSpPr>
-          <p:cNvPr id="37" name="TextBox 36"/>
-          <p:cNvSpPr txBox="1"/>
-          <p:nvPr/>
-        </p:nvSpPr>
-        <p:spPr>
-          <a:xfrm>
-            <a:off x="548640" y="6382512"/>
-            <a:ext cx="9905695" cy="256032"/>
-          </a:xfrm>
-          <a:prstGeom prst="rect">
-            <a:avLst/>
-          </a:prstGeom>
-          <a:noFill/>
-        </p:spPr>
-        <p:txBody>
-          <a:bodyPr wrap="square" anchor="ctr" lIns="0" tIns="0" rIns="0" bIns="0">
-            <a:noAutofit/>
-          </a:bodyPr>
-          <a:lstStyle/>
-          <a:p>
-            <a:pPr algn="l" latinLnBrk="0">
-              <a:lnSpc>
-                <a:spcPct val="100000"/>
-              </a:lnSpc>
-              <a:spcBef>
-                <a:spcPts val="0"/>
-              </a:spcBef>
-              <a:spcAft>
-                <a:spcPts val="0"/>
-              </a:spcAft>
-            </a:pPr>
-            <a:r>
               <a:rPr sz="1000" b="0">
                 <a:solidFill>
                   <a:srgbClr val="66727F"/>
@@ -5484,7 +5377,7 @@
       </p:sp>
       <p:sp>
         <p:nvSpPr>
-          <p:cNvPr id="38" name="TextBox 37"/>
+          <p:cNvPr id="40" name="TextBox 39"/>
           <p:cNvSpPr txBox="1"/>
           <p:nvPr/>
         </p:nvSpPr>

</xml_diff>

<commit_message>
Turn the xpugen workflow into the deck's loop ring
The five steps are one iteration, so they belong on the ring motif the Loop B page
already uses rather than in a vertical list. The ring takes the left two thirds and
the result area shrinks to a narrow column of four rows, each with a blank slot to
fill in once the numbers are measured.
</commit_message>
<xml_diff>
--- a/slides/xpugen_operator_agent.pptx
+++ b/slides/xpugen_operator_agent.pptx
@@ -551,7 +551,7 @@
                 <a:ea typeface="Microsoft YaHei"/>
                 <a:cs typeface="Microsoft YaHei"/>
               </a:rPr>
-              <a:t>左边是它怎么工作的。入口有两条：从一句需求开始，或者从现有实现反推出规格，第 0 轮直接拿现有实现当基线，后面在它上面改。</a:t>
+              <a:t>左边这个圈就是它一轮迭代。入口有两条：从一句需求开始，或者从现有实现反推出规格，第 0 轮直接拿现有实现当基线，后面在它上面改。</a:t>
             </a:r>
           </a:p>
           <a:p>
@@ -569,7 +569,7 @@
                 <a:ea typeface="Microsoft YaHei"/>
                 <a:cs typeface="Microsoft YaHei"/>
               </a:rPr>
-              <a:t>然后就是一轮轮迭代：LLM 照硬件说明卡写内核，编译跑起来，多种形状和精度逐一和 golden 对数值，再测延迟、跟理论上限比，最后把打分和慢在哪带进下一轮。最多八轮。</a:t>
+              <a:t>转一圈是这样：LLM 照硬件说明卡写内核，编译跑起来，多种形状和精度逐一和 golden 对数值，再测延迟、跟理论上限比，最后把打分和慢在哪带进下一轮。最多八轮。</a:t>
             </a:r>
           </a:p>
           <a:p>
@@ -3796,8 +3796,8 @@
         </p:nvSpPr>
         <p:spPr>
           <a:xfrm>
-            <a:off x="548640" y="1755648"/>
-            <a:ext cx="5029200" cy="292608"/>
+            <a:off x="548640" y="1682496"/>
+            <a:ext cx="7406640" cy="274320"/>
           </a:xfrm>
           <a:prstGeom prst="rect">
             <a:avLst/>
@@ -3822,40 +3822,813 @@
               </a:spcAft>
             </a:pPr>
             <a:r>
-              <a:rPr sz="1350" b="1">
-                <a:solidFill>
-                  <a:srgbClr val="16202A"/>
+              <a:rPr sz="1050" b="1">
+                <a:solidFill>
+                  <a:srgbClr val="C0612C"/>
+                </a:solidFill>
+                <a:latin typeface="Consolas"/>
+                <a:ea typeface="Microsoft YaHei"/>
+                <a:cs typeface="Microsoft YaHei"/>
+              </a:rPr>
+              <a:t>入口　</a:t>
+            </a:r>
+            <a:r>
+              <a:rPr sz="1050" b="0">
+                <a:solidFill>
+                  <a:srgbClr val="66727F"/>
                 </a:solidFill>
                 <a:latin typeface="Microsoft YaHei"/>
                 <a:ea typeface="Microsoft YaHei"/>
                 <a:cs typeface="Microsoft YaHei"/>
               </a:rPr>
-              <a:t>怎么工作</a:t>
-            </a:r>
-            <a:r>
-              <a:rPr sz="1050" b="0">
-                <a:solidFill>
-                  <a:srgbClr val="66727F"/>
+              <a:t>一句需求，或现有实现当基线</a:t>
+            </a:r>
+          </a:p>
+        </p:txBody>
+      </p:sp>
+      <p:sp>
+        <p:nvSpPr>
+          <p:cNvPr id="6" name="Oval 5"/>
+          <p:cNvSpPr/>
+          <p:nvPr/>
+        </p:nvSpPr>
+        <p:spPr>
+          <a:xfrm>
+            <a:off x="3419856" y="3374136"/>
+            <a:ext cx="1572768" cy="1572768"/>
+          </a:xfrm>
+          <a:prstGeom prst="ellipse">
+            <a:avLst/>
+          </a:prstGeom>
+          <a:solidFill>
+            <a:srgbClr val="F8EADF"/>
+          </a:solidFill>
+          <a:ln>
+            <a:noFill/>
+          </a:ln>
+        </p:spPr>
+        <p:txBody>
+          <a:bodyPr rtlCol="0" anchor="ctr"/>
+          <a:lstStyle/>
+          <a:p>
+            <a:pPr algn="ctr"/>
+          </a:p>
+        </p:txBody>
+      </p:sp>
+      <p:sp>
+        <p:nvSpPr>
+          <p:cNvPr id="7" name="TextBox 6"/>
+          <p:cNvSpPr txBox="1"/>
+          <p:nvPr/>
+        </p:nvSpPr>
+        <p:spPr>
+          <a:xfrm>
+            <a:off x="3419856" y="3374136"/>
+            <a:ext cx="1572768" cy="1572768"/>
+          </a:xfrm>
+          <a:prstGeom prst="rect">
+            <a:avLst/>
+          </a:prstGeom>
+          <a:noFill/>
+        </p:spPr>
+        <p:txBody>
+          <a:bodyPr wrap="square" anchor="ctr" lIns="0" tIns="0" rIns="0" bIns="0">
+            <a:noAutofit/>
+          </a:bodyPr>
+          <a:lstStyle/>
+          <a:p>
+            <a:pPr algn="ctr" latinLnBrk="0">
+              <a:lnSpc>
+                <a:spcPct val="100000"/>
+              </a:lnSpc>
+              <a:spcBef>
+                <a:spcPts val="0"/>
+              </a:spcBef>
+              <a:spcAft>
+                <a:spcPts val="300"/>
+              </a:spcAft>
+            </a:pPr>
+            <a:r>
+              <a:rPr sz="1100" b="1">
+                <a:solidFill>
+                  <a:srgbClr val="C0612C"/>
                 </a:solidFill>
                 <a:latin typeface="Microsoft YaHei"/>
                 <a:ea typeface="Microsoft YaHei"/>
                 <a:cs typeface="Microsoft YaHei"/>
               </a:rPr>
-              <a:t>　一个算子，最多 8 轮</a:t>
-            </a:r>
-          </a:p>
-        </p:txBody>
-      </p:sp>
-      <p:sp>
-        <p:nvSpPr>
-          <p:cNvPr id="6" name="TextBox 5"/>
+              <a:t>算子级闭环</a:t>
+            </a:r>
+          </a:p>
+          <a:p>
+            <a:pPr algn="ctr" latinLnBrk="0">
+              <a:lnSpc>
+                <a:spcPct val="100000"/>
+              </a:lnSpc>
+              <a:spcBef>
+                <a:spcPts val="0"/>
+              </a:spcBef>
+              <a:spcAft>
+                <a:spcPts val="0"/>
+              </a:spcAft>
+            </a:pPr>
+            <a:r>
+              <a:rPr sz="1300" b="1">
+                <a:solidFill>
+                  <a:srgbClr val="16202A"/>
+                </a:solidFill>
+                <a:latin typeface="Microsoft YaHei"/>
+                <a:ea typeface="Microsoft YaHei"/>
+                <a:cs typeface="Microsoft YaHei"/>
+              </a:rPr>
+              <a:t>一个算子</a:t>
+            </a:r>
+          </a:p>
+          <a:p>
+            <a:pPr algn="ctr" latinLnBrk="0">
+              <a:lnSpc>
+                <a:spcPct val="100000"/>
+              </a:lnSpc>
+              <a:spcBef>
+                <a:spcPts val="0"/>
+              </a:spcBef>
+              <a:spcAft>
+                <a:spcPts val="0"/>
+              </a:spcAft>
+            </a:pPr>
+            <a:r>
+              <a:rPr sz="1300" b="1">
+                <a:solidFill>
+                  <a:srgbClr val="16202A"/>
+                </a:solidFill>
+                <a:latin typeface="Microsoft YaHei"/>
+                <a:ea typeface="Microsoft YaHei"/>
+                <a:cs typeface="Microsoft YaHei"/>
+              </a:rPr>
+              <a:t>最多 8 轮</a:t>
+            </a:r>
+          </a:p>
+        </p:txBody>
+      </p:sp>
+      <p:sp>
+        <p:nvSpPr>
+          <p:cNvPr id="8" name="Rounded Rectangle 7"/>
+          <p:cNvSpPr/>
+          <p:nvPr/>
+        </p:nvSpPr>
+        <p:spPr>
+          <a:xfrm>
+            <a:off x="3337559" y="2066543"/>
+            <a:ext cx="1737360" cy="676656"/>
+          </a:xfrm>
+          <a:prstGeom prst="roundRect">
+            <a:avLst>
+              <a:gd name="adj" fmla="val 35000"/>
+            </a:avLst>
+          </a:prstGeom>
+          <a:solidFill>
+            <a:srgbClr val="FFFFFF"/>
+          </a:solidFill>
+          <a:ln w="15875">
+            <a:solidFill>
+              <a:srgbClr val="C0612C"/>
+            </a:solidFill>
+          </a:ln>
+        </p:spPr>
+        <p:txBody>
+          <a:bodyPr rtlCol="0" anchor="ctr" wrap="square" lIns="45720" tIns="18288" rIns="45720" bIns="18288">
+            <a:noAutofit/>
+          </a:bodyPr>
+          <a:lstStyle/>
+          <a:p>
+            <a:pPr algn="ctr" latinLnBrk="0">
+              <a:lnSpc>
+                <a:spcPct val="100000"/>
+              </a:lnSpc>
+              <a:spcBef>
+                <a:spcPts val="0"/>
+              </a:spcBef>
+              <a:spcAft>
+                <a:spcPts val="200"/>
+              </a:spcAft>
+            </a:pPr>
+            <a:r>
+              <a:rPr sz="1250" b="1">
+                <a:solidFill>
+                  <a:srgbClr val="C0612C"/>
+                </a:solidFill>
+                <a:latin typeface="Arial"/>
+                <a:ea typeface="Microsoft YaHei"/>
+                <a:cs typeface="Microsoft YaHei"/>
+              </a:rPr>
+              <a:t>1 </a:t>
+            </a:r>
+            <a:r>
+              <a:rPr sz="1250" b="1">
+                <a:solidFill>
+                  <a:srgbClr val="16202A"/>
+                </a:solidFill>
+                <a:latin typeface="Microsoft YaHei"/>
+                <a:ea typeface="Microsoft YaHei"/>
+                <a:cs typeface="Microsoft YaHei"/>
+              </a:rPr>
+              <a:t>生成</a:t>
+            </a:r>
+          </a:p>
+          <a:p>
+            <a:pPr algn="ctr" latinLnBrk="0">
+              <a:lnSpc>
+                <a:spcPct val="100000"/>
+              </a:lnSpc>
+              <a:spcBef>
+                <a:spcPts val="0"/>
+              </a:spcBef>
+              <a:spcAft>
+                <a:spcPts val="0"/>
+              </a:spcAft>
+            </a:pPr>
+            <a:r>
+              <a:rPr sz="1000" b="0">
+                <a:solidFill>
+                  <a:srgbClr val="66727F"/>
+                </a:solidFill>
+                <a:latin typeface="Microsoft YaHei"/>
+                <a:ea typeface="Microsoft YaHei"/>
+                <a:cs typeface="Microsoft YaHei"/>
+              </a:rPr>
+              <a:t>照硬件说明卡写内核</a:t>
+            </a:r>
+          </a:p>
+        </p:txBody>
+      </p:sp>
+      <p:sp>
+        <p:nvSpPr>
+          <p:cNvPr id="9" name="Rounded Rectangle 8"/>
+          <p:cNvSpPr/>
+          <p:nvPr/>
+        </p:nvSpPr>
+        <p:spPr>
+          <a:xfrm>
+            <a:off x="6033462" y="3279666"/>
+            <a:ext cx="1737360" cy="676656"/>
+          </a:xfrm>
+          <a:prstGeom prst="roundRect">
+            <a:avLst>
+              <a:gd name="adj" fmla="val 35000"/>
+            </a:avLst>
+          </a:prstGeom>
+          <a:solidFill>
+            <a:srgbClr val="FFFFFF"/>
+          </a:solidFill>
+          <a:ln w="15875">
+            <a:solidFill>
+              <a:srgbClr val="C0612C"/>
+            </a:solidFill>
+          </a:ln>
+        </p:spPr>
+        <p:txBody>
+          <a:bodyPr rtlCol="0" anchor="ctr" wrap="square" lIns="45720" tIns="18288" rIns="45720" bIns="18288">
+            <a:noAutofit/>
+          </a:bodyPr>
+          <a:lstStyle/>
+          <a:p>
+            <a:pPr algn="ctr" latinLnBrk="0">
+              <a:lnSpc>
+                <a:spcPct val="100000"/>
+              </a:lnSpc>
+              <a:spcBef>
+                <a:spcPts val="0"/>
+              </a:spcBef>
+              <a:spcAft>
+                <a:spcPts val="200"/>
+              </a:spcAft>
+            </a:pPr>
+            <a:r>
+              <a:rPr sz="1250" b="1">
+                <a:solidFill>
+                  <a:srgbClr val="C0612C"/>
+                </a:solidFill>
+                <a:latin typeface="Arial"/>
+                <a:ea typeface="Microsoft YaHei"/>
+                <a:cs typeface="Microsoft YaHei"/>
+              </a:rPr>
+              <a:t>2 </a:t>
+            </a:r>
+            <a:r>
+              <a:rPr sz="1250" b="1">
+                <a:solidFill>
+                  <a:srgbClr val="16202A"/>
+                </a:solidFill>
+                <a:latin typeface="Microsoft YaHei"/>
+                <a:ea typeface="Microsoft YaHei"/>
+                <a:cs typeface="Microsoft YaHei"/>
+              </a:rPr>
+              <a:t>编译</a:t>
+            </a:r>
+          </a:p>
+          <a:p>
+            <a:pPr algn="ctr" latinLnBrk="0">
+              <a:lnSpc>
+                <a:spcPct val="100000"/>
+              </a:lnSpc>
+              <a:spcBef>
+                <a:spcPts val="0"/>
+              </a:spcBef>
+              <a:spcAft>
+                <a:spcPts val="0"/>
+              </a:spcAft>
+            </a:pPr>
+            <a:r>
+              <a:rPr sz="1000" b="0">
+                <a:solidFill>
+                  <a:srgbClr val="66727F"/>
+                </a:solidFill>
+                <a:latin typeface="Microsoft YaHei"/>
+                <a:ea typeface="Microsoft YaHei"/>
+                <a:cs typeface="Microsoft YaHei"/>
+              </a:rPr>
+              <a:t>编译并拉起程序</a:t>
+            </a:r>
+          </a:p>
+        </p:txBody>
+      </p:sp>
+      <p:sp>
+        <p:nvSpPr>
+          <p:cNvPr id="10" name="Rounded Rectangle 9"/>
+          <p:cNvSpPr/>
+          <p:nvPr/>
+        </p:nvSpPr>
+        <p:spPr>
+          <a:xfrm>
+            <a:off x="5003719" y="5242541"/>
+            <a:ext cx="1737360" cy="676656"/>
+          </a:xfrm>
+          <a:prstGeom prst="roundRect">
+            <a:avLst>
+              <a:gd name="adj" fmla="val 35000"/>
+            </a:avLst>
+          </a:prstGeom>
+          <a:solidFill>
+            <a:srgbClr val="FFFFFF"/>
+          </a:solidFill>
+          <a:ln w="15875">
+            <a:solidFill>
+              <a:srgbClr val="C0612C"/>
+            </a:solidFill>
+          </a:ln>
+        </p:spPr>
+        <p:txBody>
+          <a:bodyPr rtlCol="0" anchor="ctr" wrap="square" lIns="45720" tIns="18288" rIns="45720" bIns="18288">
+            <a:noAutofit/>
+          </a:bodyPr>
+          <a:lstStyle/>
+          <a:p>
+            <a:pPr algn="ctr" latinLnBrk="0">
+              <a:lnSpc>
+                <a:spcPct val="100000"/>
+              </a:lnSpc>
+              <a:spcBef>
+                <a:spcPts val="0"/>
+              </a:spcBef>
+              <a:spcAft>
+                <a:spcPts val="200"/>
+              </a:spcAft>
+            </a:pPr>
+            <a:r>
+              <a:rPr sz="1250" b="1">
+                <a:solidFill>
+                  <a:srgbClr val="C0612C"/>
+                </a:solidFill>
+                <a:latin typeface="Arial"/>
+                <a:ea typeface="Microsoft YaHei"/>
+                <a:cs typeface="Microsoft YaHei"/>
+              </a:rPr>
+              <a:t>3 </a:t>
+            </a:r>
+            <a:r>
+              <a:rPr sz="1250" b="1">
+                <a:solidFill>
+                  <a:srgbClr val="16202A"/>
+                </a:solidFill>
+                <a:latin typeface="Microsoft YaHei"/>
+                <a:ea typeface="Microsoft YaHei"/>
+                <a:cs typeface="Microsoft YaHei"/>
+              </a:rPr>
+              <a:t>对数值</a:t>
+            </a:r>
+          </a:p>
+          <a:p>
+            <a:pPr algn="ctr" latinLnBrk="0">
+              <a:lnSpc>
+                <a:spcPct val="100000"/>
+              </a:lnSpc>
+              <a:spcBef>
+                <a:spcPts val="0"/>
+              </a:spcBef>
+              <a:spcAft>
+                <a:spcPts val="0"/>
+              </a:spcAft>
+            </a:pPr>
+            <a:r>
+              <a:rPr sz="1000" b="0">
+                <a:solidFill>
+                  <a:srgbClr val="66727F"/>
+                </a:solidFill>
+                <a:latin typeface="Microsoft YaHei"/>
+                <a:ea typeface="Microsoft YaHei"/>
+                <a:cs typeface="Microsoft YaHei"/>
+              </a:rPr>
+              <a:t>多形状多精度对 golden</a:t>
+            </a:r>
+          </a:p>
+        </p:txBody>
+      </p:sp>
+      <p:sp>
+        <p:nvSpPr>
+          <p:cNvPr id="11" name="Rounded Rectangle 10"/>
+          <p:cNvSpPr/>
+          <p:nvPr/>
+        </p:nvSpPr>
+        <p:spPr>
+          <a:xfrm>
+            <a:off x="1671400" y="5242541"/>
+            <a:ext cx="1737360" cy="676656"/>
+          </a:xfrm>
+          <a:prstGeom prst="roundRect">
+            <a:avLst>
+              <a:gd name="adj" fmla="val 35000"/>
+            </a:avLst>
+          </a:prstGeom>
+          <a:solidFill>
+            <a:srgbClr val="FFFFFF"/>
+          </a:solidFill>
+          <a:ln w="15875">
+            <a:solidFill>
+              <a:srgbClr val="C0612C"/>
+            </a:solidFill>
+          </a:ln>
+        </p:spPr>
+        <p:txBody>
+          <a:bodyPr rtlCol="0" anchor="ctr" wrap="square" lIns="45720" tIns="18288" rIns="45720" bIns="18288">
+            <a:noAutofit/>
+          </a:bodyPr>
+          <a:lstStyle/>
+          <a:p>
+            <a:pPr algn="ctr" latinLnBrk="0">
+              <a:lnSpc>
+                <a:spcPct val="100000"/>
+              </a:lnSpc>
+              <a:spcBef>
+                <a:spcPts val="0"/>
+              </a:spcBef>
+              <a:spcAft>
+                <a:spcPts val="200"/>
+              </a:spcAft>
+            </a:pPr>
+            <a:r>
+              <a:rPr sz="1250" b="1">
+                <a:solidFill>
+                  <a:srgbClr val="C0612C"/>
+                </a:solidFill>
+                <a:latin typeface="Arial"/>
+                <a:ea typeface="Microsoft YaHei"/>
+                <a:cs typeface="Microsoft YaHei"/>
+              </a:rPr>
+              <a:t>4 </a:t>
+            </a:r>
+            <a:r>
+              <a:rPr sz="1250" b="1">
+                <a:solidFill>
+                  <a:srgbClr val="16202A"/>
+                </a:solidFill>
+                <a:latin typeface="Microsoft YaHei"/>
+                <a:ea typeface="Microsoft YaHei"/>
+                <a:cs typeface="Microsoft YaHei"/>
+              </a:rPr>
+              <a:t>测性能</a:t>
+            </a:r>
+          </a:p>
+          <a:p>
+            <a:pPr algn="ctr" latinLnBrk="0">
+              <a:lnSpc>
+                <a:spcPct val="100000"/>
+              </a:lnSpc>
+              <a:spcBef>
+                <a:spcPts val="0"/>
+              </a:spcBef>
+              <a:spcAft>
+                <a:spcPts val="0"/>
+              </a:spcAft>
+            </a:pPr>
+            <a:r>
+              <a:rPr sz="1000" b="0">
+                <a:solidFill>
+                  <a:srgbClr val="66727F"/>
+                </a:solidFill>
+                <a:latin typeface="Microsoft YaHei"/>
+                <a:ea typeface="Microsoft YaHei"/>
+                <a:cs typeface="Microsoft YaHei"/>
+              </a:rPr>
+              <a:t>中位延迟 · 比理论上限</a:t>
+            </a:r>
+          </a:p>
+        </p:txBody>
+      </p:sp>
+      <p:sp>
+        <p:nvSpPr>
+          <p:cNvPr id="12" name="Rounded Rectangle 11"/>
+          <p:cNvSpPr/>
+          <p:nvPr/>
+        </p:nvSpPr>
+        <p:spPr>
+          <a:xfrm>
+            <a:off x="641657" y="3279666"/>
+            <a:ext cx="1737360" cy="676656"/>
+          </a:xfrm>
+          <a:prstGeom prst="roundRect">
+            <a:avLst>
+              <a:gd name="adj" fmla="val 35000"/>
+            </a:avLst>
+          </a:prstGeom>
+          <a:solidFill>
+            <a:srgbClr val="FFFFFF"/>
+          </a:solidFill>
+          <a:ln w="15875">
+            <a:solidFill>
+              <a:srgbClr val="C0612C"/>
+            </a:solidFill>
+          </a:ln>
+        </p:spPr>
+        <p:txBody>
+          <a:bodyPr rtlCol="0" anchor="ctr" wrap="square" lIns="45720" tIns="18288" rIns="45720" bIns="18288">
+            <a:noAutofit/>
+          </a:bodyPr>
+          <a:lstStyle/>
+          <a:p>
+            <a:pPr algn="ctr" latinLnBrk="0">
+              <a:lnSpc>
+                <a:spcPct val="100000"/>
+              </a:lnSpc>
+              <a:spcBef>
+                <a:spcPts val="0"/>
+              </a:spcBef>
+              <a:spcAft>
+                <a:spcPts val="200"/>
+              </a:spcAft>
+            </a:pPr>
+            <a:r>
+              <a:rPr sz="1250" b="1">
+                <a:solidFill>
+                  <a:srgbClr val="C0612C"/>
+                </a:solidFill>
+                <a:latin typeface="Arial"/>
+                <a:ea typeface="Microsoft YaHei"/>
+                <a:cs typeface="Microsoft YaHei"/>
+              </a:rPr>
+              <a:t>5 </a:t>
+            </a:r>
+            <a:r>
+              <a:rPr sz="1250" b="1">
+                <a:solidFill>
+                  <a:srgbClr val="16202A"/>
+                </a:solidFill>
+                <a:latin typeface="Microsoft YaHei"/>
+                <a:ea typeface="Microsoft YaHei"/>
+                <a:cs typeface="Microsoft YaHei"/>
+              </a:rPr>
+              <a:t>给反馈</a:t>
+            </a:r>
+          </a:p>
+          <a:p>
+            <a:pPr algn="ctr" latinLnBrk="0">
+              <a:lnSpc>
+                <a:spcPct val="100000"/>
+              </a:lnSpc>
+              <a:spcBef>
+                <a:spcPts val="0"/>
+              </a:spcBef>
+              <a:spcAft>
+                <a:spcPts val="0"/>
+              </a:spcAft>
+            </a:pPr>
+            <a:r>
+              <a:rPr sz="1000" b="0">
+                <a:solidFill>
+                  <a:srgbClr val="66727F"/>
+                </a:solidFill>
+                <a:latin typeface="Microsoft YaHei"/>
+                <a:ea typeface="Microsoft YaHei"/>
+                <a:cs typeface="Microsoft YaHei"/>
+              </a:rPr>
+              <a:t>打分 · 指出慢在哪</a:t>
+            </a:r>
+          </a:p>
+        </p:txBody>
+      </p:sp>
+      <p:sp>
+        <p:nvSpPr>
+          <p:cNvPr id="13" name="Arc 12"/>
+          <p:cNvSpPr/>
+          <p:nvPr/>
+        </p:nvSpPr>
+        <p:spPr>
+          <a:xfrm>
+            <a:off x="1371599" y="2404872"/>
+            <a:ext cx="5669280" cy="3511296"/>
+          </a:xfrm>
+          <a:prstGeom prst="arc">
+            <a:avLst>
+              <a:gd name="adj1" fmla="val 18010129"/>
+              <a:gd name="adj2" fmla="val 20263467"/>
+            </a:avLst>
+          </a:prstGeom>
+          <a:noFill/>
+          <a:ln w="19050">
+            <a:solidFill>
+              <a:srgbClr val="C0612C"/>
+            </a:solidFill>
+            <a:tailEnd type="triangle" w="med" len="med"/>
+          </a:ln>
+        </p:spPr>
+        <p:txBody>
+          <a:bodyPr rtlCol="0" anchor="ctr"/>
+          <a:lstStyle/>
+          <a:p>
+            <a:pPr algn="ctr"/>
+          </a:p>
+        </p:txBody>
+      </p:sp>
+      <p:sp>
+        <p:nvSpPr>
+          <p:cNvPr id="14" name="Arc 13"/>
+          <p:cNvSpPr/>
+          <p:nvPr/>
+        </p:nvSpPr>
+        <p:spPr>
+          <a:xfrm>
+            <a:off x="1371599" y="2404872"/>
+            <a:ext cx="5669280" cy="3511296"/>
+          </a:xfrm>
+          <a:prstGeom prst="arc">
+            <a:avLst>
+              <a:gd name="adj1" fmla="val 21452696"/>
+              <a:gd name="adj2" fmla="val 1386262"/>
+            </a:avLst>
+          </a:prstGeom>
+          <a:noFill/>
+          <a:ln w="19050">
+            <a:solidFill>
+              <a:srgbClr val="C0612C"/>
+            </a:solidFill>
+            <a:tailEnd type="triangle" w="med" len="med"/>
+          </a:ln>
+        </p:spPr>
+        <p:txBody>
+          <a:bodyPr rtlCol="0" anchor="ctr"/>
+          <a:lstStyle/>
+          <a:p>
+            <a:pPr algn="ctr"/>
+          </a:p>
+        </p:txBody>
+      </p:sp>
+      <p:sp>
+        <p:nvSpPr>
+          <p:cNvPr id="15" name="Arc 14"/>
+          <p:cNvSpPr/>
+          <p:nvPr/>
+        </p:nvSpPr>
+        <p:spPr>
+          <a:xfrm>
+            <a:off x="1371599" y="2404872"/>
+            <a:ext cx="5669280" cy="3511296"/>
+          </a:xfrm>
+          <a:prstGeom prst="arc">
+            <a:avLst>
+              <a:gd name="adj1" fmla="val 4048999"/>
+              <a:gd name="adj2" fmla="val 6751000"/>
+            </a:avLst>
+          </a:prstGeom>
+          <a:noFill/>
+          <a:ln w="19050">
+            <a:solidFill>
+              <a:srgbClr val="C0612C"/>
+            </a:solidFill>
+            <a:tailEnd type="triangle" w="med" len="med"/>
+          </a:ln>
+        </p:spPr>
+        <p:txBody>
+          <a:bodyPr rtlCol="0" anchor="ctr"/>
+          <a:lstStyle/>
+          <a:p>
+            <a:pPr algn="ctr"/>
+          </a:p>
+        </p:txBody>
+      </p:sp>
+      <p:sp>
+        <p:nvSpPr>
+          <p:cNvPr id="16" name="Arc 15"/>
+          <p:cNvSpPr/>
+          <p:nvPr/>
+        </p:nvSpPr>
+        <p:spPr>
+          <a:xfrm>
+            <a:off x="1371599" y="2404872"/>
+            <a:ext cx="5669280" cy="3511296"/>
+          </a:xfrm>
+          <a:prstGeom prst="arc">
+            <a:avLst>
+              <a:gd name="adj1" fmla="val 9413737"/>
+              <a:gd name="adj2" fmla="val 10947303"/>
+            </a:avLst>
+          </a:prstGeom>
+          <a:noFill/>
+          <a:ln w="19050">
+            <a:solidFill>
+              <a:srgbClr val="C0612C"/>
+            </a:solidFill>
+            <a:tailEnd type="triangle" w="med" len="med"/>
+          </a:ln>
+        </p:spPr>
+        <p:txBody>
+          <a:bodyPr rtlCol="0" anchor="ctr"/>
+          <a:lstStyle/>
+          <a:p>
+            <a:pPr algn="ctr"/>
+          </a:p>
+        </p:txBody>
+      </p:sp>
+      <p:sp>
+        <p:nvSpPr>
+          <p:cNvPr id="17" name="Arc 16"/>
+          <p:cNvSpPr/>
+          <p:nvPr/>
+        </p:nvSpPr>
+        <p:spPr>
+          <a:xfrm>
+            <a:off x="1371599" y="2404872"/>
+            <a:ext cx="5669280" cy="3511296"/>
+          </a:xfrm>
+          <a:prstGeom prst="arc">
+            <a:avLst>
+              <a:gd name="adj1" fmla="val 12136532"/>
+              <a:gd name="adj2" fmla="val 14389870"/>
+            </a:avLst>
+          </a:prstGeom>
+          <a:noFill/>
+          <a:ln w="19050">
+            <a:solidFill>
+              <a:srgbClr val="C0612C"/>
+            </a:solidFill>
+            <a:tailEnd type="triangle" w="med" len="med"/>
+          </a:ln>
+        </p:spPr>
+        <p:txBody>
+          <a:bodyPr rtlCol="0" anchor="ctr"/>
+          <a:lstStyle/>
+          <a:p>
+            <a:pPr algn="ctr"/>
+          </a:p>
+        </p:txBody>
+      </p:sp>
+      <p:sp>
+        <p:nvSpPr>
+          <p:cNvPr id="18" name="Rectangle 17"/>
+          <p:cNvSpPr/>
+          <p:nvPr/>
+        </p:nvSpPr>
+        <p:spPr>
+          <a:xfrm>
+            <a:off x="8321040" y="2066543"/>
+            <a:ext cx="3322015" cy="3849624"/>
+          </a:xfrm>
+          <a:prstGeom prst="rect">
+            <a:avLst/>
+          </a:prstGeom>
+          <a:solidFill>
+            <a:srgbClr val="F8EADF"/>
+          </a:solidFill>
+          <a:ln>
+            <a:noFill/>
+          </a:ln>
+        </p:spPr>
+        <p:txBody>
+          <a:bodyPr rtlCol="0" anchor="ctr"/>
+          <a:lstStyle/>
+          <a:p>
+            <a:pPr algn="ctr"/>
+          </a:p>
+        </p:txBody>
+      </p:sp>
+      <p:sp>
+        <p:nvSpPr>
+          <p:cNvPr id="19" name="TextBox 18"/>
           <p:cNvSpPr txBox="1"/>
           <p:nvPr/>
         </p:nvSpPr>
         <p:spPr>
           <a:xfrm>
-            <a:off x="548640" y="2066543"/>
-            <a:ext cx="5029200" cy="256032"/>
+            <a:off x="8558784" y="2212848"/>
+            <a:ext cx="2864815" cy="292608"/>
           </a:xfrm>
           <a:prstGeom prst="rect">
             <a:avLst/>
@@ -3880,63 +4653,133 @@
               </a:spcAft>
             </a:pPr>
             <a:r>
-              <a:rPr sz="1050" b="0">
-                <a:solidFill>
-                  <a:srgbClr val="66727F"/>
+              <a:rPr sz="1400" b="1">
+                <a:solidFill>
+                  <a:srgbClr val="16202A"/>
                 </a:solidFill>
                 <a:latin typeface="Microsoft YaHei"/>
                 <a:ea typeface="Microsoft YaHei"/>
                 <a:cs typeface="Microsoft YaHei"/>
               </a:rPr>
-              <a:t>入口：一句需求，或拿现有实现当第 0 轮基线</a:t>
-            </a:r>
-          </a:p>
-        </p:txBody>
-      </p:sp>
-      <p:cxnSp>
-        <p:nvCxnSpPr>
-          <p:cNvPr id="7" name="Connector 6"/>
-          <p:cNvCxnSpPr/>
-          <p:nvPr/>
-        </p:nvCxnSpPr>
-        <p:spPr>
-          <a:xfrm>
-            <a:off x="1161288" y="2587752"/>
-            <a:ext cx="0" cy="3090672"/>
-          </a:xfrm>
-          <a:prstGeom prst="line">
-            <a:avLst/>
-          </a:prstGeom>
-          <a:ln w="15875">
-            <a:solidFill>
-              <a:srgbClr val="C5CCD4"/>
-            </a:solidFill>
-          </a:ln>
-        </p:spPr>
-      </p:cxnSp>
-      <p:sp>
-        <p:nvSpPr>
-          <p:cNvPr id="8" name="Oval 7"/>
+              <a:t>效果</a:t>
+            </a:r>
+            <a:r>
+              <a:rPr sz="1050" b="0">
+                <a:solidFill>
+                  <a:srgbClr val="8C96A1"/>
+                </a:solidFill>
+                <a:latin typeface="Microsoft YaHei"/>
+                <a:ea typeface="Microsoft YaHei"/>
+                <a:cs typeface="Microsoft YaHei"/>
+              </a:rPr>
+              <a:t>　数字待补</a:t>
+            </a:r>
+          </a:p>
+        </p:txBody>
+      </p:sp>
+      <p:sp>
+        <p:nvSpPr>
+          <p:cNvPr id="20" name="Rectangle 19"/>
           <p:cNvSpPr/>
           <p:nvPr/>
         </p:nvSpPr>
         <p:spPr>
           <a:xfrm>
-            <a:off x="1005840" y="2432304"/>
-            <a:ext cx="310896" cy="310896"/>
-          </a:xfrm>
-          <a:prstGeom prst="ellipse">
+            <a:off x="8558784" y="2743200"/>
+            <a:ext cx="2846527" cy="582930"/>
+          </a:xfrm>
+          <a:prstGeom prst="rect">
             <a:avLst/>
           </a:prstGeom>
           <a:solidFill>
-            <a:srgbClr val="C0612C"/>
+            <a:srgbClr val="FFFFFF"/>
+          </a:solidFill>
+          <a:ln w="9525">
+            <a:solidFill>
+              <a:srgbClr val="DDE2E7"/>
+            </a:solidFill>
+          </a:ln>
+        </p:spPr>
+        <p:txBody>
+          <a:bodyPr rtlCol="0" anchor="ctr"/>
+          <a:lstStyle/>
+          <a:p>
+            <a:pPr algn="ctr"/>
+          </a:p>
+        </p:txBody>
+      </p:sp>
+      <p:sp>
+        <p:nvSpPr>
+          <p:cNvPr id="21" name="TextBox 20"/>
+          <p:cNvSpPr txBox="1"/>
+          <p:nvPr/>
+        </p:nvSpPr>
+        <p:spPr>
+          <a:xfrm>
+            <a:off x="8723376" y="2743200"/>
+            <a:ext cx="1913839" cy="582930"/>
+          </a:xfrm>
+          <a:prstGeom prst="rect">
+            <a:avLst/>
+          </a:prstGeom>
+          <a:noFill/>
+        </p:spPr>
+        <p:txBody>
+          <a:bodyPr wrap="square" anchor="ctr" lIns="0" tIns="0" rIns="0" bIns="0">
+            <a:noAutofit/>
+          </a:bodyPr>
+          <a:lstStyle/>
+          <a:p>
+            <a:pPr algn="l" latinLnBrk="0">
+              <a:lnSpc>
+                <a:spcPct val="100000"/>
+              </a:lnSpc>
+              <a:spcBef>
+                <a:spcPts val="0"/>
+              </a:spcBef>
+              <a:spcAft>
+                <a:spcPts val="0"/>
+              </a:spcAft>
+            </a:pPr>
+            <a:r>
+              <a:rPr sz="1150" b="0">
+                <a:solidFill>
+                  <a:srgbClr val="35424F"/>
+                </a:solidFill>
+                <a:latin typeface="Microsoft YaHei"/>
+                <a:ea typeface="Microsoft YaHei"/>
+                <a:cs typeface="Microsoft YaHei"/>
+              </a:rPr>
+              <a:t>已达标算子数</a:t>
+            </a:r>
+          </a:p>
+        </p:txBody>
+      </p:sp>
+      <p:sp>
+        <p:nvSpPr>
+          <p:cNvPr id="22" name="Rounded Rectangle 21"/>
+          <p:cNvSpPr/>
+          <p:nvPr/>
+        </p:nvSpPr>
+        <p:spPr>
+          <a:xfrm>
+            <a:off x="10472623" y="2852928"/>
+            <a:ext cx="768096" cy="363474"/>
+          </a:xfrm>
+          <a:prstGeom prst="roundRect">
+            <a:avLst>
+              <a:gd name="adj" fmla="val 30000"/>
+            </a:avLst>
+          </a:prstGeom>
+          <a:solidFill>
+            <a:srgbClr val="EEF1F4"/>
           </a:solidFill>
           <a:ln>
             <a:noFill/>
           </a:ln>
         </p:spPr>
         <p:txBody>
-          <a:bodyPr rtlCol="0" anchor="ctr" wrap="square" lIns="0" tIns="0" rIns="0" bIns="0">
+          <a:bodyPr rtlCol="0" anchor="ctr" wrap="square" tIns="36576" bIns="36576">
             <a:noAutofit/>
           </a:bodyPr>
           <a:lstStyle/>
@@ -3953,29 +4796,60 @@
               </a:spcAft>
             </a:pPr>
             <a:r>
-              <a:rPr sz="1100" b="1">
-                <a:solidFill>
-                  <a:srgbClr val="FFFFFF"/>
+              <a:rPr sz="1500" b="1">
+                <a:solidFill>
+                  <a:srgbClr val="8C96A1"/>
                 </a:solidFill>
                 <a:latin typeface="Arial"/>
                 <a:ea typeface="Microsoft YaHei"/>
                 <a:cs typeface="Microsoft YaHei"/>
               </a:rPr>
-              <a:t>1</a:t>
-            </a:r>
-          </a:p>
-        </p:txBody>
-      </p:sp>
-      <p:sp>
-        <p:nvSpPr>
-          <p:cNvPr id="9" name="TextBox 8"/>
+              <a:t>—</a:t>
+            </a:r>
+          </a:p>
+        </p:txBody>
+      </p:sp>
+      <p:sp>
+        <p:nvSpPr>
+          <p:cNvPr id="23" name="Rectangle 22"/>
+          <p:cNvSpPr/>
+          <p:nvPr/>
+        </p:nvSpPr>
+        <p:spPr>
+          <a:xfrm>
+            <a:off x="8558784" y="3435858"/>
+            <a:ext cx="2846527" cy="582930"/>
+          </a:xfrm>
+          <a:prstGeom prst="rect">
+            <a:avLst/>
+          </a:prstGeom>
+          <a:solidFill>
+            <a:srgbClr val="FFFFFF"/>
+          </a:solidFill>
+          <a:ln w="9525">
+            <a:solidFill>
+              <a:srgbClr val="DDE2E7"/>
+            </a:solidFill>
+          </a:ln>
+        </p:spPr>
+        <p:txBody>
+          <a:bodyPr rtlCol="0" anchor="ctr"/>
+          <a:lstStyle/>
+          <a:p>
+            <a:pPr algn="ctr"/>
+          </a:p>
+        </p:txBody>
+      </p:sp>
+      <p:sp>
+        <p:nvSpPr>
+          <p:cNvPr id="24" name="TextBox 23"/>
           <p:cNvSpPr txBox="1"/>
           <p:nvPr/>
         </p:nvSpPr>
         <p:spPr>
           <a:xfrm>
-            <a:off x="1463040" y="2395728"/>
-            <a:ext cx="4572000" cy="274320"/>
+            <a:off x="8723376" y="3435858"/>
+            <a:ext cx="1913839" cy="582930"/>
           </a:xfrm>
           <a:prstGeom prst="rect">
             <a:avLst/>
@@ -4000,29 +4874,114 @@
               </a:spcAft>
             </a:pPr>
             <a:r>
-              <a:rPr sz="1300" b="1">
-                <a:solidFill>
-                  <a:srgbClr val="16202A"/>
+              <a:rPr sz="1150" b="0">
+                <a:solidFill>
+                  <a:srgbClr val="35424F"/>
                 </a:solidFill>
                 <a:latin typeface="Microsoft YaHei"/>
                 <a:ea typeface="Microsoft YaHei"/>
                 <a:cs typeface="Microsoft YaHei"/>
               </a:rPr>
-              <a:t>生成</a:t>
-            </a:r>
-          </a:p>
-        </p:txBody>
-      </p:sp>
-      <p:sp>
-        <p:nvSpPr>
-          <p:cNvPr id="10" name="TextBox 9"/>
+              <a:t>平均达标轮数</a:t>
+            </a:r>
+          </a:p>
+        </p:txBody>
+      </p:sp>
+      <p:sp>
+        <p:nvSpPr>
+          <p:cNvPr id="25" name="Rounded Rectangle 24"/>
+          <p:cNvSpPr/>
+          <p:nvPr/>
+        </p:nvSpPr>
+        <p:spPr>
+          <a:xfrm>
+            <a:off x="10472623" y="3545586"/>
+            <a:ext cx="768096" cy="363474"/>
+          </a:xfrm>
+          <a:prstGeom prst="roundRect">
+            <a:avLst>
+              <a:gd name="adj" fmla="val 30000"/>
+            </a:avLst>
+          </a:prstGeom>
+          <a:solidFill>
+            <a:srgbClr val="EEF1F4"/>
+          </a:solidFill>
+          <a:ln>
+            <a:noFill/>
+          </a:ln>
+        </p:spPr>
+        <p:txBody>
+          <a:bodyPr rtlCol="0" anchor="ctr" wrap="square" tIns="36576" bIns="36576">
+            <a:noAutofit/>
+          </a:bodyPr>
+          <a:lstStyle/>
+          <a:p>
+            <a:pPr algn="ctr" latinLnBrk="0">
+              <a:lnSpc>
+                <a:spcPct val="100000"/>
+              </a:lnSpc>
+              <a:spcBef>
+                <a:spcPts val="0"/>
+              </a:spcBef>
+              <a:spcAft>
+                <a:spcPts val="0"/>
+              </a:spcAft>
+            </a:pPr>
+            <a:r>
+              <a:rPr sz="1500" b="1">
+                <a:solidFill>
+                  <a:srgbClr val="8C96A1"/>
+                </a:solidFill>
+                <a:latin typeface="Arial"/>
+                <a:ea typeface="Microsoft YaHei"/>
+                <a:cs typeface="Microsoft YaHei"/>
+              </a:rPr>
+              <a:t>—</a:t>
+            </a:r>
+          </a:p>
+        </p:txBody>
+      </p:sp>
+      <p:sp>
+        <p:nvSpPr>
+          <p:cNvPr id="26" name="Rectangle 25"/>
+          <p:cNvSpPr/>
+          <p:nvPr/>
+        </p:nvSpPr>
+        <p:spPr>
+          <a:xfrm>
+            <a:off x="8558784" y="4128516"/>
+            <a:ext cx="2846527" cy="582930"/>
+          </a:xfrm>
+          <a:prstGeom prst="rect">
+            <a:avLst/>
+          </a:prstGeom>
+          <a:solidFill>
+            <a:srgbClr val="FFFFFF"/>
+          </a:solidFill>
+          <a:ln w="9525">
+            <a:solidFill>
+              <a:srgbClr val="DDE2E7"/>
+            </a:solidFill>
+          </a:ln>
+        </p:spPr>
+        <p:txBody>
+          <a:bodyPr rtlCol="0" anchor="ctr"/>
+          <a:lstStyle/>
+          <a:p>
+            <a:pPr algn="ctr"/>
+          </a:p>
+        </p:txBody>
+      </p:sp>
+      <p:sp>
+        <p:nvSpPr>
+          <p:cNvPr id="27" name="TextBox 26"/>
           <p:cNvSpPr txBox="1"/>
           <p:nvPr/>
         </p:nvSpPr>
         <p:spPr>
           <a:xfrm>
-            <a:off x="1463040" y="2670048"/>
-            <a:ext cx="4572000" cy="256032"/>
+            <a:off x="8723376" y="4128516"/>
+            <a:ext cx="1913839" cy="582930"/>
           </a:xfrm>
           <a:prstGeom prst="rect">
             <a:avLst/>
@@ -4047,7 +5006,7 @@
               </a:spcAft>
             </a:pPr>
             <a:r>
-              <a:rPr sz="1050" b="0">
+              <a:rPr sz="1150" b="0">
                 <a:solidFill>
                   <a:srgbClr val="35424F"/>
                 </a:solidFill>
@@ -4055,34 +5014,36 @@
                 <a:ea typeface="Microsoft YaHei"/>
                 <a:cs typeface="Microsoft YaHei"/>
               </a:rPr>
-              <a:t>LLM 照硬件说明卡写出内核</a:t>
-            </a:r>
-          </a:p>
-        </p:txBody>
-      </p:sp>
-      <p:sp>
-        <p:nvSpPr>
-          <p:cNvPr id="11" name="Oval 10"/>
+              <a:t>相对基线加速</a:t>
+            </a:r>
+          </a:p>
+        </p:txBody>
+      </p:sp>
+      <p:sp>
+        <p:nvSpPr>
+          <p:cNvPr id="28" name="Rounded Rectangle 27"/>
           <p:cNvSpPr/>
           <p:nvPr/>
         </p:nvSpPr>
         <p:spPr>
           <a:xfrm>
-            <a:off x="1005840" y="3204972"/>
-            <a:ext cx="310896" cy="310896"/>
-          </a:xfrm>
-          <a:prstGeom prst="ellipse">
-            <a:avLst/>
+            <a:off x="10472623" y="4238244"/>
+            <a:ext cx="768096" cy="363474"/>
+          </a:xfrm>
+          <a:prstGeom prst="roundRect">
+            <a:avLst>
+              <a:gd name="adj" fmla="val 30000"/>
+            </a:avLst>
           </a:prstGeom>
           <a:solidFill>
-            <a:srgbClr val="C0612C"/>
+            <a:srgbClr val="EEF1F4"/>
           </a:solidFill>
           <a:ln>
             <a:noFill/>
           </a:ln>
         </p:spPr>
         <p:txBody>
-          <a:bodyPr rtlCol="0" anchor="ctr" wrap="square" lIns="0" tIns="0" rIns="0" bIns="0">
+          <a:bodyPr rtlCol="0" anchor="ctr" wrap="square" tIns="36576" bIns="36576">
             <a:noAutofit/>
           </a:bodyPr>
           <a:lstStyle/>
@@ -4099,29 +5060,60 @@
               </a:spcAft>
             </a:pPr>
             <a:r>
-              <a:rPr sz="1100" b="1">
-                <a:solidFill>
-                  <a:srgbClr val="FFFFFF"/>
+              <a:rPr sz="1500" b="1">
+                <a:solidFill>
+                  <a:srgbClr val="8C96A1"/>
                 </a:solidFill>
                 <a:latin typeface="Arial"/>
                 <a:ea typeface="Microsoft YaHei"/>
                 <a:cs typeface="Microsoft YaHei"/>
               </a:rPr>
-              <a:t>2</a:t>
-            </a:r>
-          </a:p>
-        </p:txBody>
-      </p:sp>
-      <p:sp>
-        <p:nvSpPr>
-          <p:cNvPr id="12" name="TextBox 11"/>
+              <a:t>—</a:t>
+            </a:r>
+          </a:p>
+        </p:txBody>
+      </p:sp>
+      <p:sp>
+        <p:nvSpPr>
+          <p:cNvPr id="29" name="Rectangle 28"/>
+          <p:cNvSpPr/>
+          <p:nvPr/>
+        </p:nvSpPr>
+        <p:spPr>
+          <a:xfrm>
+            <a:off x="8558784" y="4821174"/>
+            <a:ext cx="2846527" cy="582930"/>
+          </a:xfrm>
+          <a:prstGeom prst="rect">
+            <a:avLst/>
+          </a:prstGeom>
+          <a:solidFill>
+            <a:srgbClr val="FFFFFF"/>
+          </a:solidFill>
+          <a:ln w="9525">
+            <a:solidFill>
+              <a:srgbClr val="DDE2E7"/>
+            </a:solidFill>
+          </a:ln>
+        </p:spPr>
+        <p:txBody>
+          <a:bodyPr rtlCol="0" anchor="ctr"/>
+          <a:lstStyle/>
+          <a:p>
+            <a:pPr algn="ctr"/>
+          </a:p>
+        </p:txBody>
+      </p:sp>
+      <p:sp>
+        <p:nvSpPr>
+          <p:cNvPr id="30" name="TextBox 29"/>
           <p:cNvSpPr txBox="1"/>
           <p:nvPr/>
         </p:nvSpPr>
         <p:spPr>
           <a:xfrm>
-            <a:off x="1463040" y="3168396"/>
-            <a:ext cx="4572000" cy="274320"/>
+            <a:off x="8723376" y="4821174"/>
+            <a:ext cx="1913839" cy="582930"/>
           </a:xfrm>
           <a:prstGeom prst="rect">
             <a:avLst/>
@@ -4146,29 +5138,83 @@
               </a:spcAft>
             </a:pPr>
             <a:r>
-              <a:rPr sz="1300" b="1">
-                <a:solidFill>
-                  <a:srgbClr val="16202A"/>
+              <a:rPr sz="1150" b="0">
+                <a:solidFill>
+                  <a:srgbClr val="35424F"/>
                 </a:solidFill>
                 <a:latin typeface="Microsoft YaHei"/>
                 <a:ea typeface="Microsoft YaHei"/>
                 <a:cs typeface="Microsoft YaHei"/>
               </a:rPr>
-              <a:t>编译</a:t>
-            </a:r>
-          </a:p>
-        </p:txBody>
-      </p:sp>
-      <p:sp>
-        <p:nvSpPr>
-          <p:cNvPr id="13" name="TextBox 12"/>
+              <a:t>理论上限达成率</a:t>
+            </a:r>
+          </a:p>
+        </p:txBody>
+      </p:sp>
+      <p:sp>
+        <p:nvSpPr>
+          <p:cNvPr id="31" name="Rounded Rectangle 30"/>
+          <p:cNvSpPr/>
+          <p:nvPr/>
+        </p:nvSpPr>
+        <p:spPr>
+          <a:xfrm>
+            <a:off x="10472623" y="4930902"/>
+            <a:ext cx="768096" cy="363474"/>
+          </a:xfrm>
+          <a:prstGeom prst="roundRect">
+            <a:avLst>
+              <a:gd name="adj" fmla="val 30000"/>
+            </a:avLst>
+          </a:prstGeom>
+          <a:solidFill>
+            <a:srgbClr val="EEF1F4"/>
+          </a:solidFill>
+          <a:ln>
+            <a:noFill/>
+          </a:ln>
+        </p:spPr>
+        <p:txBody>
+          <a:bodyPr rtlCol="0" anchor="ctr" wrap="square" tIns="36576" bIns="36576">
+            <a:noAutofit/>
+          </a:bodyPr>
+          <a:lstStyle/>
+          <a:p>
+            <a:pPr algn="ctr" latinLnBrk="0">
+              <a:lnSpc>
+                <a:spcPct val="100000"/>
+              </a:lnSpc>
+              <a:spcBef>
+                <a:spcPts val="0"/>
+              </a:spcBef>
+              <a:spcAft>
+                <a:spcPts val="0"/>
+              </a:spcAft>
+            </a:pPr>
+            <a:r>
+              <a:rPr sz="1500" b="1">
+                <a:solidFill>
+                  <a:srgbClr val="8C96A1"/>
+                </a:solidFill>
+                <a:latin typeface="Arial"/>
+                <a:ea typeface="Microsoft YaHei"/>
+                <a:cs typeface="Microsoft YaHei"/>
+              </a:rPr>
+              <a:t>—</a:t>
+            </a:r>
+          </a:p>
+        </p:txBody>
+      </p:sp>
+      <p:sp>
+        <p:nvSpPr>
+          <p:cNvPr id="32" name="TextBox 31"/>
           <p:cNvSpPr txBox="1"/>
           <p:nvPr/>
         </p:nvSpPr>
         <p:spPr>
           <a:xfrm>
-            <a:off x="1463040" y="3442715"/>
-            <a:ext cx="4572000" cy="256032"/>
+            <a:off x="8558784" y="5532120"/>
+            <a:ext cx="2846527" cy="274320"/>
           </a:xfrm>
           <a:prstGeom prst="rect">
             <a:avLst/>
@@ -4195,79 +5241,27 @@
             <a:r>
               <a:rPr sz="1050" b="0">
                 <a:solidFill>
-                  <a:srgbClr val="35424F"/>
+                  <a:srgbClr val="66727F"/>
                 </a:solidFill>
                 <a:latin typeface="Microsoft YaHei"/>
                 <a:ea typeface="Microsoft YaHei"/>
                 <a:cs typeface="Microsoft YaHei"/>
               </a:rPr>
-              <a:t>编译并拉起程序，跑通才往下走</a:t>
-            </a:r>
-          </a:p>
-        </p:txBody>
-      </p:sp>
-      <p:sp>
-        <p:nvSpPr>
-          <p:cNvPr id="14" name="Oval 13"/>
-          <p:cNvSpPr/>
-          <p:nvPr/>
-        </p:nvSpPr>
-        <p:spPr>
-          <a:xfrm>
-            <a:off x="1005840" y="3977639"/>
-            <a:ext cx="310896" cy="310896"/>
-          </a:xfrm>
-          <a:prstGeom prst="ellipse">
-            <a:avLst/>
-          </a:prstGeom>
-          <a:solidFill>
-            <a:srgbClr val="C0612C"/>
-          </a:solidFill>
-          <a:ln>
-            <a:noFill/>
-          </a:ln>
-        </p:spPr>
-        <p:txBody>
-          <a:bodyPr rtlCol="0" anchor="ctr" wrap="square" lIns="0" tIns="0" rIns="0" bIns="0">
-            <a:noAutofit/>
-          </a:bodyPr>
-          <a:lstStyle/>
-          <a:p>
-            <a:pPr algn="ctr" latinLnBrk="0">
-              <a:lnSpc>
-                <a:spcPct val="100000"/>
-              </a:lnSpc>
-              <a:spcBef>
-                <a:spcPts val="0"/>
-              </a:spcBef>
-              <a:spcAft>
-                <a:spcPts val="0"/>
-              </a:spcAft>
-            </a:pPr>
-            <a:r>
-              <a:rPr sz="1100" b="1">
-                <a:solidFill>
-                  <a:srgbClr val="FFFFFF"/>
-                </a:solidFill>
-                <a:latin typeface="Arial"/>
-                <a:ea typeface="Microsoft YaHei"/>
-                <a:cs typeface="Microsoft YaHei"/>
-              </a:rPr>
-              <a:t>3</a:t>
-            </a:r>
-          </a:p>
-        </p:txBody>
-      </p:sp>
-      <p:sp>
-        <p:nvSpPr>
-          <p:cNvPr id="15" name="TextBox 14"/>
+              <a:t>口径：真机、生产形状上的实测</a:t>
+            </a:r>
+          </a:p>
+        </p:txBody>
+      </p:sp>
+      <p:sp>
+        <p:nvSpPr>
+          <p:cNvPr id="33" name="TextBox 32"/>
           <p:cNvSpPr txBox="1"/>
           <p:nvPr/>
         </p:nvSpPr>
         <p:spPr>
           <a:xfrm>
-            <a:off x="1463040" y="3941063"/>
-            <a:ext cx="4572000" cy="274320"/>
+            <a:off x="548640" y="6382512"/>
+            <a:ext cx="9905695" cy="256032"/>
           </a:xfrm>
           <a:prstGeom prst="rect">
             <a:avLst/>
@@ -4292,1076 +5286,6 @@
               </a:spcAft>
             </a:pPr>
             <a:r>
-              <a:rPr sz="1300" b="1">
-                <a:solidFill>
-                  <a:srgbClr val="16202A"/>
-                </a:solidFill>
-                <a:latin typeface="Microsoft YaHei"/>
-                <a:ea typeface="Microsoft YaHei"/>
-                <a:cs typeface="Microsoft YaHei"/>
-              </a:rPr>
-              <a:t>对数值</a:t>
-            </a:r>
-          </a:p>
-        </p:txBody>
-      </p:sp>
-      <p:sp>
-        <p:nvSpPr>
-          <p:cNvPr id="16" name="TextBox 15"/>
-          <p:cNvSpPr txBox="1"/>
-          <p:nvPr/>
-        </p:nvSpPr>
-        <p:spPr>
-          <a:xfrm>
-            <a:off x="1463040" y="4215383"/>
-            <a:ext cx="4572000" cy="256032"/>
-          </a:xfrm>
-          <a:prstGeom prst="rect">
-            <a:avLst/>
-          </a:prstGeom>
-          <a:noFill/>
-        </p:spPr>
-        <p:txBody>
-          <a:bodyPr wrap="square" anchor="ctr" lIns="0" tIns="0" rIns="0" bIns="0">
-            <a:noAutofit/>
-          </a:bodyPr>
-          <a:lstStyle/>
-          <a:p>
-            <a:pPr algn="l" latinLnBrk="0">
-              <a:lnSpc>
-                <a:spcPct val="100000"/>
-              </a:lnSpc>
-              <a:spcBef>
-                <a:spcPts val="0"/>
-              </a:spcBef>
-              <a:spcAft>
-                <a:spcPts val="0"/>
-              </a:spcAft>
-            </a:pPr>
-            <a:r>
-              <a:rPr sz="1050" b="0">
-                <a:solidFill>
-                  <a:srgbClr val="35424F"/>
-                </a:solidFill>
-                <a:latin typeface="Microsoft YaHei"/>
-                <a:ea typeface="Microsoft YaHei"/>
-                <a:cs typeface="Microsoft YaHei"/>
-              </a:rPr>
-              <a:t>多种形状、精度逐一对 golden</a:t>
-            </a:r>
-          </a:p>
-        </p:txBody>
-      </p:sp>
-      <p:sp>
-        <p:nvSpPr>
-          <p:cNvPr id="17" name="Oval 16"/>
-          <p:cNvSpPr/>
-          <p:nvPr/>
-        </p:nvSpPr>
-        <p:spPr>
-          <a:xfrm>
-            <a:off x="1005840" y="4750308"/>
-            <a:ext cx="310896" cy="310896"/>
-          </a:xfrm>
-          <a:prstGeom prst="ellipse">
-            <a:avLst/>
-          </a:prstGeom>
-          <a:solidFill>
-            <a:srgbClr val="C0612C"/>
-          </a:solidFill>
-          <a:ln>
-            <a:noFill/>
-          </a:ln>
-        </p:spPr>
-        <p:txBody>
-          <a:bodyPr rtlCol="0" anchor="ctr" wrap="square" lIns="0" tIns="0" rIns="0" bIns="0">
-            <a:noAutofit/>
-          </a:bodyPr>
-          <a:lstStyle/>
-          <a:p>
-            <a:pPr algn="ctr" latinLnBrk="0">
-              <a:lnSpc>
-                <a:spcPct val="100000"/>
-              </a:lnSpc>
-              <a:spcBef>
-                <a:spcPts val="0"/>
-              </a:spcBef>
-              <a:spcAft>
-                <a:spcPts val="0"/>
-              </a:spcAft>
-            </a:pPr>
-            <a:r>
-              <a:rPr sz="1100" b="1">
-                <a:solidFill>
-                  <a:srgbClr val="FFFFFF"/>
-                </a:solidFill>
-                <a:latin typeface="Arial"/>
-                <a:ea typeface="Microsoft YaHei"/>
-                <a:cs typeface="Microsoft YaHei"/>
-              </a:rPr>
-              <a:t>4</a:t>
-            </a:r>
-          </a:p>
-        </p:txBody>
-      </p:sp>
-      <p:sp>
-        <p:nvSpPr>
-          <p:cNvPr id="18" name="TextBox 17"/>
-          <p:cNvSpPr txBox="1"/>
-          <p:nvPr/>
-        </p:nvSpPr>
-        <p:spPr>
-          <a:xfrm>
-            <a:off x="1463040" y="4713732"/>
-            <a:ext cx="4572000" cy="274320"/>
-          </a:xfrm>
-          <a:prstGeom prst="rect">
-            <a:avLst/>
-          </a:prstGeom>
-          <a:noFill/>
-        </p:spPr>
-        <p:txBody>
-          <a:bodyPr wrap="square" anchor="ctr" lIns="0" tIns="0" rIns="0" bIns="0">
-            <a:noAutofit/>
-          </a:bodyPr>
-          <a:lstStyle/>
-          <a:p>
-            <a:pPr algn="l" latinLnBrk="0">
-              <a:lnSpc>
-                <a:spcPct val="100000"/>
-              </a:lnSpc>
-              <a:spcBef>
-                <a:spcPts val="0"/>
-              </a:spcBef>
-              <a:spcAft>
-                <a:spcPts val="0"/>
-              </a:spcAft>
-            </a:pPr>
-            <a:r>
-              <a:rPr sz="1300" b="1">
-                <a:solidFill>
-                  <a:srgbClr val="16202A"/>
-                </a:solidFill>
-                <a:latin typeface="Microsoft YaHei"/>
-                <a:ea typeface="Microsoft YaHei"/>
-                <a:cs typeface="Microsoft YaHei"/>
-              </a:rPr>
-              <a:t>测性能</a:t>
-            </a:r>
-          </a:p>
-        </p:txBody>
-      </p:sp>
-      <p:sp>
-        <p:nvSpPr>
-          <p:cNvPr id="19" name="TextBox 18"/>
-          <p:cNvSpPr txBox="1"/>
-          <p:nvPr/>
-        </p:nvSpPr>
-        <p:spPr>
-          <a:xfrm>
-            <a:off x="1463040" y="4988052"/>
-            <a:ext cx="4572000" cy="256032"/>
-          </a:xfrm>
-          <a:prstGeom prst="rect">
-            <a:avLst/>
-          </a:prstGeom>
-          <a:noFill/>
-        </p:spPr>
-        <p:txBody>
-          <a:bodyPr wrap="square" anchor="ctr" lIns="0" tIns="0" rIns="0" bIns="0">
-            <a:noAutofit/>
-          </a:bodyPr>
-          <a:lstStyle/>
-          <a:p>
-            <a:pPr algn="l" latinLnBrk="0">
-              <a:lnSpc>
-                <a:spcPct val="100000"/>
-              </a:lnSpc>
-              <a:spcBef>
-                <a:spcPts val="0"/>
-              </a:spcBef>
-              <a:spcAft>
-                <a:spcPts val="0"/>
-              </a:spcAft>
-            </a:pPr>
-            <a:r>
-              <a:rPr sz="1050" b="0">
-                <a:solidFill>
-                  <a:srgbClr val="35424F"/>
-                </a:solidFill>
-                <a:latin typeface="Microsoft YaHei"/>
-                <a:ea typeface="Microsoft YaHei"/>
-                <a:cs typeface="Microsoft YaHei"/>
-              </a:rPr>
-              <a:t>取中位延迟，和理论上限比</a:t>
-            </a:r>
-          </a:p>
-        </p:txBody>
-      </p:sp>
-      <p:sp>
-        <p:nvSpPr>
-          <p:cNvPr id="20" name="Oval 19"/>
-          <p:cNvSpPr/>
-          <p:nvPr/>
-        </p:nvSpPr>
-        <p:spPr>
-          <a:xfrm>
-            <a:off x="1005840" y="5522976"/>
-            <a:ext cx="310896" cy="310896"/>
-          </a:xfrm>
-          <a:prstGeom prst="ellipse">
-            <a:avLst/>
-          </a:prstGeom>
-          <a:solidFill>
-            <a:srgbClr val="C0612C"/>
-          </a:solidFill>
-          <a:ln>
-            <a:noFill/>
-          </a:ln>
-        </p:spPr>
-        <p:txBody>
-          <a:bodyPr rtlCol="0" anchor="ctr" wrap="square" lIns="0" tIns="0" rIns="0" bIns="0">
-            <a:noAutofit/>
-          </a:bodyPr>
-          <a:lstStyle/>
-          <a:p>
-            <a:pPr algn="ctr" latinLnBrk="0">
-              <a:lnSpc>
-                <a:spcPct val="100000"/>
-              </a:lnSpc>
-              <a:spcBef>
-                <a:spcPts val="0"/>
-              </a:spcBef>
-              <a:spcAft>
-                <a:spcPts val="0"/>
-              </a:spcAft>
-            </a:pPr>
-            <a:r>
-              <a:rPr sz="1100" b="1">
-                <a:solidFill>
-                  <a:srgbClr val="FFFFFF"/>
-                </a:solidFill>
-                <a:latin typeface="Arial"/>
-                <a:ea typeface="Microsoft YaHei"/>
-                <a:cs typeface="Microsoft YaHei"/>
-              </a:rPr>
-              <a:t>5</a:t>
-            </a:r>
-          </a:p>
-        </p:txBody>
-      </p:sp>
-      <p:sp>
-        <p:nvSpPr>
-          <p:cNvPr id="21" name="TextBox 20"/>
-          <p:cNvSpPr txBox="1"/>
-          <p:nvPr/>
-        </p:nvSpPr>
-        <p:spPr>
-          <a:xfrm>
-            <a:off x="1463040" y="5486400"/>
-            <a:ext cx="4572000" cy="274320"/>
-          </a:xfrm>
-          <a:prstGeom prst="rect">
-            <a:avLst/>
-          </a:prstGeom>
-          <a:noFill/>
-        </p:spPr>
-        <p:txBody>
-          <a:bodyPr wrap="square" anchor="ctr" lIns="0" tIns="0" rIns="0" bIns="0">
-            <a:noAutofit/>
-          </a:bodyPr>
-          <a:lstStyle/>
-          <a:p>
-            <a:pPr algn="l" latinLnBrk="0">
-              <a:lnSpc>
-                <a:spcPct val="100000"/>
-              </a:lnSpc>
-              <a:spcBef>
-                <a:spcPts val="0"/>
-              </a:spcBef>
-              <a:spcAft>
-                <a:spcPts val="0"/>
-              </a:spcAft>
-            </a:pPr>
-            <a:r>
-              <a:rPr sz="1300" b="1">
-                <a:solidFill>
-                  <a:srgbClr val="16202A"/>
-                </a:solidFill>
-                <a:latin typeface="Microsoft YaHei"/>
-                <a:ea typeface="Microsoft YaHei"/>
-                <a:cs typeface="Microsoft YaHei"/>
-              </a:rPr>
-              <a:t>给反馈</a:t>
-            </a:r>
-          </a:p>
-        </p:txBody>
-      </p:sp>
-      <p:sp>
-        <p:nvSpPr>
-          <p:cNvPr id="22" name="TextBox 21"/>
-          <p:cNvSpPr txBox="1"/>
-          <p:nvPr/>
-        </p:nvSpPr>
-        <p:spPr>
-          <a:xfrm>
-            <a:off x="1463040" y="5760720"/>
-            <a:ext cx="4572000" cy="256032"/>
-          </a:xfrm>
-          <a:prstGeom prst="rect">
-            <a:avLst/>
-          </a:prstGeom>
-          <a:noFill/>
-        </p:spPr>
-        <p:txBody>
-          <a:bodyPr wrap="square" anchor="ctr" lIns="0" tIns="0" rIns="0" bIns="0">
-            <a:noAutofit/>
-          </a:bodyPr>
-          <a:lstStyle/>
-          <a:p>
-            <a:pPr algn="l" latinLnBrk="0">
-              <a:lnSpc>
-                <a:spcPct val="100000"/>
-              </a:lnSpc>
-              <a:spcBef>
-                <a:spcPts val="0"/>
-              </a:spcBef>
-              <a:spcAft>
-                <a:spcPts val="0"/>
-              </a:spcAft>
-            </a:pPr>
-            <a:r>
-              <a:rPr sz="1050" b="0">
-                <a:solidFill>
-                  <a:srgbClr val="35424F"/>
-                </a:solidFill>
-                <a:latin typeface="Microsoft YaHei"/>
-                <a:ea typeface="Microsoft YaHei"/>
-                <a:cs typeface="Microsoft YaHei"/>
-              </a:rPr>
-              <a:t>打分、指出慢在哪，带进下一轮</a:t>
-            </a:r>
-          </a:p>
-        </p:txBody>
-      </p:sp>
-      <p:sp>
-        <p:nvSpPr>
-          <p:cNvPr id="23" name="Freeform 22"/>
-          <p:cNvSpPr/>
-          <p:nvPr/>
-        </p:nvSpPr>
-        <p:spPr>
-          <a:xfrm>
-            <a:off x="594360" y="2587752"/>
-            <a:ext cx="566928" cy="3337560"/>
-          </a:xfrm>
-          <a:custGeom>
-            <a:avLst/>
-            <a:gdLst/>
-            <a:ahLst/>
-            <a:cxnLst/>
-            <a:rect l="l" t="t" r="r" b="b"/>
-            <a:pathLst>
-              <a:path w="566928" h="3337560">
-                <a:moveTo>
-                  <a:pt x="566928" y="3337560"/>
-                </a:moveTo>
-                <a:lnTo>
-                  <a:pt x="0" y="3337560"/>
-                </a:lnTo>
-                <a:lnTo>
-                  <a:pt x="0" y="0"/>
-                </a:lnTo>
-                <a:lnTo>
-                  <a:pt x="374904" y="0"/>
-                </a:lnTo>
-              </a:path>
-            </a:pathLst>
-          </a:custGeom>
-          <a:noFill/>
-          <a:ln w="15875">
-            <a:solidFill>
-              <a:srgbClr val="C0612C"/>
-            </a:solidFill>
-            <a:tailEnd type="triangle" w="med" len="med"/>
-          </a:ln>
-        </p:spPr>
-        <p:txBody>
-          <a:bodyPr rtlCol="0" anchor="ctr"/>
-          <a:lstStyle/>
-          <a:p>
-            <a:pPr algn="ctr"/>
-          </a:p>
-        </p:txBody>
-      </p:sp>
-      <p:sp>
-        <p:nvSpPr>
-          <p:cNvPr id="24" name="Rectangle 23"/>
-          <p:cNvSpPr/>
-          <p:nvPr/>
-        </p:nvSpPr>
-        <p:spPr>
-          <a:xfrm>
-            <a:off x="5897880" y="2066543"/>
-            <a:ext cx="5745175" cy="3785616"/>
-          </a:xfrm>
-          <a:prstGeom prst="rect">
-            <a:avLst/>
-          </a:prstGeom>
-          <a:solidFill>
-            <a:srgbClr val="F8EADF"/>
-          </a:solidFill>
-          <a:ln>
-            <a:noFill/>
-          </a:ln>
-        </p:spPr>
-        <p:txBody>
-          <a:bodyPr rtlCol="0" anchor="ctr"/>
-          <a:lstStyle/>
-          <a:p>
-            <a:pPr algn="ctr"/>
-          </a:p>
-        </p:txBody>
-      </p:sp>
-      <p:sp>
-        <p:nvSpPr>
-          <p:cNvPr id="25" name="TextBox 24"/>
-          <p:cNvSpPr txBox="1"/>
-          <p:nvPr/>
-        </p:nvSpPr>
-        <p:spPr>
-          <a:xfrm>
-            <a:off x="6135624" y="2212848"/>
-            <a:ext cx="5287975" cy="292608"/>
-          </a:xfrm>
-          <a:prstGeom prst="rect">
-            <a:avLst/>
-          </a:prstGeom>
-          <a:noFill/>
-        </p:spPr>
-        <p:txBody>
-          <a:bodyPr wrap="square" anchor="ctr" lIns="0" tIns="0" rIns="0" bIns="0">
-            <a:noAutofit/>
-          </a:bodyPr>
-          <a:lstStyle/>
-          <a:p>
-            <a:pPr algn="l" latinLnBrk="0">
-              <a:lnSpc>
-                <a:spcPct val="100000"/>
-              </a:lnSpc>
-              <a:spcBef>
-                <a:spcPts val="0"/>
-              </a:spcBef>
-              <a:spcAft>
-                <a:spcPts val="0"/>
-              </a:spcAft>
-            </a:pPr>
-            <a:r>
-              <a:rPr sz="1400" b="1">
-                <a:solidFill>
-                  <a:srgbClr val="16202A"/>
-                </a:solidFill>
-                <a:latin typeface="Microsoft YaHei"/>
-                <a:ea typeface="Microsoft YaHei"/>
-                <a:cs typeface="Microsoft YaHei"/>
-              </a:rPr>
-              <a:t>效果</a:t>
-            </a:r>
-            <a:r>
-              <a:rPr sz="1050" b="0">
-                <a:solidFill>
-                  <a:srgbClr val="8C96A1"/>
-                </a:solidFill>
-                <a:latin typeface="Microsoft YaHei"/>
-                <a:ea typeface="Microsoft YaHei"/>
-                <a:cs typeface="Microsoft YaHei"/>
-              </a:rPr>
-              <a:t>　数字待补</a:t>
-            </a:r>
-          </a:p>
-        </p:txBody>
-      </p:sp>
-      <p:sp>
-        <p:nvSpPr>
-          <p:cNvPr id="26" name="Rectangle 25"/>
-          <p:cNvSpPr/>
-          <p:nvPr/>
-        </p:nvSpPr>
-        <p:spPr>
-          <a:xfrm>
-            <a:off x="6135624" y="2688336"/>
-            <a:ext cx="2552547" cy="1188720"/>
-          </a:xfrm>
-          <a:prstGeom prst="rect">
-            <a:avLst/>
-          </a:prstGeom>
-          <a:solidFill>
-            <a:srgbClr val="FFFFFF"/>
-          </a:solidFill>
-          <a:ln w="9525">
-            <a:solidFill>
-              <a:srgbClr val="DDE2E7"/>
-            </a:solidFill>
-          </a:ln>
-        </p:spPr>
-        <p:txBody>
-          <a:bodyPr rtlCol="0" anchor="ctr"/>
-          <a:lstStyle/>
-          <a:p>
-            <a:pPr algn="ctr"/>
-          </a:p>
-        </p:txBody>
-      </p:sp>
-      <p:sp>
-        <p:nvSpPr>
-          <p:cNvPr id="27" name="TextBox 26"/>
-          <p:cNvSpPr txBox="1"/>
-          <p:nvPr/>
-        </p:nvSpPr>
-        <p:spPr>
-          <a:xfrm>
-            <a:off x="6135624" y="2926080"/>
-            <a:ext cx="2552547" cy="457200"/>
-          </a:xfrm>
-          <a:prstGeom prst="rect">
-            <a:avLst/>
-          </a:prstGeom>
-          <a:noFill/>
-        </p:spPr>
-        <p:txBody>
-          <a:bodyPr wrap="square" anchor="ctr" lIns="0" tIns="0" rIns="0" bIns="0">
-            <a:noAutofit/>
-          </a:bodyPr>
-          <a:lstStyle/>
-          <a:p>
-            <a:pPr algn="ctr" latinLnBrk="0">
-              <a:lnSpc>
-                <a:spcPct val="100000"/>
-              </a:lnSpc>
-              <a:spcBef>
-                <a:spcPts val="0"/>
-              </a:spcBef>
-              <a:spcAft>
-                <a:spcPts val="0"/>
-              </a:spcAft>
-            </a:pPr>
-            <a:r>
-              <a:rPr sz="2800" b="1">
-                <a:solidFill>
-                  <a:srgbClr val="C5CCD4"/>
-                </a:solidFill>
-                <a:latin typeface="Arial"/>
-                <a:ea typeface="Microsoft YaHei"/>
-                <a:cs typeface="Microsoft YaHei"/>
-              </a:rPr>
-              <a:t>—</a:t>
-            </a:r>
-          </a:p>
-        </p:txBody>
-      </p:sp>
-      <p:sp>
-        <p:nvSpPr>
-          <p:cNvPr id="28" name="TextBox 27"/>
-          <p:cNvSpPr txBox="1"/>
-          <p:nvPr/>
-        </p:nvSpPr>
-        <p:spPr>
-          <a:xfrm>
-            <a:off x="6135624" y="3438144"/>
-            <a:ext cx="2552547" cy="274320"/>
-          </a:xfrm>
-          <a:prstGeom prst="rect">
-            <a:avLst/>
-          </a:prstGeom>
-          <a:noFill/>
-        </p:spPr>
-        <p:txBody>
-          <a:bodyPr wrap="square" anchor="ctr" lIns="0" tIns="0" rIns="0" bIns="0">
-            <a:noAutofit/>
-          </a:bodyPr>
-          <a:lstStyle/>
-          <a:p>
-            <a:pPr algn="ctr" latinLnBrk="0">
-              <a:lnSpc>
-                <a:spcPct val="100000"/>
-              </a:lnSpc>
-              <a:spcBef>
-                <a:spcPts val="0"/>
-              </a:spcBef>
-              <a:spcAft>
-                <a:spcPts val="0"/>
-              </a:spcAft>
-            </a:pPr>
-            <a:r>
-              <a:rPr sz="1100" b="0">
-                <a:solidFill>
-                  <a:srgbClr val="35424F"/>
-                </a:solidFill>
-                <a:latin typeface="Microsoft YaHei"/>
-                <a:ea typeface="Microsoft YaHei"/>
-                <a:cs typeface="Microsoft YaHei"/>
-              </a:rPr>
-              <a:t>已达标算子数</a:t>
-            </a:r>
-          </a:p>
-        </p:txBody>
-      </p:sp>
-      <p:sp>
-        <p:nvSpPr>
-          <p:cNvPr id="29" name="Rectangle 28"/>
-          <p:cNvSpPr/>
-          <p:nvPr/>
-        </p:nvSpPr>
-        <p:spPr>
-          <a:xfrm>
-            <a:off x="8852763" y="2688336"/>
-            <a:ext cx="2552547" cy="1188720"/>
-          </a:xfrm>
-          <a:prstGeom prst="rect">
-            <a:avLst/>
-          </a:prstGeom>
-          <a:solidFill>
-            <a:srgbClr val="FFFFFF"/>
-          </a:solidFill>
-          <a:ln w="9525">
-            <a:solidFill>
-              <a:srgbClr val="DDE2E7"/>
-            </a:solidFill>
-          </a:ln>
-        </p:spPr>
-        <p:txBody>
-          <a:bodyPr rtlCol="0" anchor="ctr"/>
-          <a:lstStyle/>
-          <a:p>
-            <a:pPr algn="ctr"/>
-          </a:p>
-        </p:txBody>
-      </p:sp>
-      <p:sp>
-        <p:nvSpPr>
-          <p:cNvPr id="30" name="TextBox 29"/>
-          <p:cNvSpPr txBox="1"/>
-          <p:nvPr/>
-        </p:nvSpPr>
-        <p:spPr>
-          <a:xfrm>
-            <a:off x="8852763" y="2926080"/>
-            <a:ext cx="2552547" cy="457200"/>
-          </a:xfrm>
-          <a:prstGeom prst="rect">
-            <a:avLst/>
-          </a:prstGeom>
-          <a:noFill/>
-        </p:spPr>
-        <p:txBody>
-          <a:bodyPr wrap="square" anchor="ctr" lIns="0" tIns="0" rIns="0" bIns="0">
-            <a:noAutofit/>
-          </a:bodyPr>
-          <a:lstStyle/>
-          <a:p>
-            <a:pPr algn="ctr" latinLnBrk="0">
-              <a:lnSpc>
-                <a:spcPct val="100000"/>
-              </a:lnSpc>
-              <a:spcBef>
-                <a:spcPts val="0"/>
-              </a:spcBef>
-              <a:spcAft>
-                <a:spcPts val="0"/>
-              </a:spcAft>
-            </a:pPr>
-            <a:r>
-              <a:rPr sz="2800" b="1">
-                <a:solidFill>
-                  <a:srgbClr val="C5CCD4"/>
-                </a:solidFill>
-                <a:latin typeface="Arial"/>
-                <a:ea typeface="Microsoft YaHei"/>
-                <a:cs typeface="Microsoft YaHei"/>
-              </a:rPr>
-              <a:t>—</a:t>
-            </a:r>
-          </a:p>
-        </p:txBody>
-      </p:sp>
-      <p:sp>
-        <p:nvSpPr>
-          <p:cNvPr id="31" name="TextBox 30"/>
-          <p:cNvSpPr txBox="1"/>
-          <p:nvPr/>
-        </p:nvSpPr>
-        <p:spPr>
-          <a:xfrm>
-            <a:off x="8852763" y="3438144"/>
-            <a:ext cx="2552547" cy="274320"/>
-          </a:xfrm>
-          <a:prstGeom prst="rect">
-            <a:avLst/>
-          </a:prstGeom>
-          <a:noFill/>
-        </p:spPr>
-        <p:txBody>
-          <a:bodyPr wrap="square" anchor="ctr" lIns="0" tIns="0" rIns="0" bIns="0">
-            <a:noAutofit/>
-          </a:bodyPr>
-          <a:lstStyle/>
-          <a:p>
-            <a:pPr algn="ctr" latinLnBrk="0">
-              <a:lnSpc>
-                <a:spcPct val="100000"/>
-              </a:lnSpc>
-              <a:spcBef>
-                <a:spcPts val="0"/>
-              </a:spcBef>
-              <a:spcAft>
-                <a:spcPts val="0"/>
-              </a:spcAft>
-            </a:pPr>
-            <a:r>
-              <a:rPr sz="1100" b="0">
-                <a:solidFill>
-                  <a:srgbClr val="35424F"/>
-                </a:solidFill>
-                <a:latin typeface="Microsoft YaHei"/>
-                <a:ea typeface="Microsoft YaHei"/>
-                <a:cs typeface="Microsoft YaHei"/>
-              </a:rPr>
-              <a:t>平均达标轮数</a:t>
-            </a:r>
-          </a:p>
-        </p:txBody>
-      </p:sp>
-      <p:sp>
-        <p:nvSpPr>
-          <p:cNvPr id="32" name="Rectangle 31"/>
-          <p:cNvSpPr/>
-          <p:nvPr/>
-        </p:nvSpPr>
-        <p:spPr>
-          <a:xfrm>
-            <a:off x="6135624" y="4023360"/>
-            <a:ext cx="2552547" cy="1188720"/>
-          </a:xfrm>
-          <a:prstGeom prst="rect">
-            <a:avLst/>
-          </a:prstGeom>
-          <a:solidFill>
-            <a:srgbClr val="FFFFFF"/>
-          </a:solidFill>
-          <a:ln w="9525">
-            <a:solidFill>
-              <a:srgbClr val="DDE2E7"/>
-            </a:solidFill>
-          </a:ln>
-        </p:spPr>
-        <p:txBody>
-          <a:bodyPr rtlCol="0" anchor="ctr"/>
-          <a:lstStyle/>
-          <a:p>
-            <a:pPr algn="ctr"/>
-          </a:p>
-        </p:txBody>
-      </p:sp>
-      <p:sp>
-        <p:nvSpPr>
-          <p:cNvPr id="33" name="TextBox 32"/>
-          <p:cNvSpPr txBox="1"/>
-          <p:nvPr/>
-        </p:nvSpPr>
-        <p:spPr>
-          <a:xfrm>
-            <a:off x="6135624" y="4261104"/>
-            <a:ext cx="2552547" cy="457200"/>
-          </a:xfrm>
-          <a:prstGeom prst="rect">
-            <a:avLst/>
-          </a:prstGeom>
-          <a:noFill/>
-        </p:spPr>
-        <p:txBody>
-          <a:bodyPr wrap="square" anchor="ctr" lIns="0" tIns="0" rIns="0" bIns="0">
-            <a:noAutofit/>
-          </a:bodyPr>
-          <a:lstStyle/>
-          <a:p>
-            <a:pPr algn="ctr" latinLnBrk="0">
-              <a:lnSpc>
-                <a:spcPct val="100000"/>
-              </a:lnSpc>
-              <a:spcBef>
-                <a:spcPts val="0"/>
-              </a:spcBef>
-              <a:spcAft>
-                <a:spcPts val="0"/>
-              </a:spcAft>
-            </a:pPr>
-            <a:r>
-              <a:rPr sz="2800" b="1">
-                <a:solidFill>
-                  <a:srgbClr val="C5CCD4"/>
-                </a:solidFill>
-                <a:latin typeface="Arial"/>
-                <a:ea typeface="Microsoft YaHei"/>
-                <a:cs typeface="Microsoft YaHei"/>
-              </a:rPr>
-              <a:t>—</a:t>
-            </a:r>
-          </a:p>
-        </p:txBody>
-      </p:sp>
-      <p:sp>
-        <p:nvSpPr>
-          <p:cNvPr id="34" name="TextBox 33"/>
-          <p:cNvSpPr txBox="1"/>
-          <p:nvPr/>
-        </p:nvSpPr>
-        <p:spPr>
-          <a:xfrm>
-            <a:off x="6135624" y="4773168"/>
-            <a:ext cx="2552547" cy="274320"/>
-          </a:xfrm>
-          <a:prstGeom prst="rect">
-            <a:avLst/>
-          </a:prstGeom>
-          <a:noFill/>
-        </p:spPr>
-        <p:txBody>
-          <a:bodyPr wrap="square" anchor="ctr" lIns="0" tIns="0" rIns="0" bIns="0">
-            <a:noAutofit/>
-          </a:bodyPr>
-          <a:lstStyle/>
-          <a:p>
-            <a:pPr algn="ctr" latinLnBrk="0">
-              <a:lnSpc>
-                <a:spcPct val="100000"/>
-              </a:lnSpc>
-              <a:spcBef>
-                <a:spcPts val="0"/>
-              </a:spcBef>
-              <a:spcAft>
-                <a:spcPts val="0"/>
-              </a:spcAft>
-            </a:pPr>
-            <a:r>
-              <a:rPr sz="1100" b="0">
-                <a:solidFill>
-                  <a:srgbClr val="35424F"/>
-                </a:solidFill>
-                <a:latin typeface="Microsoft YaHei"/>
-                <a:ea typeface="Microsoft YaHei"/>
-                <a:cs typeface="Microsoft YaHei"/>
-              </a:rPr>
-              <a:t>相对基线加速</a:t>
-            </a:r>
-          </a:p>
-        </p:txBody>
-      </p:sp>
-      <p:sp>
-        <p:nvSpPr>
-          <p:cNvPr id="35" name="Rectangle 34"/>
-          <p:cNvSpPr/>
-          <p:nvPr/>
-        </p:nvSpPr>
-        <p:spPr>
-          <a:xfrm>
-            <a:off x="8852763" y="4023360"/>
-            <a:ext cx="2552547" cy="1188720"/>
-          </a:xfrm>
-          <a:prstGeom prst="rect">
-            <a:avLst/>
-          </a:prstGeom>
-          <a:solidFill>
-            <a:srgbClr val="FFFFFF"/>
-          </a:solidFill>
-          <a:ln w="9525">
-            <a:solidFill>
-              <a:srgbClr val="DDE2E7"/>
-            </a:solidFill>
-          </a:ln>
-        </p:spPr>
-        <p:txBody>
-          <a:bodyPr rtlCol="0" anchor="ctr"/>
-          <a:lstStyle/>
-          <a:p>
-            <a:pPr algn="ctr"/>
-          </a:p>
-        </p:txBody>
-      </p:sp>
-      <p:sp>
-        <p:nvSpPr>
-          <p:cNvPr id="36" name="TextBox 35"/>
-          <p:cNvSpPr txBox="1"/>
-          <p:nvPr/>
-        </p:nvSpPr>
-        <p:spPr>
-          <a:xfrm>
-            <a:off x="8852763" y="4261104"/>
-            <a:ext cx="2552547" cy="457200"/>
-          </a:xfrm>
-          <a:prstGeom prst="rect">
-            <a:avLst/>
-          </a:prstGeom>
-          <a:noFill/>
-        </p:spPr>
-        <p:txBody>
-          <a:bodyPr wrap="square" anchor="ctr" lIns="0" tIns="0" rIns="0" bIns="0">
-            <a:noAutofit/>
-          </a:bodyPr>
-          <a:lstStyle/>
-          <a:p>
-            <a:pPr algn="ctr" latinLnBrk="0">
-              <a:lnSpc>
-                <a:spcPct val="100000"/>
-              </a:lnSpc>
-              <a:spcBef>
-                <a:spcPts val="0"/>
-              </a:spcBef>
-              <a:spcAft>
-                <a:spcPts val="0"/>
-              </a:spcAft>
-            </a:pPr>
-            <a:r>
-              <a:rPr sz="2800" b="1">
-                <a:solidFill>
-                  <a:srgbClr val="C5CCD4"/>
-                </a:solidFill>
-                <a:latin typeface="Arial"/>
-                <a:ea typeface="Microsoft YaHei"/>
-                <a:cs typeface="Microsoft YaHei"/>
-              </a:rPr>
-              <a:t>—</a:t>
-            </a:r>
-          </a:p>
-        </p:txBody>
-      </p:sp>
-      <p:sp>
-        <p:nvSpPr>
-          <p:cNvPr id="37" name="TextBox 36"/>
-          <p:cNvSpPr txBox="1"/>
-          <p:nvPr/>
-        </p:nvSpPr>
-        <p:spPr>
-          <a:xfrm>
-            <a:off x="8852763" y="4773168"/>
-            <a:ext cx="2552547" cy="274320"/>
-          </a:xfrm>
-          <a:prstGeom prst="rect">
-            <a:avLst/>
-          </a:prstGeom>
-          <a:noFill/>
-        </p:spPr>
-        <p:txBody>
-          <a:bodyPr wrap="square" anchor="ctr" lIns="0" tIns="0" rIns="0" bIns="0">
-            <a:noAutofit/>
-          </a:bodyPr>
-          <a:lstStyle/>
-          <a:p>
-            <a:pPr algn="ctr" latinLnBrk="0">
-              <a:lnSpc>
-                <a:spcPct val="100000"/>
-              </a:lnSpc>
-              <a:spcBef>
-                <a:spcPts val="0"/>
-              </a:spcBef>
-              <a:spcAft>
-                <a:spcPts val="0"/>
-              </a:spcAft>
-            </a:pPr>
-            <a:r>
-              <a:rPr sz="1100" b="0">
-                <a:solidFill>
-                  <a:srgbClr val="35424F"/>
-                </a:solidFill>
-                <a:latin typeface="Microsoft YaHei"/>
-                <a:ea typeface="Microsoft YaHei"/>
-                <a:cs typeface="Microsoft YaHei"/>
-              </a:rPr>
-              <a:t>理论上限达成率</a:t>
-            </a:r>
-          </a:p>
-        </p:txBody>
-      </p:sp>
-      <p:sp>
-        <p:nvSpPr>
-          <p:cNvPr id="38" name="TextBox 37"/>
-          <p:cNvSpPr txBox="1"/>
-          <p:nvPr/>
-        </p:nvSpPr>
-        <p:spPr>
-          <a:xfrm>
-            <a:off x="6135624" y="5431536"/>
-            <a:ext cx="5269687" cy="274320"/>
-          </a:xfrm>
-          <a:prstGeom prst="rect">
-            <a:avLst/>
-          </a:prstGeom>
-          <a:noFill/>
-        </p:spPr>
-        <p:txBody>
-          <a:bodyPr wrap="square" anchor="ctr" lIns="0" tIns="0" rIns="0" bIns="0">
-            <a:noAutofit/>
-          </a:bodyPr>
-          <a:lstStyle/>
-          <a:p>
-            <a:pPr algn="l" latinLnBrk="0">
-              <a:lnSpc>
-                <a:spcPct val="100000"/>
-              </a:lnSpc>
-              <a:spcBef>
-                <a:spcPts val="0"/>
-              </a:spcBef>
-              <a:spcAft>
-                <a:spcPts val="0"/>
-              </a:spcAft>
-            </a:pPr>
-            <a:r>
-              <a:rPr sz="1050" b="0">
-                <a:solidFill>
-                  <a:srgbClr val="66727F"/>
-                </a:solidFill>
-                <a:latin typeface="Microsoft YaHei"/>
-                <a:ea typeface="Microsoft YaHei"/>
-                <a:cs typeface="Microsoft YaHei"/>
-              </a:rPr>
-              <a:t>口径：真机、生产形状上的实测</a:t>
-            </a:r>
-          </a:p>
-        </p:txBody>
-      </p:sp>
-      <p:sp>
-        <p:nvSpPr>
-          <p:cNvPr id="39" name="TextBox 38"/>
-          <p:cNvSpPr txBox="1"/>
-          <p:nvPr/>
-        </p:nvSpPr>
-        <p:spPr>
-          <a:xfrm>
-            <a:off x="548640" y="6382512"/>
-            <a:ext cx="9905695" cy="256032"/>
-          </a:xfrm>
-          <a:prstGeom prst="rect">
-            <a:avLst/>
-          </a:prstGeom>
-          <a:noFill/>
-        </p:spPr>
-        <p:txBody>
-          <a:bodyPr wrap="square" anchor="ctr" lIns="0" tIns="0" rIns="0" bIns="0">
-            <a:noAutofit/>
-          </a:bodyPr>
-          <a:lstStyle/>
-          <a:p>
-            <a:pPr algn="l" latinLnBrk="0">
-              <a:lnSpc>
-                <a:spcPct val="100000"/>
-              </a:lnSpc>
-              <a:spcBef>
-                <a:spcPts val="0"/>
-              </a:spcBef>
-              <a:spcAft>
-                <a:spcPts val="0"/>
-              </a:spcAft>
-            </a:pPr>
-            <a:r>
               <a:rPr sz="1000" b="0">
                 <a:solidFill>
                   <a:srgbClr val="66727F"/>
@@ -5377,7 +5301,7 @@
       </p:sp>
       <p:sp>
         <p:nvSpPr>
-          <p:cNvPr id="40" name="TextBox 39"/>
+          <p:cNvPr id="34" name="TextBox 33"/>
           <p:cNvSpPr txBox="1"/>
           <p:nvPr/>
         </p:nvSpPr>

</xml_diff>

<commit_message>
Draw what xpugen actually is: one LLM agent plus a deterministic harness
The ring implied five peer steps done by one agent. Only generation is an LLM; the
compile, numeric, bench and profile stages are a harness with no model in them, so the
page now shows the two as separate blocks with the kernel going one way and structured
feedback coming back. The gate that precedes generation, the split between mechanism
evidence (simulator) and gain (device), and the backend as the only hardware-coupled
layer were the parts a reviewer would miss, so they are on the page now.

The turn budget no longer claims eight rounds for everything: eight is the default cap
for converging L1 accuracy, while performance tuning keeps iterating. The result panel
carries the measurements the repository can actually support (four sample operators,
rmsnorm at 1.24x, 0.47 to 0.58 of the roofline bound) and says it is a sample stage
rather than showing aggregate pass rates that do not exist yet.
</commit_message>
<xml_diff>
--- a/slides/xpugen_operator_agent.pptx
+++ b/slides/xpugen_operator_agent.pptx
@@ -515,7 +515,7 @@
                 <a:ea typeface="Microsoft YaHei"/>
                 <a:cs typeface="Microsoft YaHei"/>
               </a:rPr>
-              <a:t>【附页 · xpugen · 约 70 秒（1:10）】</a:t>
+              <a:t>【附页 · xpugen · 约 125 秒（2:05）】</a:t>
             </a:r>
           </a:p>
           <a:p>
@@ -551,7 +551,7 @@
                 <a:ea typeface="Microsoft YaHei"/>
                 <a:cs typeface="Microsoft YaHei"/>
               </a:rPr>
-              <a:t>左边这个圈就是它一轮迭代。入口有两条：从一句需求开始，或者从现有实现反推出规格，第 0 轮直接拿现有实现当基线，后面在它上面改。</a:t>
+              <a:t>先说清结构：这里只有一个 LLM，就是左边这个生成。右边编译、对数值、测速、看机制全是确定性的评测流程，不是 agent，不会自由发挥。</a:t>
             </a:r>
           </a:p>
           <a:p>
@@ -569,7 +569,7 @@
                 <a:ea typeface="Microsoft YaHei"/>
                 <a:cs typeface="Microsoft YaHei"/>
               </a:rPr>
-              <a:t>转一圈是这样：LLM 照硬件说明卡写内核，编译跑起来，多种形状和精度逐一和 golden 对数值，再测延迟、跟理论上限比，最后把打分和慢在哪带进下一轮。最多八轮。</a:t>
+              <a:t>左边动手之前还有一道门：先把需求问清楚、至少比过两个方案，才允许写内核。入口有两条，从一句需求开始，或者从现有实现反推出规格，第 0 轮直接拿它当基线。</a:t>
             </a:r>
           </a:p>
           <a:p>
@@ -587,7 +587,7 @@
                 <a:ea typeface="Microsoft YaHei"/>
                 <a:cs typeface="Microsoft YaHei"/>
               </a:rPr>
-              <a:t>右边是效果。（按实测数字讲：已经有多少个算子达标、平均几轮、相对原来的实现快多少、离理论上限还差多少。口径都是真机、生产形状上的实测。）</a:t>
+              <a:t>右边编译跑通、多种形状和精度逐一对 CPU golden；性能上分两路取证——真机回答快了多少，模拟器看逐单元 busy、跨引擎并行，回答为什么慢，两边对不上以真机为准。</a:t>
             </a:r>
           </a:p>
           <a:p>
@@ -597,6 +597,60 @@
               </a:spcAft>
             </a:pPr>
             <a:r>
+              <a:rPr sz="1200" b="0">
+                <a:solidFill>
+                  <a:srgbClr val="16202A"/>
+                </a:solidFill>
+                <a:latin typeface="Microsoft YaHei"/>
+                <a:ea typeface="Microsoft YaHei"/>
+                <a:cs typeface="Microsoft YaHei"/>
+              </a:rPr>
+              <a:t>这些结果打成结构化反馈回到生成：精度默认八轮收敛，性能调优是持续迭代，连着五十轮没进展才敢说卡住了。</a:t>
+            </a:r>
+          </a:p>
+          <a:p>
+            <a:pPr>
+              <a:spcAft>
+                <a:spcPts val="600"/>
+              </a:spcAft>
+            </a:pPr>
+            <a:r>
+              <a:rPr sz="1200" b="0">
+                <a:solidFill>
+                  <a:srgbClr val="16202A"/>
+                </a:solidFill>
+                <a:latin typeface="Microsoft YaHei"/>
+                <a:ea typeface="Microsoft YaHei"/>
+                <a:cs typeface="Microsoft YaHei"/>
+              </a:rPr>
+              <a:t>底下一行是架构：生成和评测都不碰硬件，只认 backend 这一层的四个接口，换芯片只写一个后端加一张硬件说明卡。</a:t>
+            </a:r>
+          </a:p>
+          <a:p>
+            <a:pPr>
+              <a:spcAft>
+                <a:spcPts val="600"/>
+              </a:spcAft>
+            </a:pPr>
+            <a:r>
+              <a:rPr sz="1200" b="0">
+                <a:solidFill>
+                  <a:srgbClr val="16202A"/>
+                </a:solidFill>
+                <a:latin typeface="Microsoft YaHei"/>
+                <a:ea typeface="Microsoft YaHei"/>
+                <a:cs typeface="Microsoft YaHei"/>
+              </a:rPr>
+              <a:t>右边是目前的实测，还在样例阶段：验证过四个算子，rmsnorm 相对基线一点二四倍，理论上限达成率从零点四七提到零点五八。规模化的达标统计还没有，所以这里不报聚合数字。</a:t>
+            </a:r>
+          </a:p>
+          <a:p>
+            <a:pPr>
+              <a:spcAft>
+                <a:spcPts val="600"/>
+              </a:spcAft>
+            </a:pPr>
+            <a:r>
               <a:rPr sz="1200" b="1">
                 <a:solidFill>
                   <a:srgbClr val="66727F"/>
@@ -623,7 +677,7 @@
                 <a:ea typeface="Microsoft YaHei"/>
                 <a:cs typeface="Microsoft YaHei"/>
               </a:rPr>
-              <a:t>换芯片要改什么：生成和评测这套流程完全不碰硬件，只认四个接口——编译、运行、采性能、算理论上限。每款芯片照这四个接口写一个后端、再填一张硬件说明卡，主流程一行不改。现在没有硬件也能在 CPU 上跑通整条闭环，M100 真机已接，P800 还没接。</a:t>
+              <a:t>轮数口径：max_turns 默认 8、--max-turns 可改，管的是过 L1 精度的收敛上限；性能调优不设 8 轮上限，铁律是连续 50 轮没有进展才允许下 stalled 结论。</a:t>
             </a:r>
           </a:p>
           <a:p>
@@ -641,7 +695,25 @@
                 <a:ea typeface="Microsoft YaHei"/>
                 <a:cs typeface="Microsoft YaHei"/>
               </a:rPr>
-              <a:t>数字凭什么信：精度参考只用 CPU 实现，绝不拿 CUDA 当标准，精度不过关就不看性能；模拟器只用来看清改动动了哪一块，收益一律以真机实测为准，两边对不上听真机的。而且每轮改了什么、前后数据、结论都必须落盘，写不进去这一轮就算失败。</a:t>
+              <a:t>rmsnorm 实测：延迟 741.2 → 595.6，相对基线 1.24 倍；理论上限达成率 0.47 → 0.58。验证过的算子是 relu、relu_sdnn、rmsnorm、hc_post 这几个样例。</a:t>
+            </a:r>
+          </a:p>
+          <a:p>
+            <a:pPr>
+              <a:spcAft>
+                <a:spcPts val="600"/>
+              </a:spcAft>
+            </a:pPr>
+            <a:r>
+              <a:rPr sz="1200" b="0">
+                <a:solidFill>
+                  <a:srgbClr val="66727F"/>
+                </a:solidFill>
+                <a:latin typeface="Microsoft YaHei"/>
+                <a:ea typeface="Microsoft YaHei"/>
+                <a:cs typeface="Microsoft YaHei"/>
+              </a:rPr>
+              <a:t>硬件状态：没有硬件也能在 CPU 上跑通整条闭环，M100 真机已接，P800 还没接。精度参考只用 CPU 实现，绝不拿 CUDA 当标准；每轮改了什么、前后数据、结论都必须落盘，写不进去这一轮就算失败。</a:t>
             </a:r>
           </a:p>
         </p:txBody>
@@ -3783,7 +3855,7 @@
                 <a:ea typeface="Microsoft YaHei"/>
                 <a:cs typeface="Microsoft YaHei"/>
               </a:rPr>
-              <a:t>生成的是 M100 的 SDNN4 .xpu 内核，不是 CUDA；CUDA / Triton / torch 只作算法参考与基线对照</a:t>
+              <a:t>生成 M100 的 SDNN4 .xpu 内核，不是 CUDA；只有「生成」是 LLM，编译 / 对数值 / 测速都是确定性流程</a:t>
             </a:r>
           </a:p>
         </p:txBody>
@@ -3796,7 +3868,7 @@
         </p:nvSpPr>
         <p:spPr>
           <a:xfrm>
-            <a:off x="548640" y="1682496"/>
+            <a:off x="548640" y="1664208"/>
             <a:ext cx="7406640" cy="274320"/>
           </a:xfrm>
           <a:prstGeom prst="rect">
@@ -3841,23 +3913,23 @@
                 <a:ea typeface="Microsoft YaHei"/>
                 <a:cs typeface="Microsoft YaHei"/>
               </a:rPr>
-              <a:t>一句需求，或现有实现当基线</a:t>
-            </a:r>
-          </a:p>
-        </p:txBody>
-      </p:sp>
-      <p:sp>
-        <p:nvSpPr>
-          <p:cNvPr id="6" name="Oval 5"/>
+              <a:t>一句需求，或拿现有实现当第 0 轮基线　·　精度默认 8 轮收敛（可调），性能调优持续迭代</a:t>
+            </a:r>
+          </a:p>
+        </p:txBody>
+      </p:sp>
+      <p:sp>
+        <p:nvSpPr>
+          <p:cNvPr id="6" name="Rectangle 5"/>
           <p:cNvSpPr/>
           <p:nvPr/>
         </p:nvSpPr>
         <p:spPr>
           <a:xfrm>
-            <a:off x="3419856" y="3374136"/>
-            <a:ext cx="1572768" cy="1572768"/>
-          </a:xfrm>
-          <a:prstGeom prst="ellipse">
+            <a:off x="548640" y="2560320"/>
+            <a:ext cx="3429000" cy="2212848"/>
+          </a:xfrm>
+          <a:prstGeom prst="rect">
             <a:avLst/>
           </a:prstGeom>
           <a:solidFill>
@@ -3883,8 +3955,8 @@
         </p:nvSpPr>
         <p:spPr>
           <a:xfrm>
-            <a:off x="3419856" y="3374136"/>
-            <a:ext cx="1572768" cy="1572768"/>
+            <a:off x="768096" y="2688336"/>
+            <a:ext cx="2990088" cy="292608"/>
           </a:xfrm>
           <a:prstGeom prst="rect">
             <a:avLst/>
@@ -3897,7 +3969,7 @@
           </a:bodyPr>
           <a:lstStyle/>
           <a:p>
-            <a:pPr algn="ctr" latinLnBrk="0">
+            <a:pPr algn="l" latinLnBrk="0">
               <a:lnSpc>
                 <a:spcPct val="100000"/>
               </a:lnSpc>
@@ -3905,21 +3977,702 @@
                 <a:spcPts val="0"/>
               </a:spcBef>
               <a:spcAft>
-                <a:spcPts val="300"/>
+                <a:spcPts val="0"/>
               </a:spcAft>
             </a:pPr>
             <a:r>
-              <a:rPr sz="1100" b="1">
+              <a:rPr sz="1300" b="1">
                 <a:solidFill>
                   <a:srgbClr val="C0612C"/>
+                </a:solidFill>
+                <a:latin typeface="Consolas"/>
+                <a:ea typeface="Microsoft YaHei"/>
+                <a:cs typeface="Microsoft YaHei"/>
+              </a:rPr>
+              <a:t>agent/</a:t>
+            </a:r>
+            <a:r>
+              <a:rPr sz="1300" b="1">
+                <a:solidFill>
+                  <a:srgbClr val="16202A"/>
                 </a:solidFill>
                 <a:latin typeface="Microsoft YaHei"/>
                 <a:ea typeface="Microsoft YaHei"/>
                 <a:cs typeface="Microsoft YaHei"/>
               </a:rPr>
-              <a:t>算子级闭环</a:t>
-            </a:r>
-          </a:p>
+              <a:t>　只有这一个 LLM</a:t>
+            </a:r>
+          </a:p>
+        </p:txBody>
+      </p:sp>
+      <p:sp>
+        <p:nvSpPr>
+          <p:cNvPr id="8" name="TextBox 7"/>
+          <p:cNvSpPr txBox="1"/>
+          <p:nvPr/>
+        </p:nvSpPr>
+        <p:spPr>
+          <a:xfrm>
+            <a:off x="768096" y="3218687"/>
+            <a:ext cx="2990088" cy="274320"/>
+          </a:xfrm>
+          <a:prstGeom prst="rect">
+            <a:avLst/>
+          </a:prstGeom>
+          <a:noFill/>
+        </p:spPr>
+        <p:txBody>
+          <a:bodyPr wrap="square" anchor="ctr" lIns="0" tIns="0" rIns="0" bIns="0">
+            <a:noAutofit/>
+          </a:bodyPr>
+          <a:lstStyle/>
+          <a:p>
+            <a:pPr algn="l" latinLnBrk="0">
+              <a:lnSpc>
+                <a:spcPct val="100000"/>
+              </a:lnSpc>
+              <a:spcBef>
+                <a:spcPts val="0"/>
+              </a:spcBef>
+              <a:spcAft>
+                <a:spcPts val="0"/>
+              </a:spcAft>
+            </a:pPr>
+            <a:r>
+              <a:rPr sz="1250" b="1">
+                <a:solidFill>
+                  <a:srgbClr val="16202A"/>
+                </a:solidFill>
+                <a:latin typeface="Microsoft YaHei"/>
+                <a:ea typeface="Microsoft YaHei"/>
+                <a:cs typeface="Microsoft YaHei"/>
+              </a:rPr>
+              <a:t>0 确认门</a:t>
+            </a:r>
+            <a:r>
+              <a:rPr sz="1000" b="0">
+                <a:solidFill>
+                  <a:srgbClr val="C0612C"/>
+                </a:solidFill>
+                <a:latin typeface="Consolas"/>
+                <a:ea typeface="Microsoft YaHei"/>
+                <a:cs typeface="Microsoft YaHei"/>
+              </a:rPr>
+              <a:t>　grill + plan</a:t>
+            </a:r>
+          </a:p>
+        </p:txBody>
+      </p:sp>
+      <p:sp>
+        <p:nvSpPr>
+          <p:cNvPr id="9" name="TextBox 8"/>
+          <p:cNvSpPr txBox="1"/>
+          <p:nvPr/>
+        </p:nvSpPr>
+        <p:spPr>
+          <a:xfrm>
+            <a:off x="768096" y="3493007"/>
+            <a:ext cx="2990088" cy="256032"/>
+          </a:xfrm>
+          <a:prstGeom prst="rect">
+            <a:avLst/>
+          </a:prstGeom>
+          <a:noFill/>
+        </p:spPr>
+        <p:txBody>
+          <a:bodyPr wrap="square" anchor="ctr" lIns="0" tIns="0" rIns="0" bIns="0">
+            <a:noAutofit/>
+          </a:bodyPr>
+          <a:lstStyle/>
+          <a:p>
+            <a:pPr algn="l" latinLnBrk="0">
+              <a:lnSpc>
+                <a:spcPct val="100000"/>
+              </a:lnSpc>
+              <a:spcBef>
+                <a:spcPts val="0"/>
+              </a:spcBef>
+              <a:spcAft>
+                <a:spcPts val="0"/>
+              </a:spcAft>
+            </a:pPr>
+            <a:r>
+              <a:rPr sz="1050" b="0">
+                <a:solidFill>
+                  <a:srgbClr val="35424F"/>
+                </a:solidFill>
+                <a:latin typeface="Microsoft YaHei"/>
+                <a:ea typeface="Microsoft YaHei"/>
+                <a:cs typeface="Microsoft YaHei"/>
+              </a:rPr>
+              <a:t>动手前先问清需求，至少比两个方案</a:t>
+            </a:r>
+          </a:p>
+        </p:txBody>
+      </p:sp>
+      <p:sp>
+        <p:nvSpPr>
+          <p:cNvPr id="10" name="TextBox 9"/>
+          <p:cNvSpPr txBox="1"/>
+          <p:nvPr/>
+        </p:nvSpPr>
+        <p:spPr>
+          <a:xfrm>
+            <a:off x="768096" y="4041648"/>
+            <a:ext cx="2990088" cy="274320"/>
+          </a:xfrm>
+          <a:prstGeom prst="rect">
+            <a:avLst/>
+          </a:prstGeom>
+          <a:noFill/>
+        </p:spPr>
+        <p:txBody>
+          <a:bodyPr wrap="square" anchor="ctr" lIns="0" tIns="0" rIns="0" bIns="0">
+            <a:noAutofit/>
+          </a:bodyPr>
+          <a:lstStyle/>
+          <a:p>
+            <a:pPr algn="l" latinLnBrk="0">
+              <a:lnSpc>
+                <a:spcPct val="100000"/>
+              </a:lnSpc>
+              <a:spcBef>
+                <a:spcPts val="0"/>
+              </a:spcBef>
+              <a:spcAft>
+                <a:spcPts val="0"/>
+              </a:spcAft>
+            </a:pPr>
+            <a:r>
+              <a:rPr sz="1250" b="1">
+                <a:solidFill>
+                  <a:srgbClr val="16202A"/>
+                </a:solidFill>
+                <a:latin typeface="Microsoft YaHei"/>
+                <a:ea typeface="Microsoft YaHei"/>
+                <a:cs typeface="Microsoft YaHei"/>
+              </a:rPr>
+              <a:t>1 生成</a:t>
+            </a:r>
+            <a:r>
+              <a:rPr sz="1000" b="0">
+                <a:solidFill>
+                  <a:srgbClr val="C0612C"/>
+                </a:solidFill>
+                <a:latin typeface="Consolas"/>
+                <a:ea typeface="Microsoft YaHei"/>
+                <a:cs typeface="Microsoft YaHei"/>
+              </a:rPr>
+              <a:t>　write kernel</a:t>
+            </a:r>
+          </a:p>
+        </p:txBody>
+      </p:sp>
+      <p:sp>
+        <p:nvSpPr>
+          <p:cNvPr id="11" name="TextBox 10"/>
+          <p:cNvSpPr txBox="1"/>
+          <p:nvPr/>
+        </p:nvSpPr>
+        <p:spPr>
+          <a:xfrm>
+            <a:off x="768096" y="4315968"/>
+            <a:ext cx="2990088" cy="256032"/>
+          </a:xfrm>
+          <a:prstGeom prst="rect">
+            <a:avLst/>
+          </a:prstGeom>
+          <a:noFill/>
+        </p:spPr>
+        <p:txBody>
+          <a:bodyPr wrap="square" anchor="ctr" lIns="0" tIns="0" rIns="0" bIns="0">
+            <a:noAutofit/>
+          </a:bodyPr>
+          <a:lstStyle/>
+          <a:p>
+            <a:pPr algn="l" latinLnBrk="0">
+              <a:lnSpc>
+                <a:spcPct val="100000"/>
+              </a:lnSpc>
+              <a:spcBef>
+                <a:spcPts val="0"/>
+              </a:spcBef>
+              <a:spcAft>
+                <a:spcPts val="0"/>
+              </a:spcAft>
+            </a:pPr>
+            <a:r>
+              <a:rPr sz="1050" b="0">
+                <a:solidFill>
+                  <a:srgbClr val="35424F"/>
+                </a:solidFill>
+                <a:latin typeface="Microsoft YaHei"/>
+                <a:ea typeface="Microsoft YaHei"/>
+                <a:cs typeface="Microsoft YaHei"/>
+              </a:rPr>
+              <a:t>照硬件说明卡写出 .xpu 内核</a:t>
+            </a:r>
+          </a:p>
+        </p:txBody>
+      </p:sp>
+      <p:sp>
+        <p:nvSpPr>
+          <p:cNvPr id="12" name="Rectangle 11"/>
+          <p:cNvSpPr/>
+          <p:nvPr/>
+        </p:nvSpPr>
+        <p:spPr>
+          <a:xfrm>
+            <a:off x="4526279" y="2560320"/>
+            <a:ext cx="3429000" cy="2212848"/>
+          </a:xfrm>
+          <a:prstGeom prst="rect">
+            <a:avLst/>
+          </a:prstGeom>
+          <a:solidFill>
+            <a:srgbClr val="F6F7F9"/>
+          </a:solidFill>
+          <a:ln>
+            <a:noFill/>
+          </a:ln>
+        </p:spPr>
+        <p:txBody>
+          <a:bodyPr rtlCol="0" anchor="ctr"/>
+          <a:lstStyle/>
+          <a:p>
+            <a:pPr algn="ctr"/>
+          </a:p>
+        </p:txBody>
+      </p:sp>
+      <p:sp>
+        <p:nvSpPr>
+          <p:cNvPr id="13" name="TextBox 12"/>
+          <p:cNvSpPr txBox="1"/>
+          <p:nvPr/>
+        </p:nvSpPr>
+        <p:spPr>
+          <a:xfrm>
+            <a:off x="4745736" y="2688336"/>
+            <a:ext cx="2990088" cy="292608"/>
+          </a:xfrm>
+          <a:prstGeom prst="rect">
+            <a:avLst/>
+          </a:prstGeom>
+          <a:noFill/>
+        </p:spPr>
+        <p:txBody>
+          <a:bodyPr wrap="square" anchor="ctr" lIns="0" tIns="0" rIns="0" bIns="0">
+            <a:noAutofit/>
+          </a:bodyPr>
+          <a:lstStyle/>
+          <a:p>
+            <a:pPr algn="l" latinLnBrk="0">
+              <a:lnSpc>
+                <a:spcPct val="100000"/>
+              </a:lnSpc>
+              <a:spcBef>
+                <a:spcPts val="0"/>
+              </a:spcBef>
+              <a:spcAft>
+                <a:spcPts val="0"/>
+              </a:spcAft>
+            </a:pPr>
+            <a:r>
+              <a:rPr sz="1300" b="1">
+                <a:solidFill>
+                  <a:srgbClr val="66727F"/>
+                </a:solidFill>
+                <a:latin typeface="Consolas"/>
+                <a:ea typeface="Microsoft YaHei"/>
+                <a:cs typeface="Microsoft YaHei"/>
+              </a:rPr>
+              <a:t>harness/</a:t>
+            </a:r>
+            <a:r>
+              <a:rPr sz="1300" b="1">
+                <a:solidFill>
+                  <a:srgbClr val="16202A"/>
+                </a:solidFill>
+                <a:latin typeface="Microsoft YaHei"/>
+                <a:ea typeface="Microsoft YaHei"/>
+                <a:cs typeface="Microsoft YaHei"/>
+              </a:rPr>
+              <a:t>　确定性评测，不是 agent</a:t>
+            </a:r>
+          </a:p>
+        </p:txBody>
+      </p:sp>
+      <p:sp>
+        <p:nvSpPr>
+          <p:cNvPr id="14" name="TextBox 13"/>
+          <p:cNvSpPr txBox="1"/>
+          <p:nvPr/>
+        </p:nvSpPr>
+        <p:spPr>
+          <a:xfrm>
+            <a:off x="4745736" y="3090672"/>
+            <a:ext cx="2990088" cy="274320"/>
+          </a:xfrm>
+          <a:prstGeom prst="rect">
+            <a:avLst/>
+          </a:prstGeom>
+          <a:noFill/>
+        </p:spPr>
+        <p:txBody>
+          <a:bodyPr wrap="square" anchor="ctr" lIns="0" tIns="0" rIns="0" bIns="0">
+            <a:noAutofit/>
+          </a:bodyPr>
+          <a:lstStyle/>
+          <a:p>
+            <a:pPr algn="l" latinLnBrk="0">
+              <a:lnSpc>
+                <a:spcPct val="100000"/>
+              </a:lnSpc>
+              <a:spcBef>
+                <a:spcPts val="0"/>
+              </a:spcBef>
+              <a:spcAft>
+                <a:spcPts val="0"/>
+              </a:spcAft>
+            </a:pPr>
+            <a:r>
+              <a:rPr sz="1150" b="1">
+                <a:solidFill>
+                  <a:srgbClr val="16202A"/>
+                </a:solidFill>
+                <a:latin typeface="Microsoft YaHei"/>
+                <a:ea typeface="Microsoft YaHei"/>
+                <a:cs typeface="Microsoft YaHei"/>
+              </a:rPr>
+              <a:t>L0 编译</a:t>
+            </a:r>
+            <a:r>
+              <a:rPr sz="1050" b="0">
+                <a:solidFill>
+                  <a:srgbClr val="35424F"/>
+                </a:solidFill>
+                <a:latin typeface="Microsoft YaHei"/>
+                <a:ea typeface="Microsoft YaHei"/>
+                <a:cs typeface="Microsoft YaHei"/>
+              </a:rPr>
+              <a:t>　编译并拉起，跑通才往下</a:t>
+            </a:r>
+          </a:p>
+        </p:txBody>
+      </p:sp>
+      <p:sp>
+        <p:nvSpPr>
+          <p:cNvPr id="15" name="TextBox 14"/>
+          <p:cNvSpPr txBox="1"/>
+          <p:nvPr/>
+        </p:nvSpPr>
+        <p:spPr>
+          <a:xfrm>
+            <a:off x="4745736" y="3438144"/>
+            <a:ext cx="2990088" cy="274320"/>
+          </a:xfrm>
+          <a:prstGeom prst="rect">
+            <a:avLst/>
+          </a:prstGeom>
+          <a:noFill/>
+        </p:spPr>
+        <p:txBody>
+          <a:bodyPr wrap="square" anchor="ctr" lIns="0" tIns="0" rIns="0" bIns="0">
+            <a:noAutofit/>
+          </a:bodyPr>
+          <a:lstStyle/>
+          <a:p>
+            <a:pPr algn="l" latinLnBrk="0">
+              <a:lnSpc>
+                <a:spcPct val="100000"/>
+              </a:lnSpc>
+              <a:spcBef>
+                <a:spcPts val="0"/>
+              </a:spcBef>
+              <a:spcAft>
+                <a:spcPts val="0"/>
+              </a:spcAft>
+            </a:pPr>
+            <a:r>
+              <a:rPr sz="1150" b="1">
+                <a:solidFill>
+                  <a:srgbClr val="16202A"/>
+                </a:solidFill>
+                <a:latin typeface="Microsoft YaHei"/>
+                <a:ea typeface="Microsoft YaHei"/>
+                <a:cs typeface="Microsoft YaHei"/>
+              </a:rPr>
+              <a:t>L1 精度</a:t>
+            </a:r>
+            <a:r>
+              <a:rPr sz="1050" b="0">
+                <a:solidFill>
+                  <a:srgbClr val="35424F"/>
+                </a:solidFill>
+                <a:latin typeface="Microsoft YaHei"/>
+                <a:ea typeface="Microsoft YaHei"/>
+                <a:cs typeface="Microsoft YaHei"/>
+              </a:rPr>
+              <a:t>　多形状多精度对 CPU golden</a:t>
+            </a:r>
+          </a:p>
+        </p:txBody>
+      </p:sp>
+      <p:sp>
+        <p:nvSpPr>
+          <p:cNvPr id="16" name="TextBox 15"/>
+          <p:cNvSpPr txBox="1"/>
+          <p:nvPr/>
+        </p:nvSpPr>
+        <p:spPr>
+          <a:xfrm>
+            <a:off x="4745736" y="3785615"/>
+            <a:ext cx="2990088" cy="274320"/>
+          </a:xfrm>
+          <a:prstGeom prst="rect">
+            <a:avLst/>
+          </a:prstGeom>
+          <a:noFill/>
+        </p:spPr>
+        <p:txBody>
+          <a:bodyPr wrap="square" anchor="ctr" lIns="0" tIns="0" rIns="0" bIns="0">
+            <a:noAutofit/>
+          </a:bodyPr>
+          <a:lstStyle/>
+          <a:p>
+            <a:pPr algn="l" latinLnBrk="0">
+              <a:lnSpc>
+                <a:spcPct val="100000"/>
+              </a:lnSpc>
+              <a:spcBef>
+                <a:spcPts val="0"/>
+              </a:spcBef>
+              <a:spcAft>
+                <a:spcPts val="0"/>
+              </a:spcAft>
+            </a:pPr>
+            <a:r>
+              <a:rPr sz="1150" b="1">
+                <a:solidFill>
+                  <a:srgbClr val="16202A"/>
+                </a:solidFill>
+                <a:latin typeface="Microsoft YaHei"/>
+                <a:ea typeface="Microsoft YaHei"/>
+                <a:cs typeface="Microsoft YaHei"/>
+              </a:rPr>
+              <a:t>bench 收益</a:t>
+            </a:r>
+            <a:r>
+              <a:rPr sz="1050" b="0">
+                <a:solidFill>
+                  <a:srgbClr val="35424F"/>
+                </a:solidFill>
+                <a:latin typeface="Microsoft YaHei"/>
+                <a:ea typeface="Microsoft YaHei"/>
+                <a:cs typeface="Microsoft YaHei"/>
+              </a:rPr>
+              <a:t>　真机答「快了多少」</a:t>
+            </a:r>
+          </a:p>
+        </p:txBody>
+      </p:sp>
+      <p:sp>
+        <p:nvSpPr>
+          <p:cNvPr id="17" name="TextBox 16"/>
+          <p:cNvSpPr txBox="1"/>
+          <p:nvPr/>
+        </p:nvSpPr>
+        <p:spPr>
+          <a:xfrm>
+            <a:off x="4745736" y="4133087"/>
+            <a:ext cx="2990088" cy="274320"/>
+          </a:xfrm>
+          <a:prstGeom prst="rect">
+            <a:avLst/>
+          </a:prstGeom>
+          <a:noFill/>
+        </p:spPr>
+        <p:txBody>
+          <a:bodyPr wrap="square" anchor="ctr" lIns="0" tIns="0" rIns="0" bIns="0">
+            <a:noAutofit/>
+          </a:bodyPr>
+          <a:lstStyle/>
+          <a:p>
+            <a:pPr algn="l" latinLnBrk="0">
+              <a:lnSpc>
+                <a:spcPct val="100000"/>
+              </a:lnSpc>
+              <a:spcBef>
+                <a:spcPts val="0"/>
+              </a:spcBef>
+              <a:spcAft>
+                <a:spcPts val="0"/>
+              </a:spcAft>
+            </a:pPr>
+            <a:r>
+              <a:rPr sz="1150" b="1">
+                <a:solidFill>
+                  <a:srgbClr val="16202A"/>
+                </a:solidFill>
+                <a:latin typeface="Microsoft YaHei"/>
+                <a:ea typeface="Microsoft YaHei"/>
+                <a:cs typeface="Microsoft YaHei"/>
+              </a:rPr>
+              <a:t>profile 机制</a:t>
+            </a:r>
+            <a:r>
+              <a:rPr sz="1050" b="0">
+                <a:solidFill>
+                  <a:srgbClr val="35424F"/>
+                </a:solidFill>
+                <a:latin typeface="Microsoft YaHei"/>
+                <a:ea typeface="Microsoft YaHei"/>
+                <a:cs typeface="Microsoft YaHei"/>
+              </a:rPr>
+              <a:t>　模拟器答「为什么慢」</a:t>
+            </a:r>
+          </a:p>
+        </p:txBody>
+      </p:sp>
+      <p:cxnSp>
+        <p:nvCxnSpPr>
+          <p:cNvPr id="18" name="Connector 17"/>
+          <p:cNvCxnSpPr/>
+          <p:nvPr/>
+        </p:nvCxnSpPr>
+        <p:spPr>
+          <a:xfrm>
+            <a:off x="4745736" y="4425696"/>
+            <a:ext cx="2990087" cy="0"/>
+          </a:xfrm>
+          <a:prstGeom prst="line">
+            <a:avLst/>
+          </a:prstGeom>
+          <a:ln w="12700">
+            <a:solidFill>
+              <a:srgbClr val="DDE2E7"/>
+            </a:solidFill>
+          </a:ln>
+        </p:spPr>
+      </p:cxnSp>
+      <p:sp>
+        <p:nvSpPr>
+          <p:cNvPr id="19" name="TextBox 18"/>
+          <p:cNvSpPr txBox="1"/>
+          <p:nvPr/>
+        </p:nvSpPr>
+        <p:spPr>
+          <a:xfrm>
+            <a:off x="4745736" y="4462272"/>
+            <a:ext cx="2990088" cy="256032"/>
+          </a:xfrm>
+          <a:prstGeom prst="rect">
+            <a:avLst/>
+          </a:prstGeom>
+          <a:noFill/>
+        </p:spPr>
+        <p:txBody>
+          <a:bodyPr wrap="square" anchor="ctr" lIns="0" tIns="0" rIns="0" bIns="0">
+            <a:noAutofit/>
+          </a:bodyPr>
+          <a:lstStyle/>
+          <a:p>
+            <a:pPr algn="l" latinLnBrk="0">
+              <a:lnSpc>
+                <a:spcPct val="100000"/>
+              </a:lnSpc>
+              <a:spcBef>
+                <a:spcPts val="0"/>
+              </a:spcBef>
+              <a:spcAft>
+                <a:spcPts val="0"/>
+              </a:spcAft>
+            </a:pPr>
+            <a:r>
+              <a:rPr sz="1000" b="0">
+                <a:solidFill>
+                  <a:srgbClr val="66727F"/>
+                </a:solidFill>
+                <a:latin typeface="Microsoft YaHei"/>
+                <a:ea typeface="Microsoft YaHei"/>
+                <a:cs typeface="Microsoft YaHei"/>
+              </a:rPr>
+              <a:t>机制看模拟器 · 收益看真机，以真机为准</a:t>
+            </a:r>
+          </a:p>
+        </p:txBody>
+      </p:sp>
+      <p:sp>
+        <p:nvSpPr>
+          <p:cNvPr id="20" name="Freeform 19"/>
+          <p:cNvSpPr/>
+          <p:nvPr/>
+        </p:nvSpPr>
+        <p:spPr>
+          <a:xfrm>
+            <a:off x="2263140" y="2304287"/>
+            <a:ext cx="3977639" cy="256033"/>
+          </a:xfrm>
+          <a:custGeom>
+            <a:avLst/>
+            <a:gdLst/>
+            <a:ahLst/>
+            <a:cxnLst/>
+            <a:rect l="l" t="t" r="r" b="b"/>
+            <a:pathLst>
+              <a:path w="3977639" h="256033">
+                <a:moveTo>
+                  <a:pt x="0" y="256033"/>
+                </a:moveTo>
+                <a:lnTo>
+                  <a:pt x="0" y="0"/>
+                </a:lnTo>
+                <a:lnTo>
+                  <a:pt x="3977639" y="0"/>
+                </a:lnTo>
+                <a:lnTo>
+                  <a:pt x="3977639" y="219457"/>
+                </a:lnTo>
+              </a:path>
+            </a:pathLst>
+          </a:custGeom>
+          <a:noFill/>
+          <a:ln w="19050">
+            <a:solidFill>
+              <a:srgbClr val="C0612C"/>
+            </a:solidFill>
+            <a:tailEnd type="triangle" w="med" len="med"/>
+          </a:ln>
+        </p:spPr>
+        <p:txBody>
+          <a:bodyPr rtlCol="0" anchor="ctr"/>
+          <a:lstStyle/>
+          <a:p>
+            <a:pPr algn="ctr"/>
+          </a:p>
+        </p:txBody>
+      </p:sp>
+      <p:sp>
+        <p:nvSpPr>
+          <p:cNvPr id="21" name="TextBox 20"/>
+          <p:cNvSpPr txBox="1"/>
+          <p:nvPr/>
+        </p:nvSpPr>
+        <p:spPr>
+          <a:xfrm>
+            <a:off x="2263140" y="1993392"/>
+            <a:ext cx="3977639" cy="274320"/>
+          </a:xfrm>
+          <a:prstGeom prst="rect">
+            <a:avLst/>
+          </a:prstGeom>
+          <a:noFill/>
+        </p:spPr>
+        <p:txBody>
+          <a:bodyPr wrap="square" anchor="ctr" lIns="0" tIns="0" rIns="0" bIns="0">
+            <a:noAutofit/>
+          </a:bodyPr>
+          <a:lstStyle/>
           <a:p>
             <a:pPr algn="ctr" latinLnBrk="0">
               <a:lnSpc>
@@ -3933,17 +4686,90 @@
               </a:spcAft>
             </a:pPr>
             <a:r>
-              <a:rPr sz="1300" b="1">
-                <a:solidFill>
-                  <a:srgbClr val="16202A"/>
+              <a:rPr sz="1050" b="0">
+                <a:solidFill>
+                  <a:srgbClr val="35424F"/>
                 </a:solidFill>
                 <a:latin typeface="Microsoft YaHei"/>
                 <a:ea typeface="Microsoft YaHei"/>
                 <a:cs typeface="Microsoft YaHei"/>
               </a:rPr>
-              <a:t>一个算子</a:t>
-            </a:r>
-          </a:p>
+              <a:t>交出 .xpu 内核</a:t>
+            </a:r>
+          </a:p>
+        </p:txBody>
+      </p:sp>
+      <p:sp>
+        <p:nvSpPr>
+          <p:cNvPr id="22" name="Freeform 21"/>
+          <p:cNvSpPr/>
+          <p:nvPr/>
+        </p:nvSpPr>
+        <p:spPr>
+          <a:xfrm>
+            <a:off x="2263140" y="4773168"/>
+            <a:ext cx="3977639" cy="256032"/>
+          </a:xfrm>
+          <a:custGeom>
+            <a:avLst/>
+            <a:gdLst/>
+            <a:ahLst/>
+            <a:cxnLst/>
+            <a:rect l="l" t="t" r="r" b="b"/>
+            <a:pathLst>
+              <a:path w="3977639" h="256032">
+                <a:moveTo>
+                  <a:pt x="3977639" y="0"/>
+                </a:moveTo>
+                <a:lnTo>
+                  <a:pt x="3977639" y="256032"/>
+                </a:lnTo>
+                <a:lnTo>
+                  <a:pt x="0" y="256032"/>
+                </a:lnTo>
+                <a:lnTo>
+                  <a:pt x="0" y="36576"/>
+                </a:lnTo>
+              </a:path>
+            </a:pathLst>
+          </a:custGeom>
+          <a:noFill/>
+          <a:ln w="19050">
+            <a:solidFill>
+              <a:srgbClr val="C0612C"/>
+            </a:solidFill>
+            <a:tailEnd type="triangle" w="med" len="med"/>
+          </a:ln>
+        </p:spPr>
+        <p:txBody>
+          <a:bodyPr rtlCol="0" anchor="ctr"/>
+          <a:lstStyle/>
+          <a:p>
+            <a:pPr algn="ctr"/>
+          </a:p>
+        </p:txBody>
+      </p:sp>
+      <p:sp>
+        <p:nvSpPr>
+          <p:cNvPr id="23" name="TextBox 22"/>
+          <p:cNvSpPr txBox="1"/>
+          <p:nvPr/>
+        </p:nvSpPr>
+        <p:spPr>
+          <a:xfrm>
+            <a:off x="2263140" y="5065776"/>
+            <a:ext cx="3977639" cy="274320"/>
+          </a:xfrm>
+          <a:prstGeom prst="rect">
+            <a:avLst/>
+          </a:prstGeom>
+          <a:noFill/>
+        </p:spPr>
+        <p:txBody>
+          <a:bodyPr wrap="square" anchor="ctr" lIns="0" tIns="0" rIns="0" bIns="0">
+            <a:noAutofit/>
+          </a:bodyPr>
+          <a:lstStyle/>
           <a:p>
             <a:pPr algn="ctr" latinLnBrk="0">
               <a:lnSpc>
@@ -3957,51 +4783,73 @@
               </a:spcAft>
             </a:pPr>
             <a:r>
-              <a:rPr sz="1300" b="1">
-                <a:solidFill>
-                  <a:srgbClr val="16202A"/>
+              <a:rPr sz="1050" b="0">
+                <a:solidFill>
+                  <a:srgbClr val="35424F"/>
                 </a:solidFill>
                 <a:latin typeface="Microsoft YaHei"/>
                 <a:ea typeface="Microsoft YaHei"/>
                 <a:cs typeface="Microsoft YaHei"/>
               </a:rPr>
-              <a:t>最多 8 轮</a:t>
-            </a:r>
-          </a:p>
-        </p:txBody>
-      </p:sp>
-      <p:sp>
-        <p:nvSpPr>
-          <p:cNvPr id="8" name="Rounded Rectangle 7"/>
+              <a:t>结构化反馈：打分 + 模拟器机制证据，带进下一轮</a:t>
+            </a:r>
+          </a:p>
+        </p:txBody>
+      </p:sp>
+      <p:sp>
+        <p:nvSpPr>
+          <p:cNvPr id="24" name="Rectangle 23"/>
           <p:cNvSpPr/>
           <p:nvPr/>
         </p:nvSpPr>
         <p:spPr>
           <a:xfrm>
-            <a:off x="3337559" y="2066543"/>
-            <a:ext cx="1737360" cy="676656"/>
-          </a:xfrm>
-          <a:prstGeom prst="roundRect">
-            <a:avLst>
-              <a:gd name="adj" fmla="val 35000"/>
-            </a:avLst>
+            <a:off x="548640" y="5449824"/>
+            <a:ext cx="7406640" cy="548640"/>
+          </a:xfrm>
+          <a:prstGeom prst="rect">
+            <a:avLst/>
           </a:prstGeom>
           <a:solidFill>
             <a:srgbClr val="FFFFFF"/>
           </a:solidFill>
-          <a:ln w="15875">
+          <a:ln w="9525">
             <a:solidFill>
-              <a:srgbClr val="C0612C"/>
+              <a:srgbClr val="DDE2E7"/>
             </a:solidFill>
           </a:ln>
         </p:spPr>
         <p:txBody>
-          <a:bodyPr rtlCol="0" anchor="ctr" wrap="square" lIns="45720" tIns="18288" rIns="45720" bIns="18288">
+          <a:bodyPr rtlCol="0" anchor="ctr"/>
+          <a:lstStyle/>
+          <a:p>
+            <a:pPr algn="ctr"/>
+          </a:p>
+        </p:txBody>
+      </p:sp>
+      <p:sp>
+        <p:nvSpPr>
+          <p:cNvPr id="25" name="TextBox 24"/>
+          <p:cNvSpPr txBox="1"/>
+          <p:nvPr/>
+        </p:nvSpPr>
+        <p:spPr>
+          <a:xfrm>
+            <a:off x="768096" y="5522976"/>
+            <a:ext cx="6967727" cy="438912"/>
+          </a:xfrm>
+          <a:prstGeom prst="rect">
+            <a:avLst/>
+          </a:prstGeom>
+          <a:noFill/>
+        </p:spPr>
+        <p:txBody>
+          <a:bodyPr wrap="square" anchor="t" lIns="0" tIns="0" rIns="0" bIns="0">
             <a:noAutofit/>
           </a:bodyPr>
           <a:lstStyle/>
           <a:p>
-            <a:pPr algn="ctr" latinLnBrk="0">
+            <a:pPr algn="l" latinLnBrk="0">
               <a:lnSpc>
                 <a:spcPct val="100000"/>
               </a:lnSpc>
@@ -4013,18 +4861,18 @@
               </a:spcAft>
             </a:pPr>
             <a:r>
-              <a:rPr sz="1250" b="1">
-                <a:solidFill>
-                  <a:srgbClr val="C0612C"/>
-                </a:solidFill>
-                <a:latin typeface="Arial"/>
+              <a:rPr sz="1050" b="1">
+                <a:solidFill>
+                  <a:srgbClr val="16202A"/>
+                </a:solidFill>
+                <a:latin typeface="Consolas"/>
                 <a:ea typeface="Microsoft YaHei"/>
                 <a:cs typeface="Microsoft YaHei"/>
               </a:rPr>
-              <a:t>1 </a:t>
-            </a:r>
-            <a:r>
-              <a:rPr sz="1250" b="1">
+              <a:t>backend/</a:t>
+            </a:r>
+            <a:r>
+              <a:rPr sz="1050" b="1">
                 <a:solidFill>
                   <a:srgbClr val="16202A"/>
                 </a:solidFill>
@@ -4032,614 +4880,9 @@
                 <a:ea typeface="Microsoft YaHei"/>
                 <a:cs typeface="Microsoft YaHei"/>
               </a:rPr>
-              <a:t>生成</a:t>
-            </a:r>
-          </a:p>
-          <a:p>
-            <a:pPr algn="ctr" latinLnBrk="0">
-              <a:lnSpc>
-                <a:spcPct val="100000"/>
-              </a:lnSpc>
-              <a:spcBef>
-                <a:spcPts val="0"/>
-              </a:spcBef>
-              <a:spcAft>
-                <a:spcPts val="0"/>
-              </a:spcAft>
-            </a:pPr>
-            <a:r>
-              <a:rPr sz="1000" b="0">
-                <a:solidFill>
-                  <a:srgbClr val="66727F"/>
-                </a:solidFill>
-                <a:latin typeface="Microsoft YaHei"/>
-                <a:ea typeface="Microsoft YaHei"/>
-                <a:cs typeface="Microsoft YaHei"/>
-              </a:rPr>
-              <a:t>照硬件说明卡写内核</a:t>
-            </a:r>
-          </a:p>
-        </p:txBody>
-      </p:sp>
-      <p:sp>
-        <p:nvSpPr>
-          <p:cNvPr id="9" name="Rounded Rectangle 8"/>
-          <p:cNvSpPr/>
-          <p:nvPr/>
-        </p:nvSpPr>
-        <p:spPr>
-          <a:xfrm>
-            <a:off x="6033462" y="3279666"/>
-            <a:ext cx="1737360" cy="676656"/>
-          </a:xfrm>
-          <a:prstGeom prst="roundRect">
-            <a:avLst>
-              <a:gd name="adj" fmla="val 35000"/>
-            </a:avLst>
-          </a:prstGeom>
-          <a:solidFill>
-            <a:srgbClr val="FFFFFF"/>
-          </a:solidFill>
-          <a:ln w="15875">
-            <a:solidFill>
-              <a:srgbClr val="C0612C"/>
-            </a:solidFill>
-          </a:ln>
-        </p:spPr>
-        <p:txBody>
-          <a:bodyPr rtlCol="0" anchor="ctr" wrap="square" lIns="45720" tIns="18288" rIns="45720" bIns="18288">
-            <a:noAutofit/>
-          </a:bodyPr>
-          <a:lstStyle/>
-          <a:p>
-            <a:pPr algn="ctr" latinLnBrk="0">
-              <a:lnSpc>
-                <a:spcPct val="100000"/>
-              </a:lnSpc>
-              <a:spcBef>
-                <a:spcPts val="0"/>
-              </a:spcBef>
-              <a:spcAft>
-                <a:spcPts val="200"/>
-              </a:spcAft>
-            </a:pPr>
-            <a:r>
-              <a:rPr sz="1250" b="1">
-                <a:solidFill>
-                  <a:srgbClr val="C0612C"/>
-                </a:solidFill>
-                <a:latin typeface="Arial"/>
-                <a:ea typeface="Microsoft YaHei"/>
-                <a:cs typeface="Microsoft YaHei"/>
-              </a:rPr>
-              <a:t>2 </a:t>
-            </a:r>
-            <a:r>
-              <a:rPr sz="1250" b="1">
-                <a:solidFill>
-                  <a:srgbClr val="16202A"/>
-                </a:solidFill>
-                <a:latin typeface="Microsoft YaHei"/>
-                <a:ea typeface="Microsoft YaHei"/>
-                <a:cs typeface="Microsoft YaHei"/>
-              </a:rPr>
-              <a:t>编译</a:t>
-            </a:r>
-          </a:p>
-          <a:p>
-            <a:pPr algn="ctr" latinLnBrk="0">
-              <a:lnSpc>
-                <a:spcPct val="100000"/>
-              </a:lnSpc>
-              <a:spcBef>
-                <a:spcPts val="0"/>
-              </a:spcBef>
-              <a:spcAft>
-                <a:spcPts val="0"/>
-              </a:spcAft>
-            </a:pPr>
-            <a:r>
-              <a:rPr sz="1000" b="0">
-                <a:solidFill>
-                  <a:srgbClr val="66727F"/>
-                </a:solidFill>
-                <a:latin typeface="Microsoft YaHei"/>
-                <a:ea typeface="Microsoft YaHei"/>
-                <a:cs typeface="Microsoft YaHei"/>
-              </a:rPr>
-              <a:t>编译并拉起程序</a:t>
-            </a:r>
-          </a:p>
-        </p:txBody>
-      </p:sp>
-      <p:sp>
-        <p:nvSpPr>
-          <p:cNvPr id="10" name="Rounded Rectangle 9"/>
-          <p:cNvSpPr/>
-          <p:nvPr/>
-        </p:nvSpPr>
-        <p:spPr>
-          <a:xfrm>
-            <a:off x="5003719" y="5242541"/>
-            <a:ext cx="1737360" cy="676656"/>
-          </a:xfrm>
-          <a:prstGeom prst="roundRect">
-            <a:avLst>
-              <a:gd name="adj" fmla="val 35000"/>
-            </a:avLst>
-          </a:prstGeom>
-          <a:solidFill>
-            <a:srgbClr val="FFFFFF"/>
-          </a:solidFill>
-          <a:ln w="15875">
-            <a:solidFill>
-              <a:srgbClr val="C0612C"/>
-            </a:solidFill>
-          </a:ln>
-        </p:spPr>
-        <p:txBody>
-          <a:bodyPr rtlCol="0" anchor="ctr" wrap="square" lIns="45720" tIns="18288" rIns="45720" bIns="18288">
-            <a:noAutofit/>
-          </a:bodyPr>
-          <a:lstStyle/>
-          <a:p>
-            <a:pPr algn="ctr" latinLnBrk="0">
-              <a:lnSpc>
-                <a:spcPct val="100000"/>
-              </a:lnSpc>
-              <a:spcBef>
-                <a:spcPts val="0"/>
-              </a:spcBef>
-              <a:spcAft>
-                <a:spcPts val="200"/>
-              </a:spcAft>
-            </a:pPr>
-            <a:r>
-              <a:rPr sz="1250" b="1">
-                <a:solidFill>
-                  <a:srgbClr val="C0612C"/>
-                </a:solidFill>
-                <a:latin typeface="Arial"/>
-                <a:ea typeface="Microsoft YaHei"/>
-                <a:cs typeface="Microsoft YaHei"/>
-              </a:rPr>
-              <a:t>3 </a:t>
-            </a:r>
-            <a:r>
-              <a:rPr sz="1250" b="1">
-                <a:solidFill>
-                  <a:srgbClr val="16202A"/>
-                </a:solidFill>
-                <a:latin typeface="Microsoft YaHei"/>
-                <a:ea typeface="Microsoft YaHei"/>
-                <a:cs typeface="Microsoft YaHei"/>
-              </a:rPr>
-              <a:t>对数值</a:t>
-            </a:r>
-          </a:p>
-          <a:p>
-            <a:pPr algn="ctr" latinLnBrk="0">
-              <a:lnSpc>
-                <a:spcPct val="100000"/>
-              </a:lnSpc>
-              <a:spcBef>
-                <a:spcPts val="0"/>
-              </a:spcBef>
-              <a:spcAft>
-                <a:spcPts val="0"/>
-              </a:spcAft>
-            </a:pPr>
-            <a:r>
-              <a:rPr sz="1000" b="0">
-                <a:solidFill>
-                  <a:srgbClr val="66727F"/>
-                </a:solidFill>
-                <a:latin typeface="Microsoft YaHei"/>
-                <a:ea typeface="Microsoft YaHei"/>
-                <a:cs typeface="Microsoft YaHei"/>
-              </a:rPr>
-              <a:t>多形状多精度对 golden</a:t>
-            </a:r>
-          </a:p>
-        </p:txBody>
-      </p:sp>
-      <p:sp>
-        <p:nvSpPr>
-          <p:cNvPr id="11" name="Rounded Rectangle 10"/>
-          <p:cNvSpPr/>
-          <p:nvPr/>
-        </p:nvSpPr>
-        <p:spPr>
-          <a:xfrm>
-            <a:off x="1671400" y="5242541"/>
-            <a:ext cx="1737360" cy="676656"/>
-          </a:xfrm>
-          <a:prstGeom prst="roundRect">
-            <a:avLst>
-              <a:gd name="adj" fmla="val 35000"/>
-            </a:avLst>
-          </a:prstGeom>
-          <a:solidFill>
-            <a:srgbClr val="FFFFFF"/>
-          </a:solidFill>
-          <a:ln w="15875">
-            <a:solidFill>
-              <a:srgbClr val="C0612C"/>
-            </a:solidFill>
-          </a:ln>
-        </p:spPr>
-        <p:txBody>
-          <a:bodyPr rtlCol="0" anchor="ctr" wrap="square" lIns="45720" tIns="18288" rIns="45720" bIns="18288">
-            <a:noAutofit/>
-          </a:bodyPr>
-          <a:lstStyle/>
-          <a:p>
-            <a:pPr algn="ctr" latinLnBrk="0">
-              <a:lnSpc>
-                <a:spcPct val="100000"/>
-              </a:lnSpc>
-              <a:spcBef>
-                <a:spcPts val="0"/>
-              </a:spcBef>
-              <a:spcAft>
-                <a:spcPts val="200"/>
-              </a:spcAft>
-            </a:pPr>
-            <a:r>
-              <a:rPr sz="1250" b="1">
-                <a:solidFill>
-                  <a:srgbClr val="C0612C"/>
-                </a:solidFill>
-                <a:latin typeface="Arial"/>
-                <a:ea typeface="Microsoft YaHei"/>
-                <a:cs typeface="Microsoft YaHei"/>
-              </a:rPr>
-              <a:t>4 </a:t>
-            </a:r>
-            <a:r>
-              <a:rPr sz="1250" b="1">
-                <a:solidFill>
-                  <a:srgbClr val="16202A"/>
-                </a:solidFill>
-                <a:latin typeface="Microsoft YaHei"/>
-                <a:ea typeface="Microsoft YaHei"/>
-                <a:cs typeface="Microsoft YaHei"/>
-              </a:rPr>
-              <a:t>测性能</a:t>
-            </a:r>
-          </a:p>
-          <a:p>
-            <a:pPr algn="ctr" latinLnBrk="0">
-              <a:lnSpc>
-                <a:spcPct val="100000"/>
-              </a:lnSpc>
-              <a:spcBef>
-                <a:spcPts val="0"/>
-              </a:spcBef>
-              <a:spcAft>
-                <a:spcPts val="0"/>
-              </a:spcAft>
-            </a:pPr>
-            <a:r>
-              <a:rPr sz="1000" b="0">
-                <a:solidFill>
-                  <a:srgbClr val="66727F"/>
-                </a:solidFill>
-                <a:latin typeface="Microsoft YaHei"/>
-                <a:ea typeface="Microsoft YaHei"/>
-                <a:cs typeface="Microsoft YaHei"/>
-              </a:rPr>
-              <a:t>中位延迟 · 比理论上限</a:t>
-            </a:r>
-          </a:p>
-        </p:txBody>
-      </p:sp>
-      <p:sp>
-        <p:nvSpPr>
-          <p:cNvPr id="12" name="Rounded Rectangle 11"/>
-          <p:cNvSpPr/>
-          <p:nvPr/>
-        </p:nvSpPr>
-        <p:spPr>
-          <a:xfrm>
-            <a:off x="641657" y="3279666"/>
-            <a:ext cx="1737360" cy="676656"/>
-          </a:xfrm>
-          <a:prstGeom prst="roundRect">
-            <a:avLst>
-              <a:gd name="adj" fmla="val 35000"/>
-            </a:avLst>
-          </a:prstGeom>
-          <a:solidFill>
-            <a:srgbClr val="FFFFFF"/>
-          </a:solidFill>
-          <a:ln w="15875">
-            <a:solidFill>
-              <a:srgbClr val="C0612C"/>
-            </a:solidFill>
-          </a:ln>
-        </p:spPr>
-        <p:txBody>
-          <a:bodyPr rtlCol="0" anchor="ctr" wrap="square" lIns="45720" tIns="18288" rIns="45720" bIns="18288">
-            <a:noAutofit/>
-          </a:bodyPr>
-          <a:lstStyle/>
-          <a:p>
-            <a:pPr algn="ctr" latinLnBrk="0">
-              <a:lnSpc>
-                <a:spcPct val="100000"/>
-              </a:lnSpc>
-              <a:spcBef>
-                <a:spcPts val="0"/>
-              </a:spcBef>
-              <a:spcAft>
-                <a:spcPts val="200"/>
-              </a:spcAft>
-            </a:pPr>
-            <a:r>
-              <a:rPr sz="1250" b="1">
-                <a:solidFill>
-                  <a:srgbClr val="C0612C"/>
-                </a:solidFill>
-                <a:latin typeface="Arial"/>
-                <a:ea typeface="Microsoft YaHei"/>
-                <a:cs typeface="Microsoft YaHei"/>
-              </a:rPr>
-              <a:t>5 </a:t>
-            </a:r>
-            <a:r>
-              <a:rPr sz="1250" b="1">
-                <a:solidFill>
-                  <a:srgbClr val="16202A"/>
-                </a:solidFill>
-                <a:latin typeface="Microsoft YaHei"/>
-                <a:ea typeface="Microsoft YaHei"/>
-                <a:cs typeface="Microsoft YaHei"/>
-              </a:rPr>
-              <a:t>给反馈</a:t>
-            </a:r>
-          </a:p>
-          <a:p>
-            <a:pPr algn="ctr" latinLnBrk="0">
-              <a:lnSpc>
-                <a:spcPct val="100000"/>
-              </a:lnSpc>
-              <a:spcBef>
-                <a:spcPts val="0"/>
-              </a:spcBef>
-              <a:spcAft>
-                <a:spcPts val="0"/>
-              </a:spcAft>
-            </a:pPr>
-            <a:r>
-              <a:rPr sz="1000" b="0">
-                <a:solidFill>
-                  <a:srgbClr val="66727F"/>
-                </a:solidFill>
-                <a:latin typeface="Microsoft YaHei"/>
-                <a:ea typeface="Microsoft YaHei"/>
-                <a:cs typeface="Microsoft YaHei"/>
-              </a:rPr>
-              <a:t>打分 · 指出慢在哪</a:t>
-            </a:r>
-          </a:p>
-        </p:txBody>
-      </p:sp>
-      <p:sp>
-        <p:nvSpPr>
-          <p:cNvPr id="13" name="Arc 12"/>
-          <p:cNvSpPr/>
-          <p:nvPr/>
-        </p:nvSpPr>
-        <p:spPr>
-          <a:xfrm>
-            <a:off x="1371599" y="2404872"/>
-            <a:ext cx="5669280" cy="3511296"/>
-          </a:xfrm>
-          <a:prstGeom prst="arc">
-            <a:avLst>
-              <a:gd name="adj1" fmla="val 18010129"/>
-              <a:gd name="adj2" fmla="val 20263467"/>
-            </a:avLst>
-          </a:prstGeom>
-          <a:noFill/>
-          <a:ln w="19050">
-            <a:solidFill>
-              <a:srgbClr val="C0612C"/>
-            </a:solidFill>
-            <a:tailEnd type="triangle" w="med" len="med"/>
-          </a:ln>
-        </p:spPr>
-        <p:txBody>
-          <a:bodyPr rtlCol="0" anchor="ctr"/>
-          <a:lstStyle/>
-          <a:p>
-            <a:pPr algn="ctr"/>
-          </a:p>
-        </p:txBody>
-      </p:sp>
-      <p:sp>
-        <p:nvSpPr>
-          <p:cNvPr id="14" name="Arc 13"/>
-          <p:cNvSpPr/>
-          <p:nvPr/>
-        </p:nvSpPr>
-        <p:spPr>
-          <a:xfrm>
-            <a:off x="1371599" y="2404872"/>
-            <a:ext cx="5669280" cy="3511296"/>
-          </a:xfrm>
-          <a:prstGeom prst="arc">
-            <a:avLst>
-              <a:gd name="adj1" fmla="val 21452696"/>
-              <a:gd name="adj2" fmla="val 1386262"/>
-            </a:avLst>
-          </a:prstGeom>
-          <a:noFill/>
-          <a:ln w="19050">
-            <a:solidFill>
-              <a:srgbClr val="C0612C"/>
-            </a:solidFill>
-            <a:tailEnd type="triangle" w="med" len="med"/>
-          </a:ln>
-        </p:spPr>
-        <p:txBody>
-          <a:bodyPr rtlCol="0" anchor="ctr"/>
-          <a:lstStyle/>
-          <a:p>
-            <a:pPr algn="ctr"/>
-          </a:p>
-        </p:txBody>
-      </p:sp>
-      <p:sp>
-        <p:nvSpPr>
-          <p:cNvPr id="15" name="Arc 14"/>
-          <p:cNvSpPr/>
-          <p:nvPr/>
-        </p:nvSpPr>
-        <p:spPr>
-          <a:xfrm>
-            <a:off x="1371599" y="2404872"/>
-            <a:ext cx="5669280" cy="3511296"/>
-          </a:xfrm>
-          <a:prstGeom prst="arc">
-            <a:avLst>
-              <a:gd name="adj1" fmla="val 4048999"/>
-              <a:gd name="adj2" fmla="val 6751000"/>
-            </a:avLst>
-          </a:prstGeom>
-          <a:noFill/>
-          <a:ln w="19050">
-            <a:solidFill>
-              <a:srgbClr val="C0612C"/>
-            </a:solidFill>
-            <a:tailEnd type="triangle" w="med" len="med"/>
-          </a:ln>
-        </p:spPr>
-        <p:txBody>
-          <a:bodyPr rtlCol="0" anchor="ctr"/>
-          <a:lstStyle/>
-          <a:p>
-            <a:pPr algn="ctr"/>
-          </a:p>
-        </p:txBody>
-      </p:sp>
-      <p:sp>
-        <p:nvSpPr>
-          <p:cNvPr id="16" name="Arc 15"/>
-          <p:cNvSpPr/>
-          <p:nvPr/>
-        </p:nvSpPr>
-        <p:spPr>
-          <a:xfrm>
-            <a:off x="1371599" y="2404872"/>
-            <a:ext cx="5669280" cy="3511296"/>
-          </a:xfrm>
-          <a:prstGeom prst="arc">
-            <a:avLst>
-              <a:gd name="adj1" fmla="val 9413737"/>
-              <a:gd name="adj2" fmla="val 10947303"/>
-            </a:avLst>
-          </a:prstGeom>
-          <a:noFill/>
-          <a:ln w="19050">
-            <a:solidFill>
-              <a:srgbClr val="C0612C"/>
-            </a:solidFill>
-            <a:tailEnd type="triangle" w="med" len="med"/>
-          </a:ln>
-        </p:spPr>
-        <p:txBody>
-          <a:bodyPr rtlCol="0" anchor="ctr"/>
-          <a:lstStyle/>
-          <a:p>
-            <a:pPr algn="ctr"/>
-          </a:p>
-        </p:txBody>
-      </p:sp>
-      <p:sp>
-        <p:nvSpPr>
-          <p:cNvPr id="17" name="Arc 16"/>
-          <p:cNvSpPr/>
-          <p:nvPr/>
-        </p:nvSpPr>
-        <p:spPr>
-          <a:xfrm>
-            <a:off x="1371599" y="2404872"/>
-            <a:ext cx="5669280" cy="3511296"/>
-          </a:xfrm>
-          <a:prstGeom prst="arc">
-            <a:avLst>
-              <a:gd name="adj1" fmla="val 12136532"/>
-              <a:gd name="adj2" fmla="val 14389870"/>
-            </a:avLst>
-          </a:prstGeom>
-          <a:noFill/>
-          <a:ln w="19050">
-            <a:solidFill>
-              <a:srgbClr val="C0612C"/>
-            </a:solidFill>
-            <a:tailEnd type="triangle" w="med" len="med"/>
-          </a:ln>
-        </p:spPr>
-        <p:txBody>
-          <a:bodyPr rtlCol="0" anchor="ctr"/>
-          <a:lstStyle/>
-          <a:p>
-            <a:pPr algn="ctr"/>
-          </a:p>
-        </p:txBody>
-      </p:sp>
-      <p:sp>
-        <p:nvSpPr>
-          <p:cNvPr id="18" name="Rectangle 17"/>
-          <p:cNvSpPr/>
-          <p:nvPr/>
-        </p:nvSpPr>
-        <p:spPr>
-          <a:xfrm>
-            <a:off x="8321040" y="2066543"/>
-            <a:ext cx="3322015" cy="3849624"/>
-          </a:xfrm>
-          <a:prstGeom prst="rect">
-            <a:avLst/>
-          </a:prstGeom>
-          <a:solidFill>
-            <a:srgbClr val="F8EADF"/>
-          </a:solidFill>
-          <a:ln>
-            <a:noFill/>
-          </a:ln>
-        </p:spPr>
-        <p:txBody>
-          <a:bodyPr rtlCol="0" anchor="ctr"/>
-          <a:lstStyle/>
-          <a:p>
-            <a:pPr algn="ctr"/>
-          </a:p>
-        </p:txBody>
-      </p:sp>
-      <p:sp>
-        <p:nvSpPr>
-          <p:cNvPr id="19" name="TextBox 18"/>
-          <p:cNvSpPr txBox="1"/>
-          <p:nvPr/>
-        </p:nvSpPr>
-        <p:spPr>
-          <a:xfrm>
-            <a:off x="8558784" y="2212848"/>
-            <a:ext cx="2864815" cy="292608"/>
-          </a:xfrm>
-          <a:prstGeom prst="rect">
-            <a:avLst/>
-          </a:prstGeom>
-          <a:noFill/>
-        </p:spPr>
-        <p:txBody>
-          <a:bodyPr wrap="square" anchor="ctr" lIns="0" tIns="0" rIns="0" bIns="0">
-            <a:noAutofit/>
-          </a:bodyPr>
-          <a:lstStyle/>
+              <a:t>　唯一的耦合层：编译 · 运行 · 采性能 · 理论上限</a:t>
+            </a:r>
+          </a:p>
           <a:p>
             <a:pPr algn="l" latinLnBrk="0">
               <a:lnSpc>
@@ -4653,6 +4896,82 @@
               </a:spcAft>
             </a:pPr>
             <a:r>
+              <a:rPr sz="1050" b="0">
+                <a:solidFill>
+                  <a:srgbClr val="66727F"/>
+                </a:solidFill>
+                <a:latin typeface="Microsoft YaHei"/>
+                <a:ea typeface="Microsoft YaHei"/>
+                <a:cs typeface="Microsoft YaHei"/>
+              </a:rPr>
+              <a:t>换芯片只写一个后端 + 一张硬件说明卡，agent/ 与 harness/ 零改动</a:t>
+            </a:r>
+          </a:p>
+        </p:txBody>
+      </p:sp>
+      <p:sp>
+        <p:nvSpPr>
+          <p:cNvPr id="26" name="Rectangle 25"/>
+          <p:cNvSpPr/>
+          <p:nvPr/>
+        </p:nvSpPr>
+        <p:spPr>
+          <a:xfrm>
+            <a:off x="8321040" y="2011680"/>
+            <a:ext cx="3322015" cy="3986784"/>
+          </a:xfrm>
+          <a:prstGeom prst="rect">
+            <a:avLst/>
+          </a:prstGeom>
+          <a:solidFill>
+            <a:srgbClr val="F8EADF"/>
+          </a:solidFill>
+          <a:ln>
+            <a:noFill/>
+          </a:ln>
+        </p:spPr>
+        <p:txBody>
+          <a:bodyPr rtlCol="0" anchor="ctr"/>
+          <a:lstStyle/>
+          <a:p>
+            <a:pPr algn="ctr"/>
+          </a:p>
+        </p:txBody>
+      </p:sp>
+      <p:sp>
+        <p:nvSpPr>
+          <p:cNvPr id="27" name="TextBox 26"/>
+          <p:cNvSpPr txBox="1"/>
+          <p:nvPr/>
+        </p:nvSpPr>
+        <p:spPr>
+          <a:xfrm>
+            <a:off x="8558784" y="2157984"/>
+            <a:ext cx="2864815" cy="292608"/>
+          </a:xfrm>
+          <a:prstGeom prst="rect">
+            <a:avLst/>
+          </a:prstGeom>
+          <a:noFill/>
+        </p:spPr>
+        <p:txBody>
+          <a:bodyPr wrap="square" anchor="ctr" lIns="0" tIns="0" rIns="0" bIns="0">
+            <a:noAutofit/>
+          </a:bodyPr>
+          <a:lstStyle/>
+          <a:p>
+            <a:pPr algn="l" latinLnBrk="0">
+              <a:lnSpc>
+                <a:spcPct val="100000"/>
+              </a:lnSpc>
+              <a:spcBef>
+                <a:spcPts val="0"/>
+              </a:spcBef>
+              <a:spcAft>
+                <a:spcPts val="0"/>
+              </a:spcAft>
+            </a:pPr>
+            <a:r>
               <a:rPr sz="1400" b="1">
                 <a:solidFill>
                   <a:srgbClr val="16202A"/>
@@ -4672,21 +4991,21 @@
                 <a:ea typeface="Microsoft YaHei"/>
                 <a:cs typeface="Microsoft YaHei"/>
               </a:rPr>
-              <a:t>　数字待补</a:t>
-            </a:r>
-          </a:p>
-        </p:txBody>
-      </p:sp>
-      <p:sp>
-        <p:nvSpPr>
-          <p:cNvPr id="20" name="Rectangle 19"/>
+              <a:t>　样例阶段</a:t>
+            </a:r>
+          </a:p>
+        </p:txBody>
+      </p:sp>
+      <p:sp>
+        <p:nvSpPr>
+          <p:cNvPr id="28" name="Rectangle 27"/>
           <p:cNvSpPr/>
           <p:nvPr/>
         </p:nvSpPr>
         <p:spPr>
           <a:xfrm>
-            <a:off x="8558784" y="2743200"/>
-            <a:ext cx="2846527" cy="582930"/>
+            <a:off x="8558784" y="2706624"/>
+            <a:ext cx="2846527" cy="896112"/>
           </a:xfrm>
           <a:prstGeom prst="rect">
             <a:avLst/>
@@ -4710,14 +5029,14 @@
       </p:sp>
       <p:sp>
         <p:nvSpPr>
-          <p:cNvPr id="21" name="TextBox 20"/>
+          <p:cNvPr id="29" name="TextBox 28"/>
           <p:cNvSpPr txBox="1"/>
           <p:nvPr/>
         </p:nvSpPr>
         <p:spPr>
           <a:xfrm>
-            <a:off x="8723376" y="2743200"/>
-            <a:ext cx="1913839" cy="582930"/>
+            <a:off x="8723376" y="2706624"/>
+            <a:ext cx="2517343" cy="896112"/>
           </a:xfrm>
           <a:prstGeom prst="rect">
             <a:avLst/>
@@ -4729,6 +5048,30 @@
             <a:noAutofit/>
           </a:bodyPr>
           <a:lstStyle/>
+          <a:p>
+            <a:pPr algn="l" latinLnBrk="0">
+              <a:lnSpc>
+                <a:spcPct val="100000"/>
+              </a:lnSpc>
+              <a:spcBef>
+                <a:spcPts val="0"/>
+              </a:spcBef>
+              <a:spcAft>
+                <a:spcPts val="200"/>
+              </a:spcAft>
+            </a:pPr>
+            <a:r>
+              <a:rPr sz="1050" b="0">
+                <a:solidFill>
+                  <a:srgbClr val="66727F"/>
+                </a:solidFill>
+                <a:latin typeface="Microsoft YaHei"/>
+                <a:ea typeface="Microsoft YaHei"/>
+                <a:cs typeface="Microsoft YaHei"/>
+              </a:rPr>
+              <a:t>已验证算子</a:t>
+            </a:r>
+          </a:p>
           <a:p>
             <a:pPr algn="l" latinLnBrk="0">
               <a:lnSpc>
@@ -4742,83 +5085,53 @@
               </a:spcAft>
             </a:pPr>
             <a:r>
-              <a:rPr sz="1150" b="0">
-                <a:solidFill>
-                  <a:srgbClr val="35424F"/>
-                </a:solidFill>
-                <a:latin typeface="Microsoft YaHei"/>
+              <a:rPr sz="1600" b="1">
+                <a:solidFill>
+                  <a:srgbClr val="16202A"/>
+                </a:solidFill>
+                <a:latin typeface="Arial"/>
                 <a:ea typeface="Microsoft YaHei"/>
                 <a:cs typeface="Microsoft YaHei"/>
               </a:rPr>
-              <a:t>已达标算子数</a:t>
-            </a:r>
-          </a:p>
-        </p:txBody>
-      </p:sp>
-      <p:sp>
-        <p:nvSpPr>
-          <p:cNvPr id="22" name="Rounded Rectangle 21"/>
-          <p:cNvSpPr/>
-          <p:nvPr/>
-        </p:nvSpPr>
-        <p:spPr>
-          <a:xfrm>
-            <a:off x="10472623" y="2852928"/>
-            <a:ext cx="768096" cy="363474"/>
-          </a:xfrm>
-          <a:prstGeom prst="roundRect">
-            <a:avLst>
-              <a:gd name="adj" fmla="val 30000"/>
-            </a:avLst>
-          </a:prstGeom>
-          <a:solidFill>
-            <a:srgbClr val="EEF1F4"/>
-          </a:solidFill>
-          <a:ln>
-            <a:noFill/>
-          </a:ln>
-        </p:spPr>
-        <p:txBody>
-          <a:bodyPr rtlCol="0" anchor="ctr" wrap="square" tIns="36576" bIns="36576">
-            <a:noAutofit/>
-          </a:bodyPr>
-          <a:lstStyle/>
-          <a:p>
-            <a:pPr algn="ctr" latinLnBrk="0">
+              <a:t>4 个</a:t>
+            </a:r>
+          </a:p>
+          <a:p>
+            <a:pPr algn="l" latinLnBrk="0">
               <a:lnSpc>
                 <a:spcPct val="100000"/>
               </a:lnSpc>
               <a:spcBef>
-                <a:spcPts val="0"/>
+                <a:spcPts val="200"/>
               </a:spcBef>
               <a:spcAft>
                 <a:spcPts val="0"/>
               </a:spcAft>
             </a:pPr>
             <a:r>
-              <a:rPr sz="1500" b="1">
+              <a:rPr sz="950" b="0">
                 <a:solidFill>
                   <a:srgbClr val="8C96A1"/>
                 </a:solidFill>
-                <a:latin typeface="Arial"/>
+                <a:latin typeface="Microsoft YaHei"/>
                 <a:ea typeface="Microsoft YaHei"/>
                 <a:cs typeface="Microsoft YaHei"/>
               </a:rPr>
-              <a:t>—</a:t>
-            </a:r>
-          </a:p>
-        </p:txBody>
-      </p:sp>
-      <p:sp>
-        <p:nvSpPr>
-          <p:cNvPr id="23" name="Rectangle 22"/>
+              <a:t>relu · relu_sdnn · rmsnorm · hc_post</a:t>
+            </a:r>
+          </a:p>
+        </p:txBody>
+      </p:sp>
+      <p:sp>
+        <p:nvSpPr>
+          <p:cNvPr id="30" name="Rectangle 29"/>
           <p:cNvSpPr/>
           <p:nvPr/>
         </p:nvSpPr>
         <p:spPr>
           <a:xfrm>
-            <a:off x="8558784" y="3435858"/>
-            <a:ext cx="2846527" cy="582930"/>
+            <a:off x="8558784" y="3712464"/>
+            <a:ext cx="2846527" cy="896112"/>
           </a:xfrm>
           <a:prstGeom prst="rect">
             <a:avLst/>
@@ -4842,14 +5155,14 @@
       </p:sp>
       <p:sp>
         <p:nvSpPr>
-          <p:cNvPr id="24" name="TextBox 23"/>
+          <p:cNvPr id="31" name="TextBox 30"/>
           <p:cNvSpPr txBox="1"/>
           <p:nvPr/>
         </p:nvSpPr>
         <p:spPr>
           <a:xfrm>
-            <a:off x="8723376" y="3435858"/>
-            <a:ext cx="1913839" cy="582930"/>
+            <a:off x="8723376" y="3712464"/>
+            <a:ext cx="2517343" cy="896112"/>
           </a:xfrm>
           <a:prstGeom prst="rect">
             <a:avLst/>
@@ -4861,6 +5174,30 @@
             <a:noAutofit/>
           </a:bodyPr>
           <a:lstStyle/>
+          <a:p>
+            <a:pPr algn="l" latinLnBrk="0">
+              <a:lnSpc>
+                <a:spcPct val="100000"/>
+              </a:lnSpc>
+              <a:spcBef>
+                <a:spcPts val="0"/>
+              </a:spcBef>
+              <a:spcAft>
+                <a:spcPts val="200"/>
+              </a:spcAft>
+            </a:pPr>
+            <a:r>
+              <a:rPr sz="1050" b="0">
+                <a:solidFill>
+                  <a:srgbClr val="66727F"/>
+                </a:solidFill>
+                <a:latin typeface="Microsoft YaHei"/>
+                <a:ea typeface="Microsoft YaHei"/>
+                <a:cs typeface="Microsoft YaHei"/>
+              </a:rPr>
+              <a:t>rmsnorm 相对基线</a:t>
+            </a:r>
+          </a:p>
           <a:p>
             <a:pPr algn="l" latinLnBrk="0">
               <a:lnSpc>
@@ -4874,83 +5211,53 @@
               </a:spcAft>
             </a:pPr>
             <a:r>
-              <a:rPr sz="1150" b="0">
-                <a:solidFill>
-                  <a:srgbClr val="35424F"/>
-                </a:solidFill>
-                <a:latin typeface="Microsoft YaHei"/>
+              <a:rPr sz="1600" b="1">
+                <a:solidFill>
+                  <a:srgbClr val="16202A"/>
+                </a:solidFill>
+                <a:latin typeface="Arial"/>
                 <a:ea typeface="Microsoft YaHei"/>
                 <a:cs typeface="Microsoft YaHei"/>
               </a:rPr>
-              <a:t>平均达标轮数</a:t>
-            </a:r>
-          </a:p>
-        </p:txBody>
-      </p:sp>
-      <p:sp>
-        <p:nvSpPr>
-          <p:cNvPr id="25" name="Rounded Rectangle 24"/>
-          <p:cNvSpPr/>
-          <p:nvPr/>
-        </p:nvSpPr>
-        <p:spPr>
-          <a:xfrm>
-            <a:off x="10472623" y="3545586"/>
-            <a:ext cx="768096" cy="363474"/>
-          </a:xfrm>
-          <a:prstGeom prst="roundRect">
-            <a:avLst>
-              <a:gd name="adj" fmla="val 30000"/>
-            </a:avLst>
-          </a:prstGeom>
-          <a:solidFill>
-            <a:srgbClr val="EEF1F4"/>
-          </a:solidFill>
-          <a:ln>
-            <a:noFill/>
-          </a:ln>
-        </p:spPr>
-        <p:txBody>
-          <a:bodyPr rtlCol="0" anchor="ctr" wrap="square" tIns="36576" bIns="36576">
-            <a:noAutofit/>
-          </a:bodyPr>
-          <a:lstStyle/>
-          <a:p>
-            <a:pPr algn="ctr" latinLnBrk="0">
+              <a:t>1.24×</a:t>
+            </a:r>
+          </a:p>
+          <a:p>
+            <a:pPr algn="l" latinLnBrk="0">
               <a:lnSpc>
                 <a:spcPct val="100000"/>
               </a:lnSpc>
               <a:spcBef>
-                <a:spcPts val="0"/>
+                <a:spcPts val="200"/>
               </a:spcBef>
               <a:spcAft>
                 <a:spcPts val="0"/>
               </a:spcAft>
             </a:pPr>
             <a:r>
-              <a:rPr sz="1500" b="1">
+              <a:rPr sz="950" b="0">
                 <a:solidFill>
                   <a:srgbClr val="8C96A1"/>
                 </a:solidFill>
-                <a:latin typeface="Arial"/>
+                <a:latin typeface="Microsoft YaHei"/>
                 <a:ea typeface="Microsoft YaHei"/>
                 <a:cs typeface="Microsoft YaHei"/>
               </a:rPr>
-              <a:t>—</a:t>
-            </a:r>
-          </a:p>
-        </p:txBody>
-      </p:sp>
-      <p:sp>
-        <p:nvSpPr>
-          <p:cNvPr id="26" name="Rectangle 25"/>
+              <a:t>741.2 → 595.6</a:t>
+            </a:r>
+          </a:p>
+        </p:txBody>
+      </p:sp>
+      <p:sp>
+        <p:nvSpPr>
+          <p:cNvPr id="32" name="Rectangle 31"/>
           <p:cNvSpPr/>
           <p:nvPr/>
         </p:nvSpPr>
         <p:spPr>
           <a:xfrm>
-            <a:off x="8558784" y="4128516"/>
-            <a:ext cx="2846527" cy="582930"/>
+            <a:off x="8558784" y="4718304"/>
+            <a:ext cx="2846527" cy="640080"/>
           </a:xfrm>
           <a:prstGeom prst="rect">
             <a:avLst/>
@@ -4974,14 +5281,14 @@
       </p:sp>
       <p:sp>
         <p:nvSpPr>
-          <p:cNvPr id="27" name="TextBox 26"/>
+          <p:cNvPr id="33" name="TextBox 32"/>
           <p:cNvSpPr txBox="1"/>
           <p:nvPr/>
         </p:nvSpPr>
         <p:spPr>
           <a:xfrm>
-            <a:off x="8723376" y="4128516"/>
-            <a:ext cx="1913839" cy="582930"/>
+            <a:off x="8723376" y="4718304"/>
+            <a:ext cx="2517343" cy="640080"/>
           </a:xfrm>
           <a:prstGeom prst="rect">
             <a:avLst/>
@@ -4993,6 +5300,30 @@
             <a:noAutofit/>
           </a:bodyPr>
           <a:lstStyle/>
+          <a:p>
+            <a:pPr algn="l" latinLnBrk="0">
+              <a:lnSpc>
+                <a:spcPct val="100000"/>
+              </a:lnSpc>
+              <a:spcBef>
+                <a:spcPts val="0"/>
+              </a:spcBef>
+              <a:spcAft>
+                <a:spcPts val="200"/>
+              </a:spcAft>
+            </a:pPr>
+            <a:r>
+              <a:rPr sz="1050" b="0">
+                <a:solidFill>
+                  <a:srgbClr val="66727F"/>
+                </a:solidFill>
+                <a:latin typeface="Microsoft YaHei"/>
+                <a:ea typeface="Microsoft YaHei"/>
+                <a:cs typeface="Microsoft YaHei"/>
+              </a:rPr>
+              <a:t>理论上限达成率</a:t>
+            </a:r>
+          </a:p>
           <a:p>
             <a:pPr algn="l" latinLnBrk="0">
               <a:lnSpc>
@@ -5006,114 +5337,29 @@
               </a:spcAft>
             </a:pPr>
             <a:r>
-              <a:rPr sz="1150" b="0">
-                <a:solidFill>
-                  <a:srgbClr val="35424F"/>
-                </a:solidFill>
-                <a:latin typeface="Microsoft YaHei"/>
-                <a:ea typeface="Microsoft YaHei"/>
-                <a:cs typeface="Microsoft YaHei"/>
-              </a:rPr>
-              <a:t>相对基线加速</a:t>
-            </a:r>
-          </a:p>
-        </p:txBody>
-      </p:sp>
-      <p:sp>
-        <p:nvSpPr>
-          <p:cNvPr id="28" name="Rounded Rectangle 27"/>
-          <p:cNvSpPr/>
-          <p:nvPr/>
-        </p:nvSpPr>
-        <p:spPr>
-          <a:xfrm>
-            <a:off x="10472623" y="4238244"/>
-            <a:ext cx="768096" cy="363474"/>
-          </a:xfrm>
-          <a:prstGeom prst="roundRect">
-            <a:avLst>
-              <a:gd name="adj" fmla="val 30000"/>
-            </a:avLst>
-          </a:prstGeom>
-          <a:solidFill>
-            <a:srgbClr val="EEF1F4"/>
-          </a:solidFill>
-          <a:ln>
-            <a:noFill/>
-          </a:ln>
-        </p:spPr>
-        <p:txBody>
-          <a:bodyPr rtlCol="0" anchor="ctr" wrap="square" tIns="36576" bIns="36576">
-            <a:noAutofit/>
-          </a:bodyPr>
-          <a:lstStyle/>
-          <a:p>
-            <a:pPr algn="ctr" latinLnBrk="0">
-              <a:lnSpc>
-                <a:spcPct val="100000"/>
-              </a:lnSpc>
-              <a:spcBef>
-                <a:spcPts val="0"/>
-              </a:spcBef>
-              <a:spcAft>
-                <a:spcPts val="0"/>
-              </a:spcAft>
-            </a:pPr>
-            <a:r>
-              <a:rPr sz="1500" b="1">
-                <a:solidFill>
-                  <a:srgbClr val="8C96A1"/>
+              <a:rPr sz="1600" b="1">
+                <a:solidFill>
+                  <a:srgbClr val="16202A"/>
                 </a:solidFill>
                 <a:latin typeface="Arial"/>
                 <a:ea typeface="Microsoft YaHei"/>
                 <a:cs typeface="Microsoft YaHei"/>
               </a:rPr>
-              <a:t>—</a:t>
-            </a:r>
-          </a:p>
-        </p:txBody>
-      </p:sp>
-      <p:sp>
-        <p:nvSpPr>
-          <p:cNvPr id="29" name="Rectangle 28"/>
-          <p:cNvSpPr/>
-          <p:nvPr/>
-        </p:nvSpPr>
-        <p:spPr>
-          <a:xfrm>
-            <a:off x="8558784" y="4821174"/>
-            <a:ext cx="2846527" cy="582930"/>
-          </a:xfrm>
-          <a:prstGeom prst="rect">
-            <a:avLst/>
-          </a:prstGeom>
-          <a:solidFill>
-            <a:srgbClr val="FFFFFF"/>
-          </a:solidFill>
-          <a:ln w="9525">
-            <a:solidFill>
-              <a:srgbClr val="DDE2E7"/>
-            </a:solidFill>
-          </a:ln>
-        </p:spPr>
-        <p:txBody>
-          <a:bodyPr rtlCol="0" anchor="ctr"/>
-          <a:lstStyle/>
-          <a:p>
-            <a:pPr algn="ctr"/>
-          </a:p>
-        </p:txBody>
-      </p:sp>
-      <p:sp>
-        <p:nvSpPr>
-          <p:cNvPr id="30" name="TextBox 29"/>
+              <a:t>0.47 → 0.58</a:t>
+            </a:r>
+          </a:p>
+        </p:txBody>
+      </p:sp>
+      <p:sp>
+        <p:nvSpPr>
+          <p:cNvPr id="34" name="TextBox 33"/>
           <p:cNvSpPr txBox="1"/>
           <p:nvPr/>
         </p:nvSpPr>
         <p:spPr>
           <a:xfrm>
-            <a:off x="8723376" y="4821174"/>
-            <a:ext cx="1913839" cy="582930"/>
+            <a:off x="8558784" y="5504688"/>
+            <a:ext cx="2846527" cy="457200"/>
           </a:xfrm>
           <a:prstGeom prst="rect">
             <a:avLst/>
@@ -5121,7 +5367,7 @@
           <a:noFill/>
         </p:spPr>
         <p:txBody>
-          <a:bodyPr wrap="square" anchor="ctr" lIns="0" tIns="0" rIns="0" bIns="0">
+          <a:bodyPr wrap="square" anchor="t" lIns="0" tIns="0" rIns="0" bIns="0">
             <a:noAutofit/>
           </a:bodyPr>
           <a:lstStyle/>
@@ -5138,83 +5384,29 @@
               </a:spcAft>
             </a:pPr>
             <a:r>
-              <a:rPr sz="1150" b="0">
-                <a:solidFill>
-                  <a:srgbClr val="35424F"/>
+              <a:rPr sz="1050" b="0">
+                <a:solidFill>
+                  <a:srgbClr val="66727F"/>
                 </a:solidFill>
                 <a:latin typeface="Microsoft YaHei"/>
                 <a:ea typeface="Microsoft YaHei"/>
                 <a:cs typeface="Microsoft YaHei"/>
               </a:rPr>
-              <a:t>理论上限达成率</a:t>
-            </a:r>
-          </a:p>
-        </p:txBody>
-      </p:sp>
-      <p:sp>
-        <p:nvSpPr>
-          <p:cNvPr id="31" name="Rounded Rectangle 30"/>
-          <p:cNvSpPr/>
-          <p:nvPr/>
-        </p:nvSpPr>
-        <p:spPr>
-          <a:xfrm>
-            <a:off x="10472623" y="4930902"/>
-            <a:ext cx="768096" cy="363474"/>
-          </a:xfrm>
-          <a:prstGeom prst="roundRect">
-            <a:avLst>
-              <a:gd name="adj" fmla="val 30000"/>
-            </a:avLst>
-          </a:prstGeom>
-          <a:solidFill>
-            <a:srgbClr val="EEF1F4"/>
-          </a:solidFill>
-          <a:ln>
-            <a:noFill/>
-          </a:ln>
-        </p:spPr>
-        <p:txBody>
-          <a:bodyPr rtlCol="0" anchor="ctr" wrap="square" tIns="36576" bIns="36576">
-            <a:noAutofit/>
-          </a:bodyPr>
-          <a:lstStyle/>
-          <a:p>
-            <a:pPr algn="ctr" latinLnBrk="0">
-              <a:lnSpc>
-                <a:spcPct val="100000"/>
-              </a:lnSpc>
-              <a:spcBef>
-                <a:spcPts val="0"/>
-              </a:spcBef>
-              <a:spcAft>
-                <a:spcPts val="0"/>
-              </a:spcAft>
-            </a:pPr>
-            <a:r>
-              <a:rPr sz="1500" b="1">
-                <a:solidFill>
-                  <a:srgbClr val="8C96A1"/>
-                </a:solidFill>
-                <a:latin typeface="Arial"/>
-                <a:ea typeface="Microsoft YaHei"/>
-                <a:cs typeface="Microsoft YaHei"/>
-              </a:rPr>
-              <a:t>—</a:t>
-            </a:r>
-          </a:p>
-        </p:txBody>
-      </p:sp>
-      <p:sp>
-        <p:nvSpPr>
-          <p:cNvPr id="32" name="TextBox 31"/>
+              <a:t>单算子实测，尚无规模化达标统计；口径为真机、生产形状</a:t>
+            </a:r>
+          </a:p>
+        </p:txBody>
+      </p:sp>
+      <p:sp>
+        <p:nvSpPr>
+          <p:cNvPr id="35" name="TextBox 34"/>
           <p:cNvSpPr txBox="1"/>
           <p:nvPr/>
         </p:nvSpPr>
         <p:spPr>
           <a:xfrm>
-            <a:off x="8558784" y="5532120"/>
-            <a:ext cx="2846527" cy="274320"/>
+            <a:off x="548640" y="6382512"/>
+            <a:ext cx="9905695" cy="256032"/>
           </a:xfrm>
           <a:prstGeom prst="rect">
             <a:avLst/>
@@ -5239,53 +5431,6 @@
               </a:spcAft>
             </a:pPr>
             <a:r>
-              <a:rPr sz="1050" b="0">
-                <a:solidFill>
-                  <a:srgbClr val="66727F"/>
-                </a:solidFill>
-                <a:latin typeface="Microsoft YaHei"/>
-                <a:ea typeface="Microsoft YaHei"/>
-                <a:cs typeface="Microsoft YaHei"/>
-              </a:rPr>
-              <a:t>口径：真机、生产形状上的实测</a:t>
-            </a:r>
-          </a:p>
-        </p:txBody>
-      </p:sp>
-      <p:sp>
-        <p:nvSpPr>
-          <p:cNvPr id="33" name="TextBox 32"/>
-          <p:cNvSpPr txBox="1"/>
-          <p:nvPr/>
-        </p:nvSpPr>
-        <p:spPr>
-          <a:xfrm>
-            <a:off x="548640" y="6382512"/>
-            <a:ext cx="9905695" cy="256032"/>
-          </a:xfrm>
-          <a:prstGeom prst="rect">
-            <a:avLst/>
-          </a:prstGeom>
-          <a:noFill/>
-        </p:spPr>
-        <p:txBody>
-          <a:bodyPr wrap="square" anchor="ctr" lIns="0" tIns="0" rIns="0" bIns="0">
-            <a:noAutofit/>
-          </a:bodyPr>
-          <a:lstStyle/>
-          <a:p>
-            <a:pPr algn="l" latinLnBrk="0">
-              <a:lnSpc>
-                <a:spcPct val="100000"/>
-              </a:lnSpc>
-              <a:spcBef>
-                <a:spcPts val="0"/>
-              </a:spcBef>
-              <a:spcAft>
-                <a:spcPts val="0"/>
-              </a:spcAft>
-            </a:pPr>
-            <a:r>
               <a:rPr sz="1000" b="0">
                 <a:solidFill>
                   <a:srgbClr val="66727F"/>
@@ -5301,7 +5446,7 @@
       </p:sp>
       <p:sp>
         <p:nvSpPr>
-          <p:cNvPr id="34" name="TextBox 33"/>
+          <p:cNvPr id="36" name="TextBox 35"/>
           <p:cNvSpPr txBox="1"/>
           <p:nvPr/>
         </p:nvSpPr>

</xml_diff>

<commit_message>
Say it the way the room hears it
"Deterministic harness, not an agent" answers a reviewer, not an audience: someone
hearing it wonders what is wrong with the thing that makes you insist. The two blocks
are now 写算子 and 判算子, with the directory names kept as small tags, and the stages
read as the questions they answer: can it run, is it correct, how much faster, why
slow. The disciplines land as consequences the listener can act on -- speedups count
only on the device, the simulator is for diagnosis -- and the speaker notes use the
same words so the script and the slide agree.
</commit_message>
<xml_diff>
--- a/slides/xpugen_operator_agent.pptx
+++ b/slides/xpugen_operator_agent.pptx
@@ -515,7 +515,7 @@
                 <a:ea typeface="Microsoft YaHei"/>
                 <a:cs typeface="Microsoft YaHei"/>
               </a:rPr>
-              <a:t>【附页 · xpugen · 约 125 秒（2:05）】</a:t>
+              <a:t>【附页 · xpugen · 约 130 秒（2:10）】</a:t>
             </a:r>
           </a:p>
           <a:p>
@@ -551,7 +551,7 @@
                 <a:ea typeface="Microsoft YaHei"/>
                 <a:cs typeface="Microsoft YaHei"/>
               </a:rPr>
-              <a:t>先说清结构：这里只有一个 LLM，就是左边这个生成。右边编译、对数值、测速、看机制全是确定性的评测流程，不是 agent，不会自由发挥。</a:t>
+              <a:t>先说清结构：左边写算子，右边判算子。会「猜」的只有左边这一个模型，右边从编译到测速每一步都是写死的规则，行不行轮不到模型自己说。</a:t>
             </a:r>
           </a:p>
           <a:p>
@@ -569,7 +569,7 @@
                 <a:ea typeface="Microsoft YaHei"/>
                 <a:cs typeface="Microsoft YaHei"/>
               </a:rPr>
-              <a:t>左边动手之前还有一道门：先把需求问清楚、至少比过两个方案，才允许写内核。入口有两条，从一句需求开始，或者从现有实现反推出规格，第 0 轮直接拿它当基线。</a:t>
+              <a:t>左边动手之前还有一道门：先把需求问到没有歧义、至少比过两个方案，才允许写内核。起步有两条路，从一句需求开始，或者从现有实现反推出规格，第 0 轮直接拿它当基线。</a:t>
             </a:r>
           </a:p>
           <a:p>
@@ -587,7 +587,7 @@
                 <a:ea typeface="Microsoft YaHei"/>
                 <a:cs typeface="Microsoft YaHei"/>
               </a:rPr>
-              <a:t>右边编译跑通、多种形状和精度逐一对 CPU golden；性能上分两路取证——真机回答快了多少，模拟器看逐单元 busy、跨引擎并行，回答为什么慢，两边对不上以真机为准。</a:t>
+              <a:t>右边是一级级往上问：能不能跑起来、算得对不对、快了多少、为什么慢。快了多少只认真机；为什么慢才看模拟器，它能看到逐个单元的忙闲和跨引擎的并行，两边对不上以真机为准。</a:t>
             </a:r>
           </a:p>
           <a:p>
@@ -605,7 +605,7 @@
                 <a:ea typeface="Microsoft YaHei"/>
                 <a:cs typeface="Microsoft YaHei"/>
               </a:rPr>
-              <a:t>这些结果打成结构化反馈回到生成：精度默认八轮收敛，性能调优是持续迭代，连着五十轮没进展才敢说卡住了。</a:t>
+              <a:t>判完的分数和卡在哪原样回传给左边，接着改下一轮：精度默认八轮收敛，性能调优是持续迭代，连着五十轮没进展才敢说卡住了。</a:t>
             </a:r>
           </a:p>
           <a:p>
@@ -623,7 +623,7 @@
                 <a:ea typeface="Microsoft YaHei"/>
                 <a:cs typeface="Microsoft YaHei"/>
               </a:rPr>
-              <a:t>底下一行是架构：生成和评测都不碰硬件，只认 backend 这一层的四个接口，换芯片只写一个后端加一张硬件说明卡。</a:t>
+              <a:t>底下一行是架构：写算子、判算子都不碰硬件，认硬件的只有 backend 这一层四件事，换一款芯片只补这一层，加一张硬件说明卡。</a:t>
             </a:r>
           </a:p>
           <a:p>
@@ -3855,7 +3855,7 @@
                 <a:ea typeface="Microsoft YaHei"/>
                 <a:cs typeface="Microsoft YaHei"/>
               </a:rPr>
-              <a:t>生成 M100 的 SDNN4 .xpu 内核，不是 CUDA；只有「生成」是 LLM，编译 / 对数值 / 测速都是确定性流程</a:t>
+              <a:t>写的是 M100 原生内核（SDNN4 .xpu），不是 CUDA；模型只管写，判它行不行的是一套固定流程</a:t>
             </a:r>
           </a:p>
         </p:txBody>
@@ -3902,7 +3902,7 @@
                 <a:ea typeface="Microsoft YaHei"/>
                 <a:cs typeface="Microsoft YaHei"/>
               </a:rPr>
-              <a:t>入口　</a:t>
+              <a:t>怎么起步　</a:t>
             </a:r>
             <a:r>
               <a:rPr sz="1050" b="0">
@@ -3913,7 +3913,7 @@
                 <a:ea typeface="Microsoft YaHei"/>
                 <a:cs typeface="Microsoft YaHei"/>
               </a:rPr>
-              <a:t>一句需求，或拿现有实现当第 0 轮基线　·　精度默认 8 轮收敛（可调），性能调优持续迭代</a:t>
+              <a:t>从一句需求开始，也可以拿现有实现当第 0 轮基线　·　先把精度收住（默认 8 轮），再持续抠性能</a:t>
             </a:r>
           </a:p>
         </p:txBody>
@@ -3983,24 +3983,35 @@
             <a:r>
               <a:rPr sz="1300" b="1">
                 <a:solidFill>
+                  <a:srgbClr val="16202A"/>
+                </a:solidFill>
+                <a:latin typeface="Microsoft YaHei"/>
+                <a:ea typeface="Microsoft YaHei"/>
+                <a:cs typeface="Microsoft YaHei"/>
+              </a:rPr>
+              <a:t>写算子</a:t>
+            </a:r>
+            <a:r>
+              <a:rPr sz="1000" b="0">
+                <a:solidFill>
                   <a:srgbClr val="C0612C"/>
                 </a:solidFill>
                 <a:latin typeface="Consolas"/>
                 <a:ea typeface="Microsoft YaHei"/>
                 <a:cs typeface="Microsoft YaHei"/>
               </a:rPr>
-              <a:t>agent/</a:t>
-            </a:r>
-            <a:r>
-              <a:rPr sz="1300" b="1">
-                <a:solidFill>
-                  <a:srgbClr val="16202A"/>
+              <a:t>　agent/</a:t>
+            </a:r>
+            <a:r>
+              <a:rPr sz="1100" b="0">
+                <a:solidFill>
+                  <a:srgbClr val="35424F"/>
                 </a:solidFill>
                 <a:latin typeface="Microsoft YaHei"/>
                 <a:ea typeface="Microsoft YaHei"/>
                 <a:cs typeface="Microsoft YaHei"/>
               </a:rPr>
-              <a:t>　只有这一个 LLM</a:t>
+              <a:t>　全流程只有这一个模型</a:t>
             </a:r>
           </a:p>
         </p:txBody>
@@ -4047,7 +4058,7 @@
                 <a:ea typeface="Microsoft YaHei"/>
                 <a:cs typeface="Microsoft YaHei"/>
               </a:rPr>
-              <a:t>0 确认门</a:t>
+              <a:t>先问清楚再动手</a:t>
             </a:r>
             <a:r>
               <a:rPr sz="1000" b="0">
@@ -4105,7 +4116,7 @@
                 <a:ea typeface="Microsoft YaHei"/>
                 <a:cs typeface="Microsoft YaHei"/>
               </a:rPr>
-              <a:t>动手前先问清需求，至少比两个方案</a:t>
+              <a:t>把需求问到没有歧义，至少比过两个方案</a:t>
             </a:r>
           </a:p>
         </p:txBody>
@@ -4152,7 +4163,7 @@
                 <a:ea typeface="Microsoft YaHei"/>
                 <a:cs typeface="Microsoft YaHei"/>
               </a:rPr>
-              <a:t>1 生成</a:t>
+              <a:t>照硬件说明卡写内核</a:t>
             </a:r>
             <a:r>
               <a:rPr sz="1000" b="0">
@@ -4210,7 +4221,7 @@
                 <a:ea typeface="Microsoft YaHei"/>
                 <a:cs typeface="Microsoft YaHei"/>
               </a:rPr>
-              <a:t>照硬件说明卡写出 .xpu 内核</a:t>
+              <a:t>说明卡写着这颗芯片有哪些单元、怎么用</a:t>
             </a:r>
           </a:p>
         </p:txBody>
@@ -4280,24 +4291,35 @@
             <a:r>
               <a:rPr sz="1300" b="1">
                 <a:solidFill>
+                  <a:srgbClr val="16202A"/>
+                </a:solidFill>
+                <a:latin typeface="Microsoft YaHei"/>
+                <a:ea typeface="Microsoft YaHei"/>
+                <a:cs typeface="Microsoft YaHei"/>
+              </a:rPr>
+              <a:t>判算子</a:t>
+            </a:r>
+            <a:r>
+              <a:rPr sz="1000" b="0">
+                <a:solidFill>
                   <a:srgbClr val="66727F"/>
                 </a:solidFill>
                 <a:latin typeface="Consolas"/>
                 <a:ea typeface="Microsoft YaHei"/>
                 <a:cs typeface="Microsoft YaHei"/>
               </a:rPr>
-              <a:t>harness/</a:t>
-            </a:r>
-            <a:r>
-              <a:rPr sz="1300" b="1">
-                <a:solidFill>
-                  <a:srgbClr val="16202A"/>
+              <a:t>　harness/</a:t>
+            </a:r>
+            <a:r>
+              <a:rPr sz="1100" b="0">
+                <a:solidFill>
+                  <a:srgbClr val="35424F"/>
                 </a:solidFill>
                 <a:latin typeface="Microsoft YaHei"/>
                 <a:ea typeface="Microsoft YaHei"/>
                 <a:cs typeface="Microsoft YaHei"/>
               </a:rPr>
-              <a:t>　确定性评测，不是 agent</a:t>
+              <a:t>　规则固定，模型说了不算</a:t>
             </a:r>
           </a:p>
         </p:txBody>
@@ -4336,6 +4358,17 @@
               </a:spcAft>
             </a:pPr>
             <a:r>
+              <a:rPr sz="950" b="0">
+                <a:solidFill>
+                  <a:srgbClr val="8C96A1"/>
+                </a:solidFill>
+                <a:latin typeface="Consolas"/>
+                <a:ea typeface="Microsoft YaHei"/>
+                <a:cs typeface="Microsoft YaHei"/>
+              </a:rPr>
+              <a:t>L0</a:t>
+            </a:r>
+            <a:r>
               <a:rPr sz="1150" b="1">
                 <a:solidFill>
                   <a:srgbClr val="16202A"/>
@@ -4344,7 +4377,7 @@
                 <a:ea typeface="Microsoft YaHei"/>
                 <a:cs typeface="Microsoft YaHei"/>
               </a:rPr>
-              <a:t>L0 编译</a:t>
+              <a:t>　能不能跑起来</a:t>
             </a:r>
             <a:r>
               <a:rPr sz="1050" b="0">
@@ -4355,7 +4388,7 @@
                 <a:ea typeface="Microsoft YaHei"/>
                 <a:cs typeface="Microsoft YaHei"/>
               </a:rPr>
-              <a:t>　编译并拉起，跑通才往下</a:t>
+              <a:t>　编译 + 拉起</a:t>
             </a:r>
           </a:p>
         </p:txBody>
@@ -4394,6 +4427,17 @@
               </a:spcAft>
             </a:pPr>
             <a:r>
+              <a:rPr sz="950" b="0">
+                <a:solidFill>
+                  <a:srgbClr val="8C96A1"/>
+                </a:solidFill>
+                <a:latin typeface="Consolas"/>
+                <a:ea typeface="Microsoft YaHei"/>
+                <a:cs typeface="Microsoft YaHei"/>
+              </a:rPr>
+              <a:t>L1</a:t>
+            </a:r>
+            <a:r>
               <a:rPr sz="1150" b="1">
                 <a:solidFill>
                   <a:srgbClr val="16202A"/>
@@ -4402,7 +4446,7 @@
                 <a:ea typeface="Microsoft YaHei"/>
                 <a:cs typeface="Microsoft YaHei"/>
               </a:rPr>
-              <a:t>L1 精度</a:t>
+              <a:t>　算得对不对</a:t>
             </a:r>
             <a:r>
               <a:rPr sz="1050" b="0">
@@ -4413,7 +4457,7 @@
                 <a:ea typeface="Microsoft YaHei"/>
                 <a:cs typeface="Microsoft YaHei"/>
               </a:rPr>
-              <a:t>　多形状多精度对 CPU golden</a:t>
+              <a:t>　多形状多精度对 CPU</a:t>
             </a:r>
           </a:p>
         </p:txBody>
@@ -4452,6 +4496,17 @@
               </a:spcAft>
             </a:pPr>
             <a:r>
+              <a:rPr sz="950" b="0">
+                <a:solidFill>
+                  <a:srgbClr val="8C96A1"/>
+                </a:solidFill>
+                <a:latin typeface="Consolas"/>
+                <a:ea typeface="Microsoft YaHei"/>
+                <a:cs typeface="Microsoft YaHei"/>
+              </a:rPr>
+              <a:t>bench</a:t>
+            </a:r>
+            <a:r>
               <a:rPr sz="1150" b="1">
                 <a:solidFill>
                   <a:srgbClr val="16202A"/>
@@ -4460,7 +4515,7 @@
                 <a:ea typeface="Microsoft YaHei"/>
                 <a:cs typeface="Microsoft YaHei"/>
               </a:rPr>
-              <a:t>bench 收益</a:t>
+              <a:t>　快了多少</a:t>
             </a:r>
             <a:r>
               <a:rPr sz="1050" b="0">
@@ -4471,7 +4526,7 @@
                 <a:ea typeface="Microsoft YaHei"/>
                 <a:cs typeface="Microsoft YaHei"/>
               </a:rPr>
-              <a:t>　真机答「快了多少」</a:t>
+              <a:t>　真机实测</a:t>
             </a:r>
           </a:p>
         </p:txBody>
@@ -4510,6 +4565,17 @@
               </a:spcAft>
             </a:pPr>
             <a:r>
+              <a:rPr sz="950" b="0">
+                <a:solidFill>
+                  <a:srgbClr val="8C96A1"/>
+                </a:solidFill>
+                <a:latin typeface="Consolas"/>
+                <a:ea typeface="Microsoft YaHei"/>
+                <a:cs typeface="Microsoft YaHei"/>
+              </a:rPr>
+              <a:t>profile</a:t>
+            </a:r>
+            <a:r>
               <a:rPr sz="1150" b="1">
                 <a:solidFill>
                   <a:srgbClr val="16202A"/>
@@ -4518,7 +4584,7 @@
                 <a:ea typeface="Microsoft YaHei"/>
                 <a:cs typeface="Microsoft YaHei"/>
               </a:rPr>
-              <a:t>profile 机制</a:t>
+              <a:t>　为什么慢</a:t>
             </a:r>
             <a:r>
               <a:rPr sz="1050" b="0">
@@ -4529,7 +4595,7 @@
                 <a:ea typeface="Microsoft YaHei"/>
                 <a:cs typeface="Microsoft YaHei"/>
               </a:rPr>
-              <a:t>　模拟器答「为什么慢」</a:t>
+              <a:t>　模拟器看卡在哪一步</a:t>
             </a:r>
           </a:p>
         </p:txBody>
@@ -4597,7 +4663,7 @@
                 <a:ea typeface="Microsoft YaHei"/>
                 <a:cs typeface="Microsoft YaHei"/>
               </a:rPr>
-              <a:t>机制看模拟器 · 收益看真机，以真机为准</a:t>
+              <a:t>原因看模拟器，收益只认真机</a:t>
             </a:r>
           </a:p>
         </p:txBody>
@@ -4694,7 +4760,7 @@
                 <a:ea typeface="Microsoft YaHei"/>
                 <a:cs typeface="Microsoft YaHei"/>
               </a:rPr>
-              <a:t>交出 .xpu 内核</a:t>
+              <a:t>把写好的内核交过去</a:t>
             </a:r>
           </a:p>
         </p:txBody>
@@ -4791,7 +4857,7 @@
                 <a:ea typeface="Microsoft YaHei"/>
                 <a:cs typeface="Microsoft YaHei"/>
               </a:rPr>
-              <a:t>结构化反馈：打分 + 模拟器机制证据，带进下一轮</a:t>
+              <a:t>把分数和「卡在哪」原样带回去，接着改下一轮</a:t>
             </a:r>
           </a:p>
         </p:txBody>
@@ -4865,22 +4931,22 @@
                 <a:solidFill>
                   <a:srgbClr val="16202A"/>
                 </a:solidFill>
+                <a:latin typeface="Microsoft YaHei"/>
+                <a:ea typeface="Microsoft YaHei"/>
+                <a:cs typeface="Microsoft YaHei"/>
+              </a:rPr>
+              <a:t>认硬件的只有这一层：编译 · 运行 · 采性能 · 算理论上限</a:t>
+            </a:r>
+            <a:r>
+              <a:rPr sz="1000" b="0">
+                <a:solidFill>
+                  <a:srgbClr val="66727F"/>
+                </a:solidFill>
                 <a:latin typeface="Consolas"/>
                 <a:ea typeface="Microsoft YaHei"/>
                 <a:cs typeface="Microsoft YaHei"/>
               </a:rPr>
-              <a:t>backend/</a:t>
-            </a:r>
-            <a:r>
-              <a:rPr sz="1050" b="1">
-                <a:solidFill>
-                  <a:srgbClr val="16202A"/>
-                </a:solidFill>
-                <a:latin typeface="Microsoft YaHei"/>
-                <a:ea typeface="Microsoft YaHei"/>
-                <a:cs typeface="Microsoft YaHei"/>
-              </a:rPr>
-              <a:t>　唯一的耦合层：编译 · 运行 · 采性能 · 理论上限</a:t>
+              <a:t>　backend/</a:t>
             </a:r>
           </a:p>
           <a:p>
@@ -4904,7 +4970,7 @@
                 <a:ea typeface="Microsoft YaHei"/>
                 <a:cs typeface="Microsoft YaHei"/>
               </a:rPr>
-              <a:t>换芯片只写一个后端 + 一张硬件说明卡，agent/ 与 harness/ 零改动</a:t>
+              <a:t>换一款芯片只补这一层，上面写算子、判算子的流程一行不改</a:t>
             </a:r>
           </a:p>
         </p:txBody>
@@ -5005,7 +5071,7 @@
         <p:spPr>
           <a:xfrm>
             <a:off x="8558784" y="2706624"/>
-            <a:ext cx="2846527" cy="896112"/>
+            <a:ext cx="2846527" cy="810768"/>
           </a:xfrm>
           <a:prstGeom prst="rect">
             <a:avLst/>
@@ -5036,7 +5102,7 @@
         <p:spPr>
           <a:xfrm>
             <a:off x="8723376" y="2706624"/>
-            <a:ext cx="2517343" cy="896112"/>
+            <a:ext cx="2517343" cy="810768"/>
           </a:xfrm>
           <a:prstGeom prst="rect">
             <a:avLst/>
@@ -5130,8 +5196,8 @@
         </p:nvSpPr>
         <p:spPr>
           <a:xfrm>
-            <a:off x="8558784" y="3712464"/>
-            <a:ext cx="2846527" cy="896112"/>
+            <a:off x="8558784" y="3627120"/>
+            <a:ext cx="2846527" cy="810768"/>
           </a:xfrm>
           <a:prstGeom prst="rect">
             <a:avLst/>
@@ -5161,8 +5227,8 @@
         </p:nvSpPr>
         <p:spPr>
           <a:xfrm>
-            <a:off x="8723376" y="3712464"/>
-            <a:ext cx="2517343" cy="896112"/>
+            <a:off x="8723376" y="3627120"/>
+            <a:ext cx="2517343" cy="810768"/>
           </a:xfrm>
           <a:prstGeom prst="rect">
             <a:avLst/>
@@ -5243,7 +5309,7 @@
                 <a:ea typeface="Microsoft YaHei"/>
                 <a:cs typeface="Microsoft YaHei"/>
               </a:rPr>
-              <a:t>741.2 → 595.6</a:t>
+              <a:t>延迟 741.2 → 595.6</a:t>
             </a:r>
           </a:p>
         </p:txBody>
@@ -5256,8 +5322,8 @@
         </p:nvSpPr>
         <p:spPr>
           <a:xfrm>
-            <a:off x="8558784" y="4718304"/>
-            <a:ext cx="2846527" cy="640080"/>
+            <a:off x="8558784" y="4547616"/>
+            <a:ext cx="2846527" cy="810768"/>
           </a:xfrm>
           <a:prstGeom prst="rect">
             <a:avLst/>
@@ -5287,8 +5353,8 @@
         </p:nvSpPr>
         <p:spPr>
           <a:xfrm>
-            <a:off x="8723376" y="4718304"/>
-            <a:ext cx="2517343" cy="640080"/>
+            <a:off x="8723376" y="4547616"/>
+            <a:ext cx="2517343" cy="810768"/>
           </a:xfrm>
           <a:prstGeom prst="rect">
             <a:avLst/>
@@ -5348,6 +5414,30 @@
               <a:t>0.47 → 0.58</a:t>
             </a:r>
           </a:p>
+          <a:p>
+            <a:pPr algn="l" latinLnBrk="0">
+              <a:lnSpc>
+                <a:spcPct val="100000"/>
+              </a:lnSpc>
+              <a:spcBef>
+                <a:spcPts val="200"/>
+              </a:spcBef>
+              <a:spcAft>
+                <a:spcPts val="0"/>
+              </a:spcAft>
+            </a:pPr>
+            <a:r>
+              <a:rPr sz="950" b="0">
+                <a:solidFill>
+                  <a:srgbClr val="8C96A1"/>
+                </a:solidFill>
+                <a:latin typeface="Microsoft YaHei"/>
+                <a:ea typeface="Microsoft YaHei"/>
+                <a:cs typeface="Microsoft YaHei"/>
+              </a:rPr>
+              <a:t>越接近 1，硬件越被榨干</a:t>
+            </a:r>
+          </a:p>
         </p:txBody>
       </p:sp>
       <p:sp>
@@ -5392,7 +5482,7 @@
                 <a:ea typeface="Microsoft YaHei"/>
                 <a:cs typeface="Microsoft YaHei"/>
               </a:rPr>
-              <a:t>单算子实测，尚无规模化达标统计；口径为真机、生产形状</a:t>
+              <a:t>目前是单算子的实测样例，还没有成规模的达标统计；数字都来自真机、生产形状</a:t>
             </a:r>
           </a:p>
         </p:txBody>

</xml_diff>

<commit_message>
Lift the xpugen slide out of spoken register
Plain wording was the right call, but it drifted into speech: 收住, 抠性能, 说了不算,
卡在哪. Each line now states the same thing in the register the rest of the deck uses
-- accuracy converges first and performance is pressed afterwards, evaluation is
objective and decided by rules, the four stages ask whether it compiles, whether the
numbers are right, how much faster, and where the bottleneck is. Also dropped two
pieces of ops slang (拉起, 采性能) and aligned the first row of both blocks.
</commit_message>
<xml_diff>
--- a/slides/xpugen_operator_agent.pptx
+++ b/slides/xpugen_operator_agent.pptx
@@ -515,7 +515,7 @@
                 <a:ea typeface="Microsoft YaHei"/>
                 <a:cs typeface="Microsoft YaHei"/>
               </a:rPr>
-              <a:t>【附页 · xpugen · 约 130 秒（2:10）】</a:t>
+              <a:t>【附页 · xpugen · 约 135 秒（2:15）】</a:t>
             </a:r>
           </a:p>
           <a:p>
@@ -533,7 +533,7 @@
                 <a:ea typeface="Microsoft YaHei"/>
                 <a:cs typeface="Microsoft YaHei"/>
               </a:rPr>
-              <a:t>这一页是另一个仓库 xpugen：给国产 GPU 写算子的 Agent。它生成的是 M100 的 SDNN4 内核，不是 CUDA；CUDA、Triton、torch 只当算法参考和基线。</a:t>
+              <a:t>这一页是另一个仓库 xpugen：给国产 GPU 写算子的 Agent。它生成的是 M100 的 SDNN4 内核，不是 CUDA；CUDA、Triton、torch 只作算法参考与基线。</a:t>
             </a:r>
           </a:p>
           <a:p>
@@ -551,7 +551,7 @@
                 <a:ea typeface="Microsoft YaHei"/>
                 <a:cs typeface="Microsoft YaHei"/>
               </a:rPr>
-              <a:t>先说清结构：左边写算子，右边判算子。会「猜」的只有左边这一个模型，右边从编译到测速每一步都是写死的规则，行不行轮不到模型自己说。</a:t>
+              <a:t>先说清结构：左边写算子，右边判算子。整条链路里只有左边这一个模型；右边从编译到测速都是固定规则，合不合格由规则判定，不由模型自己说。</a:t>
             </a:r>
           </a:p>
           <a:p>
@@ -569,7 +569,7 @@
                 <a:ea typeface="Microsoft YaHei"/>
                 <a:cs typeface="Microsoft YaHei"/>
               </a:rPr>
-              <a:t>左边动手之前还有一道门：先把需求问到没有歧义、至少比过两个方案，才允许写内核。起步有两条路，从一句需求开始，或者从现有实现反推出规格，第 0 轮直接拿它当基线。</a:t>
+              <a:t>左边在生成之前还有一道确认门：需求澄清到没有歧义、至少比选两个方案，才允许写内核。起步有两条路径：从一句需求开始，或者从现有实现反推出规格，第 0 轮直接以它为基线。</a:t>
             </a:r>
           </a:p>
           <a:p>
@@ -587,7 +587,7 @@
                 <a:ea typeface="Microsoft YaHei"/>
                 <a:cs typeface="Microsoft YaHei"/>
               </a:rPr>
-              <a:t>右边是一级级往上问：能不能跑起来、算得对不对、快了多少、为什么慢。快了多少只认真机；为什么慢才看模拟器，它能看到逐个单元的忙闲和跨引擎的并行，两边对不上以真机为准。</a:t>
+              <a:t>右边逐级验证：能否编译运行、数值是否正确、提速多少、瓶颈在哪。提速只认真机实测；瓶颈分析才用模拟器，它能看到逐个单元的忙闲和跨引擎并行，两者不一致时以真机为准。</a:t>
             </a:r>
           </a:p>
           <a:p>
@@ -605,7 +605,7 @@
                 <a:ea typeface="Microsoft YaHei"/>
                 <a:cs typeface="Microsoft YaHei"/>
               </a:rPr>
-              <a:t>判完的分数和卡在哪原样回传给左边，接着改下一轮：精度默认八轮收敛，性能调优是持续迭代，连着五十轮没进展才敢说卡住了。</a:t>
+              <a:t>评测结论和瓶颈定位原样回传给左边，进入下一轮：精度默认八轮收敛，性能调优则持续迭代，连续五十轮没有进展才下停滞结论。</a:t>
             </a:r>
           </a:p>
           <a:p>
@@ -623,7 +623,7 @@
                 <a:ea typeface="Microsoft YaHei"/>
                 <a:cs typeface="Microsoft YaHei"/>
               </a:rPr>
-              <a:t>底下一行是架构：写算子、判算子都不碰硬件，认硬件的只有 backend 这一层四件事，换一款芯片只补这一层，加一张硬件说明卡。</a:t>
+              <a:t>底下一行是架构：写算子和判算子都不碰硬件，与硬件耦合的只有 backend 这一层四件事；更换芯片只需补齐这一层，再加一张硬件说明卡。</a:t>
             </a:r>
           </a:p>
           <a:p>
@@ -641,7 +641,7 @@
                 <a:ea typeface="Microsoft YaHei"/>
                 <a:cs typeface="Microsoft YaHei"/>
               </a:rPr>
-              <a:t>右边是目前的实测，还在样例阶段：验证过四个算子，rmsnorm 相对基线一点二四倍，理论上限达成率从零点四七提到零点五八。规模化的达标统计还没有，所以这里不报聚合数字。</a:t>
+              <a:t>右边是目前的实测，仍处在样例阶段：验证过四个算子，rmsnorm 相对基线一点二四倍，理论上限达成率从零点四七提到零点五八。规模化的达标统计还没有，所以这里不报聚合指标。</a:t>
             </a:r>
           </a:p>
           <a:p>
@@ -677,7 +677,7 @@
                 <a:ea typeface="Microsoft YaHei"/>
                 <a:cs typeface="Microsoft YaHei"/>
               </a:rPr>
-              <a:t>轮数口径：max_turns 默认 8、--max-turns 可改，管的是过 L1 精度的收敛上限；性能调优不设 8 轮上限，铁律是连续 50 轮没有进展才允许下 stalled 结论。</a:t>
+              <a:t>轮数口径：max_turns 默认 8、--max-turns 可调，对应的是 L1 精度的收敛上限；性能调优不设 8 轮上限，铁律是连续 50 轮没有进展才允许下 stalled 结论。</a:t>
             </a:r>
           </a:p>
           <a:p>
@@ -3855,7 +3855,7 @@
                 <a:ea typeface="Microsoft YaHei"/>
                 <a:cs typeface="Microsoft YaHei"/>
               </a:rPr>
-              <a:t>写的是 M100 原生内核（SDNN4 .xpu），不是 CUDA；模型只管写，判它行不行的是一套固定流程</a:t>
+              <a:t>生成 M100 原生内核（SDNN4 .xpu），不是 CUDA；模型只负责生成，是否合格由固定流程判定</a:t>
             </a:r>
           </a:p>
         </p:txBody>
@@ -3902,7 +3902,7 @@
                 <a:ea typeface="Microsoft YaHei"/>
                 <a:cs typeface="Microsoft YaHei"/>
               </a:rPr>
-              <a:t>怎么起步　</a:t>
+              <a:t>起步　</a:t>
             </a:r>
             <a:r>
               <a:rPr sz="1050" b="0">
@@ -3913,7 +3913,7 @@
                 <a:ea typeface="Microsoft YaHei"/>
                 <a:cs typeface="Microsoft YaHei"/>
               </a:rPr>
-              <a:t>从一句需求开始，也可以拿现有实现当第 0 轮基线　·　先把精度收住（默认 8 轮），再持续抠性能</a:t>
+              <a:t>可从一句需求开始，也可以现有实现作为第 0 轮基线　·　精度优先（默认 8 轮收敛），再迭代压榨性能</a:t>
             </a:r>
           </a:p>
         </p:txBody>
@@ -4011,7 +4011,7 @@
                 <a:ea typeface="Microsoft YaHei"/>
                 <a:cs typeface="Microsoft YaHei"/>
               </a:rPr>
-              <a:t>　全流程只有这一个模型</a:t>
+              <a:t>　全流程唯一的模型</a:t>
             </a:r>
           </a:p>
         </p:txBody>
@@ -4024,7 +4024,7 @@
         </p:nvSpPr>
         <p:spPr>
           <a:xfrm>
-            <a:off x="768096" y="3218687"/>
+            <a:off x="768096" y="3090672"/>
             <a:ext cx="2990088" cy="274320"/>
           </a:xfrm>
           <a:prstGeom prst="rect">
@@ -4058,7 +4058,7 @@
                 <a:ea typeface="Microsoft YaHei"/>
                 <a:cs typeface="Microsoft YaHei"/>
               </a:rPr>
-              <a:t>先问清楚再动手</a:t>
+              <a:t>先确认，后生成</a:t>
             </a:r>
             <a:r>
               <a:rPr sz="1000" b="0">
@@ -4082,7 +4082,7 @@
         </p:nvSpPr>
         <p:spPr>
           <a:xfrm>
-            <a:off x="768096" y="3493007"/>
+            <a:off x="768096" y="3364991"/>
             <a:ext cx="2990088" cy="256032"/>
           </a:xfrm>
           <a:prstGeom prst="rect">
@@ -4116,7 +4116,7 @@
                 <a:ea typeface="Microsoft YaHei"/>
                 <a:cs typeface="Microsoft YaHei"/>
               </a:rPr>
-              <a:t>把需求问到没有歧义，至少比过两个方案</a:t>
+              <a:t>需求澄清到无歧义，至少比选两个方案</a:t>
             </a:r>
           </a:p>
         </p:txBody>
@@ -4129,7 +4129,7 @@
         </p:nvSpPr>
         <p:spPr>
           <a:xfrm>
-            <a:off x="768096" y="4041648"/>
+            <a:off x="768096" y="4005072"/>
             <a:ext cx="2990088" cy="274320"/>
           </a:xfrm>
           <a:prstGeom prst="rect">
@@ -4163,7 +4163,7 @@
                 <a:ea typeface="Microsoft YaHei"/>
                 <a:cs typeface="Microsoft YaHei"/>
               </a:rPr>
-              <a:t>照硬件说明卡写内核</a:t>
+              <a:t>依硬件说明卡生成内核</a:t>
             </a:r>
             <a:r>
               <a:rPr sz="1000" b="0">
@@ -4187,7 +4187,7 @@
         </p:nvSpPr>
         <p:spPr>
           <a:xfrm>
-            <a:off x="768096" y="4315968"/>
+            <a:off x="768096" y="4279392"/>
             <a:ext cx="2990088" cy="256032"/>
           </a:xfrm>
           <a:prstGeom prst="rect">
@@ -4221,7 +4221,7 @@
                 <a:ea typeface="Microsoft YaHei"/>
                 <a:cs typeface="Microsoft YaHei"/>
               </a:rPr>
-              <a:t>说明卡写着这颗芯片有哪些单元、怎么用</a:t>
+              <a:t>说明卡列明该芯片的计算单元与用法</a:t>
             </a:r>
           </a:p>
         </p:txBody>
@@ -4319,7 +4319,7 @@
                 <a:ea typeface="Microsoft YaHei"/>
                 <a:cs typeface="Microsoft YaHei"/>
               </a:rPr>
-              <a:t>　规则固定，模型说了不算</a:t>
+              <a:t>　客观评测，由规则决定</a:t>
             </a:r>
           </a:p>
         </p:txBody>
@@ -4377,7 +4377,7 @@
                 <a:ea typeface="Microsoft YaHei"/>
                 <a:cs typeface="Microsoft YaHei"/>
               </a:rPr>
-              <a:t>　能不能跑起来</a:t>
+              <a:t>　能否编译运行</a:t>
             </a:r>
             <a:r>
               <a:rPr sz="1050" b="0">
@@ -4388,7 +4388,7 @@
                 <a:ea typeface="Microsoft YaHei"/>
                 <a:cs typeface="Microsoft YaHei"/>
               </a:rPr>
-              <a:t>　编译 + 拉起</a:t>
+              <a:t>　编译并启动，失败即返工</a:t>
             </a:r>
           </a:p>
         </p:txBody>
@@ -4446,7 +4446,7 @@
                 <a:ea typeface="Microsoft YaHei"/>
                 <a:cs typeface="Microsoft YaHei"/>
               </a:rPr>
-              <a:t>　算得对不对</a:t>
+              <a:t>　数值是否正确</a:t>
             </a:r>
             <a:r>
               <a:rPr sz="1050" b="0">
@@ -4457,7 +4457,7 @@
                 <a:ea typeface="Microsoft YaHei"/>
                 <a:cs typeface="Microsoft YaHei"/>
               </a:rPr>
-              <a:t>　多形状多精度对 CPU</a:t>
+              <a:t>　多形状多精度对照 CPU</a:t>
             </a:r>
           </a:p>
         </p:txBody>
@@ -4515,7 +4515,7 @@
                 <a:ea typeface="Microsoft YaHei"/>
                 <a:cs typeface="Microsoft YaHei"/>
               </a:rPr>
-              <a:t>　快了多少</a:t>
+              <a:t>　提速多少</a:t>
             </a:r>
             <a:r>
               <a:rPr sz="1050" b="0">
@@ -4584,7 +4584,7 @@
                 <a:ea typeface="Microsoft YaHei"/>
                 <a:cs typeface="Microsoft YaHei"/>
               </a:rPr>
-              <a:t>　为什么慢</a:t>
+              <a:t>　瓶颈在哪</a:t>
             </a:r>
             <a:r>
               <a:rPr sz="1050" b="0">
@@ -4595,7 +4595,7 @@
                 <a:ea typeface="Microsoft YaHei"/>
                 <a:cs typeface="Microsoft YaHei"/>
               </a:rPr>
-              <a:t>　模拟器看卡在哪一步</a:t>
+              <a:t>　模拟器定位到具体环节</a:t>
             </a:r>
           </a:p>
         </p:txBody>
@@ -4663,7 +4663,7 @@
                 <a:ea typeface="Microsoft YaHei"/>
                 <a:cs typeface="Microsoft YaHei"/>
               </a:rPr>
-              <a:t>原因看模拟器，收益只认真机</a:t>
+              <a:t>机制分析用模拟器，收益以真机为准</a:t>
             </a:r>
           </a:p>
         </p:txBody>
@@ -4760,7 +4760,7 @@
                 <a:ea typeface="Microsoft YaHei"/>
                 <a:cs typeface="Microsoft YaHei"/>
               </a:rPr>
-              <a:t>把写好的内核交过去</a:t>
+              <a:t>交付生成的内核</a:t>
             </a:r>
           </a:p>
         </p:txBody>
@@ -4857,7 +4857,7 @@
                 <a:ea typeface="Microsoft YaHei"/>
                 <a:cs typeface="Microsoft YaHei"/>
               </a:rPr>
-              <a:t>把分数和「卡在哪」原样带回去，接着改下一轮</a:t>
+              <a:t>评测结论与瓶颈定位原样回传，进入下一轮</a:t>
             </a:r>
           </a:p>
         </p:txBody>
@@ -4935,7 +4935,7 @@
                 <a:ea typeface="Microsoft YaHei"/>
                 <a:cs typeface="Microsoft YaHei"/>
               </a:rPr>
-              <a:t>认硬件的只有这一层：编译 · 运行 · 采性能 · 算理论上限</a:t>
+              <a:t>与硬件耦合的只有这一层：编译 · 运行 · 性能采集 · 理论上限</a:t>
             </a:r>
             <a:r>
               <a:rPr sz="1000" b="0">
@@ -4970,7 +4970,7 @@
                 <a:ea typeface="Microsoft YaHei"/>
                 <a:cs typeface="Microsoft YaHei"/>
               </a:rPr>
-              <a:t>换一款芯片只补这一层，上面写算子、判算子的流程一行不改</a:t>
+              <a:t>更换芯片只需补齐这一层，生成与评测流程无需改动</a:t>
             </a:r>
           </a:p>
         </p:txBody>
@@ -5435,7 +5435,7 @@
                 <a:ea typeface="Microsoft YaHei"/>
                 <a:cs typeface="Microsoft YaHei"/>
               </a:rPr>
-              <a:t>越接近 1，硬件越被榨干</a:t>
+              <a:t>越接近 1，硬件利用越充分</a:t>
             </a:r>
           </a:p>
         </p:txBody>
@@ -5482,7 +5482,7 @@
                 <a:ea typeface="Microsoft YaHei"/>
                 <a:cs typeface="Microsoft YaHei"/>
               </a:rPr>
-              <a:t>目前是单算子的实测样例，还没有成规模的达标统计；数字都来自真机、生产形状</a:t>
+              <a:t>当前为单算子实测样例，尚无规模化达标统计；数据均取自真机、生产形状</a:t>
             </a:r>
           </a:p>
         </p:txBody>

</xml_diff>